<commit_message>
Auto-build: 2026-05-08 00:00 UTC
</commit_message>
<xml_diff>
--- a/reports/2026-04.pptx
+++ b/reports/2026-04.pptx
@@ -238,16 +238,16 @@
                 <c:ptCount val="5"/>
                 <c:lvl>
                   <c:pt idx="0">
+                    <c:v>Tanzania</c:v>
+                  </c:pt>
+                  <c:pt idx="1">
                     <c:v>Kenya</c:v>
                   </c:pt>
-                  <c:pt idx="1">
+                  <c:pt idx="2">
                     <c:v>Sierra Leone</c:v>
                   </c:pt>
-                  <c:pt idx="2">
+                  <c:pt idx="3">
                     <c:v>Nigeria</c:v>
-                  </c:pt>
-                  <c:pt idx="3">
-                    <c:v>Tanzania</c:v>
                   </c:pt>
                   <c:pt idx="4">
                     <c:v>Uganda</c:v>
@@ -263,16 +263,16 @@
                 <c:formatCode>General</c:formatCode>
                 <c:ptCount val="5"/>
                 <c:pt idx="0">
+                  <c:v>84</c:v>
+                </c:pt>
+                <c:pt idx="1">
                   <c:v>69</c:v>
                 </c:pt>
-                <c:pt idx="1">
+                <c:pt idx="2">
                   <c:v>47</c:v>
                 </c:pt>
-                <c:pt idx="2">
+                <c:pt idx="3">
                   <c:v>29</c:v>
-                </c:pt>
-                <c:pt idx="3">
-                  <c:v>0</c:v>
                 </c:pt>
                 <c:pt idx="4">
                   <c:v>0</c:v>
@@ -575,7 +575,7 @@
                   <c:v>42</c:v>
                 </c:pt>
                 <c:pt idx="4">
-                  <c:v>112</c:v>
+                  <c:v>63</c:v>
                 </c:pt>
               </c:numCache>
             </c:numRef>
@@ -841,13 +841,13 @@
                     <c:v>Nigeria</c:v>
                   </c:pt>
                   <c:pt idx="1">
+                    <c:v>Tanzania</c:v>
+                  </c:pt>
+                  <c:pt idx="2">
                     <c:v>Sierra Leone</c:v>
                   </c:pt>
-                  <c:pt idx="2">
+                  <c:pt idx="3">
                     <c:v>Kenya</c:v>
-                  </c:pt>
-                  <c:pt idx="3">
-                    <c:v>Tanzania</c:v>
                   </c:pt>
                   <c:pt idx="4">
                     <c:v>Uganda</c:v>
@@ -866,13 +866,13 @@
                   <c:v>0.993289</c:v>
                 </c:pt>
                 <c:pt idx="1">
+                  <c:v>0.949701</c:v>
+                </c:pt>
+                <c:pt idx="2">
                   <c:v>0.871729</c:v>
                 </c:pt>
-                <c:pt idx="2">
+                <c:pt idx="3">
                   <c:v>0.831573</c:v>
-                </c:pt>
-                <c:pt idx="3">
-                  <c:v>0</c:v>
                 </c:pt>
                 <c:pt idx="4">
                   <c:v>0</c:v>
@@ -2038,16 +2038,16 @@
                 <c:ptCount val="5"/>
                 <c:lvl>
                   <c:pt idx="0">
+                    <c:v>Tanzania</c:v>
+                  </c:pt>
+                  <c:pt idx="1">
                     <c:v>Kenya</c:v>
                   </c:pt>
-                  <c:pt idx="1">
+                  <c:pt idx="2">
                     <c:v>Sierra Leone</c:v>
                   </c:pt>
-                  <c:pt idx="2">
+                  <c:pt idx="3">
                     <c:v>Nigeria</c:v>
-                  </c:pt>
-                  <c:pt idx="3">
-                    <c:v>Tanzania</c:v>
                   </c:pt>
                   <c:pt idx="4">
                     <c:v>Uganda</c:v>
@@ -2063,7 +2063,7 @@
                 <c:formatCode>General</c:formatCode>
                 <c:ptCount val="5"/>
                 <c:pt idx="0">
-                  <c:v>3</c:v>
+                  <c:v>2</c:v>
                 </c:pt>
                 <c:pt idx="1">
                   <c:v>3</c:v>
@@ -2072,7 +2072,7 @@
                   <c:v>3</c:v>
                 </c:pt>
                 <c:pt idx="3">
-                  <c:v>12</c:v>
+                  <c:v>3</c:v>
                 </c:pt>
                 <c:pt idx="4">
                   <c:v>0</c:v>
@@ -2647,10 +2647,10 @@
                     <c:v>Sierra Leone</c:v>
                   </c:pt>
                   <c:pt idx="3">
-                    <c:v>Kenya</c:v>
+                    <c:v>Tanzania</c:v>
                   </c:pt>
                   <c:pt idx="4">
-                    <c:v>Tanzania</c:v>
+                    <c:v>Kenya</c:v>
                   </c:pt>
                 </c:lvl>
               </c:multiLvlStrCache>
@@ -2672,10 +2672,10 @@
                   <c:v>850</c:v>
                 </c:pt>
                 <c:pt idx="3">
-                  <c:v>1456</c:v>
+                  <c:v>1209</c:v>
                 </c:pt>
                 <c:pt idx="4">
-                  <c:v>2127</c:v>
+                  <c:v>1456</c:v>
                 </c:pt>
               </c:numCache>
             </c:numRef>
@@ -2975,7 +2975,7 @@
                   <c:v>209</c:v>
                 </c:pt>
                 <c:pt idx="4">
-                  <c:v>494</c:v>
+                  <c:v>281</c:v>
                 </c:pt>
               </c:numCache>
             </c:numRef>
@@ -5236,7 +5236,7 @@
                 <a:ea typeface="Calibri" pitchFamily="34" charset="-122"/>
                 <a:cs typeface="Calibri" pitchFamily="34" charset="-120"/>
               </a:rPr>
-              <a:t>Prepared: May 7, 2026</a:t>
+              <a:t>Prepared: May 8, 2026</a:t>
             </a:r>
             <a:endParaRPr lang="en-US" sz="1200" dirty="0"/>
           </a:p>
@@ -6386,7 +6386,7 @@
                           <a:ea typeface="Calibri" pitchFamily="34" charset="-122"/>
                           <a:cs typeface="Calibri" pitchFamily="34" charset="-120"/>
                         </a:rPr>
-                        <a:t>$239,160</a:t>
+                        <a:t>$1,402,657</a:t>
                       </a:r>
                       <a:endParaRPr lang="en-US" sz="1200" dirty="0">
                         <a:latin typeface="Calibri" charset="0"/>
@@ -6454,7 +6454,7 @@
                           <a:ea typeface="Calibri" pitchFamily="34" charset="-122"/>
                           <a:cs typeface="Calibri" pitchFamily="34" charset="-120"/>
                         </a:rPr>
-                        <a:t>24.3%</a:t>
+                        <a:t>142.6%</a:t>
                       </a:r>
                       <a:endParaRPr lang="en-US" sz="1200" dirty="0">
                         <a:latin typeface="Calibri" charset="0"/>
@@ -6522,7 +6522,7 @@
                           <a:ea typeface="Calibri" pitchFamily="34" charset="-122"/>
                           <a:cs typeface="Calibri" pitchFamily="34" charset="-120"/>
                         </a:rPr>
-                        <a:t>$236,358</a:t>
+                        <a:t>$1,528,589</a:t>
                       </a:r>
                       <a:endParaRPr lang="en-US" sz="1200" dirty="0">
                         <a:latin typeface="Calibri" charset="0"/>
@@ -6864,7 +6864,7 @@
                           <a:ea typeface="Calibri" pitchFamily="34" charset="-122"/>
                           <a:cs typeface="Calibri" pitchFamily="34" charset="-120"/>
                         </a:rPr>
-                        <a:t>$96,097</a:t>
+                        <a:t>$1,064,339</a:t>
                       </a:r>
                       <a:endParaRPr lang="en-US" sz="1200" dirty="0">
                         <a:latin typeface="Calibri" charset="0"/>
@@ -6932,7 +6932,7 @@
                           <a:ea typeface="Calibri" pitchFamily="34" charset="-122"/>
                           <a:cs typeface="Calibri" pitchFamily="34" charset="-120"/>
                         </a:rPr>
-                        <a:t>14.4%</a:t>
+                        <a:t>159.3%</a:t>
                       </a:r>
                       <a:endParaRPr lang="en-US" sz="1200" dirty="0">
                         <a:latin typeface="Calibri" charset="0"/>
@@ -7000,7 +7000,7 @@
                           <a:ea typeface="Calibri" pitchFamily="34" charset="-122"/>
                           <a:cs typeface="Calibri" pitchFamily="34" charset="-120"/>
                         </a:rPr>
-                        <a:t>$137,171</a:t>
+                        <a:t>$1,005,976</a:t>
                       </a:r>
                       <a:endParaRPr lang="en-US" sz="1200" dirty="0">
                         <a:latin typeface="Calibri" charset="0"/>
@@ -7342,7 +7342,7 @@
                           <a:ea typeface="Calibri" pitchFamily="34" charset="-122"/>
                           <a:cs typeface="Calibri" pitchFamily="34" charset="-120"/>
                         </a:rPr>
-                        <a:t>$54,744</a:t>
+                        <a:t>$422,243</a:t>
                       </a:r>
                       <a:endParaRPr lang="en-US" sz="1200" dirty="0">
                         <a:latin typeface="Calibri" charset="0"/>
@@ -7410,7 +7410,7 @@
                           <a:ea typeface="Calibri" pitchFamily="34" charset="-122"/>
                           <a:cs typeface="Calibri" pitchFamily="34" charset="-120"/>
                         </a:rPr>
-                        <a:t>23.8%</a:t>
+                        <a:t>183.8%</a:t>
                       </a:r>
                       <a:endParaRPr lang="en-US" sz="1200" dirty="0">
                         <a:latin typeface="Calibri" charset="0"/>
@@ -7478,7 +7478,7 @@
                           <a:ea typeface="Calibri" pitchFamily="34" charset="-122"/>
                           <a:cs typeface="Calibri" pitchFamily="34" charset="-120"/>
                         </a:rPr>
-                        <a:t>$32,644</a:t>
+                        <a:t>$456,299</a:t>
                       </a:r>
                       <a:endParaRPr lang="en-US" sz="1200" dirty="0">
                         <a:latin typeface="Calibri" charset="0"/>
@@ -7526,6 +7526,484 @@
                     </a:lnB>
                     <a:solidFill>
                       <a:srgbClr val="FFFFFF"/>
+                    </a:solidFill>
+                  </a:tcPr>
+                </a:tc>
+              </a:tr>
+              <a:tr h="457200">
+                <a:tc>
+                  <a:txBody>
+                    <a:bodyPr/>
+                    <a:lstStyle/>
+                    <a:p>
+                      <a:pPr algn="l" indent="0" marL="0">
+                        <a:buNone/>
+                      </a:pPr>
+                      <a:r>
+                        <a:rPr lang="en-US" sz="1200" b="1" dirty="0">
+                          <a:solidFill>
+                            <a:srgbClr val="2D2A26"/>
+                          </a:solidFill>
+                          <a:latin typeface="Century Gothic" pitchFamily="34" charset="0"/>
+                          <a:ea typeface="Century Gothic" pitchFamily="34" charset="-122"/>
+                          <a:cs typeface="Century Gothic" pitchFamily="34" charset="-120"/>
+                        </a:rPr>
+                        <a:t>Nigeria</a:t>
+                      </a:r>
+                      <a:endParaRPr lang="en-US" sz="1200" dirty="0">
+                        <a:latin typeface="Century Gothic" charset="0"/>
+                        <a:ea typeface="Century Gothic" charset="0"/>
+                        <a:cs typeface="Century Gothic" charset="0"/>
+                      </a:endParaRPr>
+                    </a:p>
+                  </a:txBody>
+                  <a:tcPr marL="91440" marR="91440" marT="45720" marB="45720" anchor="ctr">
+                    <a:lnL w="6350" cap="flat" cmpd="sng" algn="ctr">
+                      <a:solidFill>
+                        <a:srgbClr val="D6CFC4"/>
+                      </a:solidFill>
+                      <a:prstDash val="solid"/>
+                      <a:round/>
+                      <a:headEnd type="none" w="med" len="med"/>
+                      <a:tailEnd type="none" w="med" len="med"/>
+                    </a:lnL>
+                    <a:lnR w="6350" cap="flat" cmpd="sng" algn="ctr">
+                      <a:solidFill>
+                        <a:srgbClr val="D6CFC4"/>
+                      </a:solidFill>
+                      <a:prstDash val="solid"/>
+                      <a:round/>
+                      <a:headEnd type="none" w="med" len="med"/>
+                      <a:tailEnd type="none" w="med" len="med"/>
+                    </a:lnR>
+                    <a:lnT w="6350" cap="flat" cmpd="sng" algn="ctr">
+                      <a:solidFill>
+                        <a:srgbClr val="D6CFC4"/>
+                      </a:solidFill>
+                      <a:prstDash val="solid"/>
+                      <a:round/>
+                      <a:headEnd type="none" w="med" len="med"/>
+                      <a:tailEnd type="none" w="med" len="med"/>
+                    </a:lnT>
+                    <a:lnB w="6350" cap="flat" cmpd="sng" algn="ctr">
+                      <a:solidFill>
+                        <a:srgbClr val="D6CFC4"/>
+                      </a:solidFill>
+                      <a:prstDash val="solid"/>
+                      <a:round/>
+                      <a:headEnd type="none" w="med" len="med"/>
+                      <a:tailEnd type="none" w="med" len="med"/>
+                    </a:lnB>
+                    <a:solidFill>
+                      <a:srgbClr val="FAF7F2"/>
+                    </a:solidFill>
+                  </a:tcPr>
+                </a:tc>
+                <a:tc>
+                  <a:txBody>
+                    <a:bodyPr/>
+                    <a:lstStyle/>
+                    <a:p>
+                      <a:pPr algn="ctr" indent="0" marL="0">
+                        <a:buNone/>
+                      </a:pPr>
+                      <a:r>
+                        <a:rPr lang="en-US" sz="1200" dirty="0">
+                          <a:solidFill>
+                            <a:srgbClr val="2D2A26"/>
+                          </a:solidFill>
+                          <a:latin typeface="Calibri" pitchFamily="34" charset="0"/>
+                          <a:ea typeface="Calibri" pitchFamily="34" charset="-122"/>
+                          <a:cs typeface="Calibri" pitchFamily="34" charset="-120"/>
+                        </a:rPr>
+                        <a:t>$55,571</a:t>
+                      </a:r>
+                      <a:endParaRPr lang="en-US" sz="1200" dirty="0">
+                        <a:latin typeface="Calibri" charset="0"/>
+                        <a:ea typeface="Calibri" charset="0"/>
+                        <a:cs typeface="Calibri" charset="0"/>
+                      </a:endParaRPr>
+                    </a:p>
+                  </a:txBody>
+                  <a:tcPr marL="91440" marR="91440" marT="45720" marB="45720" anchor="ctr">
+                    <a:lnL w="6350" cap="flat" cmpd="sng" algn="ctr">
+                      <a:solidFill>
+                        <a:srgbClr val="D6CFC4"/>
+                      </a:solidFill>
+                      <a:prstDash val="solid"/>
+                      <a:round/>
+                      <a:headEnd type="none" w="med" len="med"/>
+                      <a:tailEnd type="none" w="med" len="med"/>
+                    </a:lnL>
+                    <a:lnR w="6350" cap="flat" cmpd="sng" algn="ctr">
+                      <a:solidFill>
+                        <a:srgbClr val="D6CFC4"/>
+                      </a:solidFill>
+                      <a:prstDash val="solid"/>
+                      <a:round/>
+                      <a:headEnd type="none" w="med" len="med"/>
+                      <a:tailEnd type="none" w="med" len="med"/>
+                    </a:lnR>
+                    <a:lnT w="6350" cap="flat" cmpd="sng" algn="ctr">
+                      <a:solidFill>
+                        <a:srgbClr val="D6CFC4"/>
+                      </a:solidFill>
+                      <a:prstDash val="solid"/>
+                      <a:round/>
+                      <a:headEnd type="none" w="med" len="med"/>
+                      <a:tailEnd type="none" w="med" len="med"/>
+                    </a:lnT>
+                    <a:lnB w="6350" cap="flat" cmpd="sng" algn="ctr">
+                      <a:solidFill>
+                        <a:srgbClr val="D6CFC4"/>
+                      </a:solidFill>
+                      <a:prstDash val="solid"/>
+                      <a:round/>
+                      <a:headEnd type="none" w="med" len="med"/>
+                      <a:tailEnd type="none" w="med" len="med"/>
+                    </a:lnB>
+                    <a:solidFill>
+                      <a:srgbClr val="FAF7F2"/>
+                    </a:solidFill>
+                  </a:tcPr>
+                </a:tc>
+                <a:tc>
+                  <a:txBody>
+                    <a:bodyPr/>
+                    <a:lstStyle/>
+                    <a:p>
+                      <a:pPr algn="ctr" indent="0" marL="0">
+                        <a:buNone/>
+                      </a:pPr>
+                      <a:r>
+                        <a:rPr lang="en-US" sz="1200" dirty="0">
+                          <a:solidFill>
+                            <a:srgbClr val="2D2A26"/>
+                          </a:solidFill>
+                          <a:latin typeface="Calibri" pitchFamily="34" charset="0"/>
+                          <a:ea typeface="Calibri" pitchFamily="34" charset="-122"/>
+                          <a:cs typeface="Calibri" pitchFamily="34" charset="-120"/>
+                        </a:rPr>
+                        <a:t>$-29,100</a:t>
+                      </a:r>
+                      <a:endParaRPr lang="en-US" sz="1200" dirty="0">
+                        <a:latin typeface="Calibri" charset="0"/>
+                        <a:ea typeface="Calibri" charset="0"/>
+                        <a:cs typeface="Calibri" charset="0"/>
+                      </a:endParaRPr>
+                    </a:p>
+                  </a:txBody>
+                  <a:tcPr marL="91440" marR="91440" marT="45720" marB="45720" anchor="ctr">
+                    <a:lnL w="6350" cap="flat" cmpd="sng" algn="ctr">
+                      <a:solidFill>
+                        <a:srgbClr val="D6CFC4"/>
+                      </a:solidFill>
+                      <a:prstDash val="solid"/>
+                      <a:round/>
+                      <a:headEnd type="none" w="med" len="med"/>
+                      <a:tailEnd type="none" w="med" len="med"/>
+                    </a:lnL>
+                    <a:lnR w="6350" cap="flat" cmpd="sng" algn="ctr">
+                      <a:solidFill>
+                        <a:srgbClr val="D6CFC4"/>
+                      </a:solidFill>
+                      <a:prstDash val="solid"/>
+                      <a:round/>
+                      <a:headEnd type="none" w="med" len="med"/>
+                      <a:tailEnd type="none" w="med" len="med"/>
+                    </a:lnR>
+                    <a:lnT w="6350" cap="flat" cmpd="sng" algn="ctr">
+                      <a:solidFill>
+                        <a:srgbClr val="D6CFC4"/>
+                      </a:solidFill>
+                      <a:prstDash val="solid"/>
+                      <a:round/>
+                      <a:headEnd type="none" w="med" len="med"/>
+                      <a:tailEnd type="none" w="med" len="med"/>
+                    </a:lnT>
+                    <a:lnB w="6350" cap="flat" cmpd="sng" algn="ctr">
+                      <a:solidFill>
+                        <a:srgbClr val="D6CFC4"/>
+                      </a:solidFill>
+                      <a:prstDash val="solid"/>
+                      <a:round/>
+                      <a:headEnd type="none" w="med" len="med"/>
+                      <a:tailEnd type="none" w="med" len="med"/>
+                    </a:lnB>
+                    <a:solidFill>
+                      <a:srgbClr val="FAF7F2"/>
+                    </a:solidFill>
+                  </a:tcPr>
+                </a:tc>
+                <a:tc>
+                  <a:txBody>
+                    <a:bodyPr/>
+                    <a:lstStyle/>
+                    <a:p>
+                      <a:pPr algn="ctr" indent="0" marL="0">
+                        <a:buNone/>
+                      </a:pPr>
+                      <a:r>
+                        <a:rPr lang="en-US" sz="1200" dirty="0">
+                          <a:solidFill>
+                            <a:srgbClr val="2D2A26"/>
+                          </a:solidFill>
+                          <a:latin typeface="Calibri" pitchFamily="34" charset="0"/>
+                          <a:ea typeface="Calibri" pitchFamily="34" charset="-122"/>
+                          <a:cs typeface="Calibri" pitchFamily="34" charset="-120"/>
+                        </a:rPr>
+                        <a:t>$-82,622</a:t>
+                      </a:r>
+                      <a:endParaRPr lang="en-US" sz="1200" dirty="0">
+                        <a:latin typeface="Calibri" charset="0"/>
+                        <a:ea typeface="Calibri" charset="0"/>
+                        <a:cs typeface="Calibri" charset="0"/>
+                      </a:endParaRPr>
+                    </a:p>
+                  </a:txBody>
+                  <a:tcPr marL="91440" marR="91440" marT="45720" marB="45720" anchor="ctr">
+                    <a:lnL w="6350" cap="flat" cmpd="sng" algn="ctr">
+                      <a:solidFill>
+                        <a:srgbClr val="D6CFC4"/>
+                      </a:solidFill>
+                      <a:prstDash val="solid"/>
+                      <a:round/>
+                      <a:headEnd type="none" w="med" len="med"/>
+                      <a:tailEnd type="none" w="med" len="med"/>
+                    </a:lnL>
+                    <a:lnR w="6350" cap="flat" cmpd="sng" algn="ctr">
+                      <a:solidFill>
+                        <a:srgbClr val="D6CFC4"/>
+                      </a:solidFill>
+                      <a:prstDash val="solid"/>
+                      <a:round/>
+                      <a:headEnd type="none" w="med" len="med"/>
+                      <a:tailEnd type="none" w="med" len="med"/>
+                    </a:lnR>
+                    <a:lnT w="6350" cap="flat" cmpd="sng" algn="ctr">
+                      <a:solidFill>
+                        <a:srgbClr val="D6CFC4"/>
+                      </a:solidFill>
+                      <a:prstDash val="solid"/>
+                      <a:round/>
+                      <a:headEnd type="none" w="med" len="med"/>
+                      <a:tailEnd type="none" w="med" len="med"/>
+                    </a:lnT>
+                    <a:lnB w="6350" cap="flat" cmpd="sng" algn="ctr">
+                      <a:solidFill>
+                        <a:srgbClr val="D6CFC4"/>
+                      </a:solidFill>
+                      <a:prstDash val="solid"/>
+                      <a:round/>
+                      <a:headEnd type="none" w="med" len="med"/>
+                      <a:tailEnd type="none" w="med" len="med"/>
+                    </a:lnB>
+                    <a:solidFill>
+                      <a:srgbClr val="FAF7F2"/>
+                    </a:solidFill>
+                  </a:tcPr>
+                </a:tc>
+                <a:tc>
+                  <a:txBody>
+                    <a:bodyPr/>
+                    <a:lstStyle/>
+                    <a:p>
+                      <a:pPr algn="ctr" indent="0" marL="0">
+                        <a:buNone/>
+                      </a:pPr>
+                      <a:r>
+                        <a:rPr lang="en-US" sz="1200" dirty="0">
+                          <a:solidFill>
+                            <a:srgbClr val="2D2A26"/>
+                          </a:solidFill>
+                          <a:latin typeface="Calibri" pitchFamily="34" charset="0"/>
+                          <a:ea typeface="Calibri" pitchFamily="34" charset="-122"/>
+                          <a:cs typeface="Calibri" pitchFamily="34" charset="-120"/>
+                        </a:rPr>
+                        <a:t>$109,094</a:t>
+                      </a:r>
+                      <a:endParaRPr lang="en-US" sz="1200" dirty="0">
+                        <a:latin typeface="Calibri" charset="0"/>
+                        <a:ea typeface="Calibri" charset="0"/>
+                        <a:cs typeface="Calibri" charset="0"/>
+                      </a:endParaRPr>
+                    </a:p>
+                  </a:txBody>
+                  <a:tcPr marL="91440" marR="91440" marT="45720" marB="45720" anchor="ctr">
+                    <a:lnL w="6350" cap="flat" cmpd="sng" algn="ctr">
+                      <a:solidFill>
+                        <a:srgbClr val="D6CFC4"/>
+                      </a:solidFill>
+                      <a:prstDash val="solid"/>
+                      <a:round/>
+                      <a:headEnd type="none" w="med" len="med"/>
+                      <a:tailEnd type="none" w="med" len="med"/>
+                    </a:lnL>
+                    <a:lnR w="6350" cap="flat" cmpd="sng" algn="ctr">
+                      <a:solidFill>
+                        <a:srgbClr val="D6CFC4"/>
+                      </a:solidFill>
+                      <a:prstDash val="solid"/>
+                      <a:round/>
+                      <a:headEnd type="none" w="med" len="med"/>
+                      <a:tailEnd type="none" w="med" len="med"/>
+                    </a:lnR>
+                    <a:lnT w="6350" cap="flat" cmpd="sng" algn="ctr">
+                      <a:solidFill>
+                        <a:srgbClr val="D6CFC4"/>
+                      </a:solidFill>
+                      <a:prstDash val="solid"/>
+                      <a:round/>
+                      <a:headEnd type="none" w="med" len="med"/>
+                      <a:tailEnd type="none" w="med" len="med"/>
+                    </a:lnT>
+                    <a:lnB w="6350" cap="flat" cmpd="sng" algn="ctr">
+                      <a:solidFill>
+                        <a:srgbClr val="D6CFC4"/>
+                      </a:solidFill>
+                      <a:prstDash val="solid"/>
+                      <a:round/>
+                      <a:headEnd type="none" w="med" len="med"/>
+                      <a:tailEnd type="none" w="med" len="med"/>
+                    </a:lnB>
+                    <a:solidFill>
+                      <a:srgbClr val="FAF7F2"/>
+                    </a:solidFill>
+                  </a:tcPr>
+                </a:tc>
+                <a:tc>
+                  <a:txBody>
+                    <a:bodyPr/>
+                    <a:lstStyle/>
+                    <a:p>
+                      <a:pPr algn="ctr" indent="0" marL="0">
+                        <a:buNone/>
+                      </a:pPr>
+                      <a:r>
+                        <a:rPr lang="en-US" sz="1200" dirty="0">
+                          <a:solidFill>
+                            <a:srgbClr val="2D2A26"/>
+                          </a:solidFill>
+                          <a:latin typeface="Calibri" pitchFamily="34" charset="0"/>
+                          <a:ea typeface="Calibri" pitchFamily="34" charset="-122"/>
+                          <a:cs typeface="Calibri" pitchFamily="34" charset="-120"/>
+                        </a:rPr>
+                        <a:t>196.3%</a:t>
+                      </a:r>
+                      <a:endParaRPr lang="en-US" sz="1200" dirty="0">
+                        <a:latin typeface="Calibri" charset="0"/>
+                        <a:ea typeface="Calibri" charset="0"/>
+                        <a:cs typeface="Calibri" charset="0"/>
+                      </a:endParaRPr>
+                    </a:p>
+                  </a:txBody>
+                  <a:tcPr marL="91440" marR="91440" marT="45720" marB="45720" anchor="ctr">
+                    <a:lnL w="6350" cap="flat" cmpd="sng" algn="ctr">
+                      <a:solidFill>
+                        <a:srgbClr val="D6CFC4"/>
+                      </a:solidFill>
+                      <a:prstDash val="solid"/>
+                      <a:round/>
+                      <a:headEnd type="none" w="med" len="med"/>
+                      <a:tailEnd type="none" w="med" len="med"/>
+                    </a:lnL>
+                    <a:lnR w="6350" cap="flat" cmpd="sng" algn="ctr">
+                      <a:solidFill>
+                        <a:srgbClr val="D6CFC4"/>
+                      </a:solidFill>
+                      <a:prstDash val="solid"/>
+                      <a:round/>
+                      <a:headEnd type="none" w="med" len="med"/>
+                      <a:tailEnd type="none" w="med" len="med"/>
+                    </a:lnR>
+                    <a:lnT w="6350" cap="flat" cmpd="sng" algn="ctr">
+                      <a:solidFill>
+                        <a:srgbClr val="D6CFC4"/>
+                      </a:solidFill>
+                      <a:prstDash val="solid"/>
+                      <a:round/>
+                      <a:headEnd type="none" w="med" len="med"/>
+                      <a:tailEnd type="none" w="med" len="med"/>
+                    </a:lnT>
+                    <a:lnB w="6350" cap="flat" cmpd="sng" algn="ctr">
+                      <a:solidFill>
+                        <a:srgbClr val="D6CFC4"/>
+                      </a:solidFill>
+                      <a:prstDash val="solid"/>
+                      <a:round/>
+                      <a:headEnd type="none" w="med" len="med"/>
+                      <a:tailEnd type="none" w="med" len="med"/>
+                    </a:lnB>
+                    <a:solidFill>
+                      <a:srgbClr val="FAF7F2"/>
+                    </a:solidFill>
+                  </a:tcPr>
+                </a:tc>
+                <a:tc>
+                  <a:txBody>
+                    <a:bodyPr/>
+                    <a:lstStyle/>
+                    <a:p>
+                      <a:pPr algn="ctr" indent="0" marL="0">
+                        <a:buNone/>
+                      </a:pPr>
+                      <a:r>
+                        <a:rPr lang="en-US" sz="1200" dirty="0">
+                          <a:solidFill>
+                            <a:srgbClr val="2D2A26"/>
+                          </a:solidFill>
+                          <a:latin typeface="Calibri" pitchFamily="34" charset="0"/>
+                          <a:ea typeface="Calibri" pitchFamily="34" charset="-122"/>
+                          <a:cs typeface="Calibri" pitchFamily="34" charset="-120"/>
+                        </a:rPr>
+                        <a:t>$105,341</a:t>
+                      </a:r>
+                      <a:endParaRPr lang="en-US" sz="1200" dirty="0">
+                        <a:latin typeface="Calibri" charset="0"/>
+                        <a:ea typeface="Calibri" charset="0"/>
+                        <a:cs typeface="Calibri" charset="0"/>
+                      </a:endParaRPr>
+                    </a:p>
+                  </a:txBody>
+                  <a:tcPr marL="91440" marR="91440" marT="45720" marB="45720" anchor="ctr">
+                    <a:lnL w="6350" cap="flat" cmpd="sng" algn="ctr">
+                      <a:solidFill>
+                        <a:srgbClr val="D6CFC4"/>
+                      </a:solidFill>
+                      <a:prstDash val="solid"/>
+                      <a:round/>
+                      <a:headEnd type="none" w="med" len="med"/>
+                      <a:tailEnd type="none" w="med" len="med"/>
+                    </a:lnL>
+                    <a:lnR w="6350" cap="flat" cmpd="sng" algn="ctr">
+                      <a:solidFill>
+                        <a:srgbClr val="D6CFC4"/>
+                      </a:solidFill>
+                      <a:prstDash val="solid"/>
+                      <a:round/>
+                      <a:headEnd type="none" w="med" len="med"/>
+                      <a:tailEnd type="none" w="med" len="med"/>
+                    </a:lnR>
+                    <a:lnT w="6350" cap="flat" cmpd="sng" algn="ctr">
+                      <a:solidFill>
+                        <a:srgbClr val="D6CFC4"/>
+                      </a:solidFill>
+                      <a:prstDash val="solid"/>
+                      <a:round/>
+                      <a:headEnd type="none" w="med" len="med"/>
+                      <a:tailEnd type="none" w="med" len="med"/>
+                    </a:lnT>
+                    <a:lnB w="6350" cap="flat" cmpd="sng" algn="ctr">
+                      <a:solidFill>
+                        <a:srgbClr val="D6CFC4"/>
+                      </a:solidFill>
+                      <a:prstDash val="solid"/>
+                      <a:round/>
+                      <a:headEnd type="none" w="med" len="med"/>
+                      <a:tailEnd type="none" w="med" len="med"/>
+                    </a:lnB>
+                    <a:solidFill>
+                      <a:srgbClr val="FAF7F2"/>
                     </a:solidFill>
                   </a:tcPr>
                 </a:tc>
@@ -7595,7 +8073,7 @@
                       <a:tailEnd type="none" w="med" len="med"/>
                     </a:lnB>
                     <a:solidFill>
-                      <a:srgbClr val="FAF7F2"/>
+                      <a:srgbClr val="FFFFFF"/>
                     </a:solidFill>
                   </a:tcPr>
                 </a:tc>
@@ -7663,7 +8141,7 @@
                       <a:tailEnd type="none" w="med" len="med"/>
                     </a:lnB>
                     <a:solidFill>
-                      <a:srgbClr val="FAF7F2"/>
+                      <a:srgbClr val="FFFFFF"/>
                     </a:solidFill>
                   </a:tcPr>
                 </a:tc>
@@ -7731,7 +8209,7 @@
                       <a:tailEnd type="none" w="med" len="med"/>
                     </a:lnB>
                     <a:solidFill>
-                      <a:srgbClr val="FAF7F2"/>
+                      <a:srgbClr val="FFFFFF"/>
                     </a:solidFill>
                   </a:tcPr>
                 </a:tc>
@@ -7799,7 +8277,7 @@
                       <a:tailEnd type="none" w="med" len="med"/>
                     </a:lnB>
                     <a:solidFill>
-                      <a:srgbClr val="FAF7F2"/>
+                      <a:srgbClr val="FFFFFF"/>
                     </a:solidFill>
                   </a:tcPr>
                 </a:tc>
@@ -7867,7 +8345,7 @@
                       <a:tailEnd type="none" w="med" len="med"/>
                     </a:lnB>
                     <a:solidFill>
-                      <a:srgbClr val="FAF7F2"/>
+                      <a:srgbClr val="FFFFFF"/>
                     </a:solidFill>
                   </a:tcPr>
                 </a:tc>
@@ -7935,7 +8413,7 @@
                       <a:tailEnd type="none" w="med" len="med"/>
                     </a:lnB>
                     <a:solidFill>
-                      <a:srgbClr val="FAF7F2"/>
+                      <a:srgbClr val="FFFFFF"/>
                     </a:solidFill>
                   </a:tcPr>
                 </a:tc>
@@ -7957,484 +8435,6 @@
                           <a:cs typeface="Calibri" pitchFamily="34" charset="-120"/>
                         </a:rPr>
                         <a:t>—</a:t>
-                      </a:r>
-                      <a:endParaRPr lang="en-US" sz="1200" dirty="0">
-                        <a:latin typeface="Calibri" charset="0"/>
-                        <a:ea typeface="Calibri" charset="0"/>
-                        <a:cs typeface="Calibri" charset="0"/>
-                      </a:endParaRPr>
-                    </a:p>
-                  </a:txBody>
-                  <a:tcPr marL="91440" marR="91440" marT="45720" marB="45720" anchor="ctr">
-                    <a:lnL w="6350" cap="flat" cmpd="sng" algn="ctr">
-                      <a:solidFill>
-                        <a:srgbClr val="D6CFC4"/>
-                      </a:solidFill>
-                      <a:prstDash val="solid"/>
-                      <a:round/>
-                      <a:headEnd type="none" w="med" len="med"/>
-                      <a:tailEnd type="none" w="med" len="med"/>
-                    </a:lnL>
-                    <a:lnR w="6350" cap="flat" cmpd="sng" algn="ctr">
-                      <a:solidFill>
-                        <a:srgbClr val="D6CFC4"/>
-                      </a:solidFill>
-                      <a:prstDash val="solid"/>
-                      <a:round/>
-                      <a:headEnd type="none" w="med" len="med"/>
-                      <a:tailEnd type="none" w="med" len="med"/>
-                    </a:lnR>
-                    <a:lnT w="6350" cap="flat" cmpd="sng" algn="ctr">
-                      <a:solidFill>
-                        <a:srgbClr val="D6CFC4"/>
-                      </a:solidFill>
-                      <a:prstDash val="solid"/>
-                      <a:round/>
-                      <a:headEnd type="none" w="med" len="med"/>
-                      <a:tailEnd type="none" w="med" len="med"/>
-                    </a:lnT>
-                    <a:lnB w="6350" cap="flat" cmpd="sng" algn="ctr">
-                      <a:solidFill>
-                        <a:srgbClr val="D6CFC4"/>
-                      </a:solidFill>
-                      <a:prstDash val="solid"/>
-                      <a:round/>
-                      <a:headEnd type="none" w="med" len="med"/>
-                      <a:tailEnd type="none" w="med" len="med"/>
-                    </a:lnB>
-                    <a:solidFill>
-                      <a:srgbClr val="FAF7F2"/>
-                    </a:solidFill>
-                  </a:tcPr>
-                </a:tc>
-              </a:tr>
-              <a:tr h="457200">
-                <a:tc>
-                  <a:txBody>
-                    <a:bodyPr/>
-                    <a:lstStyle/>
-                    <a:p>
-                      <a:pPr algn="l" indent="0" marL="0">
-                        <a:buNone/>
-                      </a:pPr>
-                      <a:r>
-                        <a:rPr lang="en-US" sz="1200" b="1" dirty="0">
-                          <a:solidFill>
-                            <a:srgbClr val="2D2A26"/>
-                          </a:solidFill>
-                          <a:latin typeface="Century Gothic" pitchFamily="34" charset="0"/>
-                          <a:ea typeface="Century Gothic" pitchFamily="34" charset="-122"/>
-                          <a:cs typeface="Century Gothic" pitchFamily="34" charset="-120"/>
-                        </a:rPr>
-                        <a:t>Nigeria</a:t>
-                      </a:r>
-                      <a:endParaRPr lang="en-US" sz="1200" dirty="0">
-                        <a:latin typeface="Century Gothic" charset="0"/>
-                        <a:ea typeface="Century Gothic" charset="0"/>
-                        <a:cs typeface="Century Gothic" charset="0"/>
-                      </a:endParaRPr>
-                    </a:p>
-                  </a:txBody>
-                  <a:tcPr marL="91440" marR="91440" marT="45720" marB="45720" anchor="ctr">
-                    <a:lnL w="6350" cap="flat" cmpd="sng" algn="ctr">
-                      <a:solidFill>
-                        <a:srgbClr val="D6CFC4"/>
-                      </a:solidFill>
-                      <a:prstDash val="solid"/>
-                      <a:round/>
-                      <a:headEnd type="none" w="med" len="med"/>
-                      <a:tailEnd type="none" w="med" len="med"/>
-                    </a:lnL>
-                    <a:lnR w="6350" cap="flat" cmpd="sng" algn="ctr">
-                      <a:solidFill>
-                        <a:srgbClr val="D6CFC4"/>
-                      </a:solidFill>
-                      <a:prstDash val="solid"/>
-                      <a:round/>
-                      <a:headEnd type="none" w="med" len="med"/>
-                      <a:tailEnd type="none" w="med" len="med"/>
-                    </a:lnR>
-                    <a:lnT w="6350" cap="flat" cmpd="sng" algn="ctr">
-                      <a:solidFill>
-                        <a:srgbClr val="D6CFC4"/>
-                      </a:solidFill>
-                      <a:prstDash val="solid"/>
-                      <a:round/>
-                      <a:headEnd type="none" w="med" len="med"/>
-                      <a:tailEnd type="none" w="med" len="med"/>
-                    </a:lnT>
-                    <a:lnB w="6350" cap="flat" cmpd="sng" algn="ctr">
-                      <a:solidFill>
-                        <a:srgbClr val="D6CFC4"/>
-                      </a:solidFill>
-                      <a:prstDash val="solid"/>
-                      <a:round/>
-                      <a:headEnd type="none" w="med" len="med"/>
-                      <a:tailEnd type="none" w="med" len="med"/>
-                    </a:lnB>
-                    <a:solidFill>
-                      <a:srgbClr val="FFFFFF"/>
-                    </a:solidFill>
-                  </a:tcPr>
-                </a:tc>
-                <a:tc>
-                  <a:txBody>
-                    <a:bodyPr/>
-                    <a:lstStyle/>
-                    <a:p>
-                      <a:pPr algn="ctr" indent="0" marL="0">
-                        <a:buNone/>
-                      </a:pPr>
-                      <a:r>
-                        <a:rPr lang="en-US" sz="1200" dirty="0">
-                          <a:solidFill>
-                            <a:srgbClr val="2D2A26"/>
-                          </a:solidFill>
-                          <a:latin typeface="Calibri" pitchFamily="34" charset="0"/>
-                          <a:ea typeface="Calibri" pitchFamily="34" charset="-122"/>
-                          <a:cs typeface="Calibri" pitchFamily="34" charset="-120"/>
-                        </a:rPr>
-                        <a:t>$55,571</a:t>
-                      </a:r>
-                      <a:endParaRPr lang="en-US" sz="1200" dirty="0">
-                        <a:latin typeface="Calibri" charset="0"/>
-                        <a:ea typeface="Calibri" charset="0"/>
-                        <a:cs typeface="Calibri" charset="0"/>
-                      </a:endParaRPr>
-                    </a:p>
-                  </a:txBody>
-                  <a:tcPr marL="91440" marR="91440" marT="45720" marB="45720" anchor="ctr">
-                    <a:lnL w="6350" cap="flat" cmpd="sng" algn="ctr">
-                      <a:solidFill>
-                        <a:srgbClr val="D6CFC4"/>
-                      </a:solidFill>
-                      <a:prstDash val="solid"/>
-                      <a:round/>
-                      <a:headEnd type="none" w="med" len="med"/>
-                      <a:tailEnd type="none" w="med" len="med"/>
-                    </a:lnL>
-                    <a:lnR w="6350" cap="flat" cmpd="sng" algn="ctr">
-                      <a:solidFill>
-                        <a:srgbClr val="D6CFC4"/>
-                      </a:solidFill>
-                      <a:prstDash val="solid"/>
-                      <a:round/>
-                      <a:headEnd type="none" w="med" len="med"/>
-                      <a:tailEnd type="none" w="med" len="med"/>
-                    </a:lnR>
-                    <a:lnT w="6350" cap="flat" cmpd="sng" algn="ctr">
-                      <a:solidFill>
-                        <a:srgbClr val="D6CFC4"/>
-                      </a:solidFill>
-                      <a:prstDash val="solid"/>
-                      <a:round/>
-                      <a:headEnd type="none" w="med" len="med"/>
-                      <a:tailEnd type="none" w="med" len="med"/>
-                    </a:lnT>
-                    <a:lnB w="6350" cap="flat" cmpd="sng" algn="ctr">
-                      <a:solidFill>
-                        <a:srgbClr val="D6CFC4"/>
-                      </a:solidFill>
-                      <a:prstDash val="solid"/>
-                      <a:round/>
-                      <a:headEnd type="none" w="med" len="med"/>
-                      <a:tailEnd type="none" w="med" len="med"/>
-                    </a:lnB>
-                    <a:solidFill>
-                      <a:srgbClr val="FFFFFF"/>
-                    </a:solidFill>
-                  </a:tcPr>
-                </a:tc>
-                <a:tc>
-                  <a:txBody>
-                    <a:bodyPr/>
-                    <a:lstStyle/>
-                    <a:p>
-                      <a:pPr algn="ctr" indent="0" marL="0">
-                        <a:buNone/>
-                      </a:pPr>
-                      <a:r>
-                        <a:rPr lang="en-US" sz="1200" dirty="0">
-                          <a:solidFill>
-                            <a:srgbClr val="2D2A26"/>
-                          </a:solidFill>
-                          <a:latin typeface="Calibri" pitchFamily="34" charset="0"/>
-                          <a:ea typeface="Calibri" pitchFamily="34" charset="-122"/>
-                          <a:cs typeface="Calibri" pitchFamily="34" charset="-120"/>
-                        </a:rPr>
-                        <a:t>$-29,100</a:t>
-                      </a:r>
-                      <a:endParaRPr lang="en-US" sz="1200" dirty="0">
-                        <a:latin typeface="Calibri" charset="0"/>
-                        <a:ea typeface="Calibri" charset="0"/>
-                        <a:cs typeface="Calibri" charset="0"/>
-                      </a:endParaRPr>
-                    </a:p>
-                  </a:txBody>
-                  <a:tcPr marL="91440" marR="91440" marT="45720" marB="45720" anchor="ctr">
-                    <a:lnL w="6350" cap="flat" cmpd="sng" algn="ctr">
-                      <a:solidFill>
-                        <a:srgbClr val="D6CFC4"/>
-                      </a:solidFill>
-                      <a:prstDash val="solid"/>
-                      <a:round/>
-                      <a:headEnd type="none" w="med" len="med"/>
-                      <a:tailEnd type="none" w="med" len="med"/>
-                    </a:lnL>
-                    <a:lnR w="6350" cap="flat" cmpd="sng" algn="ctr">
-                      <a:solidFill>
-                        <a:srgbClr val="D6CFC4"/>
-                      </a:solidFill>
-                      <a:prstDash val="solid"/>
-                      <a:round/>
-                      <a:headEnd type="none" w="med" len="med"/>
-                      <a:tailEnd type="none" w="med" len="med"/>
-                    </a:lnR>
-                    <a:lnT w="6350" cap="flat" cmpd="sng" algn="ctr">
-                      <a:solidFill>
-                        <a:srgbClr val="D6CFC4"/>
-                      </a:solidFill>
-                      <a:prstDash val="solid"/>
-                      <a:round/>
-                      <a:headEnd type="none" w="med" len="med"/>
-                      <a:tailEnd type="none" w="med" len="med"/>
-                    </a:lnT>
-                    <a:lnB w="6350" cap="flat" cmpd="sng" algn="ctr">
-                      <a:solidFill>
-                        <a:srgbClr val="D6CFC4"/>
-                      </a:solidFill>
-                      <a:prstDash val="solid"/>
-                      <a:round/>
-                      <a:headEnd type="none" w="med" len="med"/>
-                      <a:tailEnd type="none" w="med" len="med"/>
-                    </a:lnB>
-                    <a:solidFill>
-                      <a:srgbClr val="FFFFFF"/>
-                    </a:solidFill>
-                  </a:tcPr>
-                </a:tc>
-                <a:tc>
-                  <a:txBody>
-                    <a:bodyPr/>
-                    <a:lstStyle/>
-                    <a:p>
-                      <a:pPr algn="ctr" indent="0" marL="0">
-                        <a:buNone/>
-                      </a:pPr>
-                      <a:r>
-                        <a:rPr lang="en-US" sz="1200" dirty="0">
-                          <a:solidFill>
-                            <a:srgbClr val="2D2A26"/>
-                          </a:solidFill>
-                          <a:latin typeface="Calibri" pitchFamily="34" charset="0"/>
-                          <a:ea typeface="Calibri" pitchFamily="34" charset="-122"/>
-                          <a:cs typeface="Calibri" pitchFamily="34" charset="-120"/>
-                        </a:rPr>
-                        <a:t>$-82,622</a:t>
-                      </a:r>
-                      <a:endParaRPr lang="en-US" sz="1200" dirty="0">
-                        <a:latin typeface="Calibri" charset="0"/>
-                        <a:ea typeface="Calibri" charset="0"/>
-                        <a:cs typeface="Calibri" charset="0"/>
-                      </a:endParaRPr>
-                    </a:p>
-                  </a:txBody>
-                  <a:tcPr marL="91440" marR="91440" marT="45720" marB="45720" anchor="ctr">
-                    <a:lnL w="6350" cap="flat" cmpd="sng" algn="ctr">
-                      <a:solidFill>
-                        <a:srgbClr val="D6CFC4"/>
-                      </a:solidFill>
-                      <a:prstDash val="solid"/>
-                      <a:round/>
-                      <a:headEnd type="none" w="med" len="med"/>
-                      <a:tailEnd type="none" w="med" len="med"/>
-                    </a:lnL>
-                    <a:lnR w="6350" cap="flat" cmpd="sng" algn="ctr">
-                      <a:solidFill>
-                        <a:srgbClr val="D6CFC4"/>
-                      </a:solidFill>
-                      <a:prstDash val="solid"/>
-                      <a:round/>
-                      <a:headEnd type="none" w="med" len="med"/>
-                      <a:tailEnd type="none" w="med" len="med"/>
-                    </a:lnR>
-                    <a:lnT w="6350" cap="flat" cmpd="sng" algn="ctr">
-                      <a:solidFill>
-                        <a:srgbClr val="D6CFC4"/>
-                      </a:solidFill>
-                      <a:prstDash val="solid"/>
-                      <a:round/>
-                      <a:headEnd type="none" w="med" len="med"/>
-                      <a:tailEnd type="none" w="med" len="med"/>
-                    </a:lnT>
-                    <a:lnB w="6350" cap="flat" cmpd="sng" algn="ctr">
-                      <a:solidFill>
-                        <a:srgbClr val="D6CFC4"/>
-                      </a:solidFill>
-                      <a:prstDash val="solid"/>
-                      <a:round/>
-                      <a:headEnd type="none" w="med" len="med"/>
-                      <a:tailEnd type="none" w="med" len="med"/>
-                    </a:lnB>
-                    <a:solidFill>
-                      <a:srgbClr val="FFFFFF"/>
-                    </a:solidFill>
-                  </a:tcPr>
-                </a:tc>
-                <a:tc>
-                  <a:txBody>
-                    <a:bodyPr/>
-                    <a:lstStyle/>
-                    <a:p>
-                      <a:pPr algn="ctr" indent="0" marL="0">
-                        <a:buNone/>
-                      </a:pPr>
-                      <a:r>
-                        <a:rPr lang="en-US" sz="1200" dirty="0">
-                          <a:solidFill>
-                            <a:srgbClr val="C0392B"/>
-                          </a:solidFill>
-                          <a:latin typeface="Calibri" pitchFamily="34" charset="0"/>
-                          <a:ea typeface="Calibri" pitchFamily="34" charset="-122"/>
-                          <a:cs typeface="Calibri" pitchFamily="34" charset="-120"/>
-                        </a:rPr>
-                        <a:t>$-56,151</a:t>
-                      </a:r>
-                      <a:endParaRPr lang="en-US" sz="1200" dirty="0">
-                        <a:latin typeface="Calibri" charset="0"/>
-                        <a:ea typeface="Calibri" charset="0"/>
-                        <a:cs typeface="Calibri" charset="0"/>
-                      </a:endParaRPr>
-                    </a:p>
-                  </a:txBody>
-                  <a:tcPr marL="91440" marR="91440" marT="45720" marB="45720" anchor="ctr">
-                    <a:lnL w="6350" cap="flat" cmpd="sng" algn="ctr">
-                      <a:solidFill>
-                        <a:srgbClr val="D6CFC4"/>
-                      </a:solidFill>
-                      <a:prstDash val="solid"/>
-                      <a:round/>
-                      <a:headEnd type="none" w="med" len="med"/>
-                      <a:tailEnd type="none" w="med" len="med"/>
-                    </a:lnL>
-                    <a:lnR w="6350" cap="flat" cmpd="sng" algn="ctr">
-                      <a:solidFill>
-                        <a:srgbClr val="D6CFC4"/>
-                      </a:solidFill>
-                      <a:prstDash val="solid"/>
-                      <a:round/>
-                      <a:headEnd type="none" w="med" len="med"/>
-                      <a:tailEnd type="none" w="med" len="med"/>
-                    </a:lnR>
-                    <a:lnT w="6350" cap="flat" cmpd="sng" algn="ctr">
-                      <a:solidFill>
-                        <a:srgbClr val="D6CFC4"/>
-                      </a:solidFill>
-                      <a:prstDash val="solid"/>
-                      <a:round/>
-                      <a:headEnd type="none" w="med" len="med"/>
-                      <a:tailEnd type="none" w="med" len="med"/>
-                    </a:lnT>
-                    <a:lnB w="6350" cap="flat" cmpd="sng" algn="ctr">
-                      <a:solidFill>
-                        <a:srgbClr val="D6CFC4"/>
-                      </a:solidFill>
-                      <a:prstDash val="solid"/>
-                      <a:round/>
-                      <a:headEnd type="none" w="med" len="med"/>
-                      <a:tailEnd type="none" w="med" len="med"/>
-                    </a:lnB>
-                    <a:solidFill>
-                      <a:srgbClr val="FFFFFF"/>
-                    </a:solidFill>
-                  </a:tcPr>
-                </a:tc>
-                <a:tc>
-                  <a:txBody>
-                    <a:bodyPr/>
-                    <a:lstStyle/>
-                    <a:p>
-                      <a:pPr algn="ctr" indent="0" marL="0">
-                        <a:buNone/>
-                      </a:pPr>
-                      <a:r>
-                        <a:rPr lang="en-US" sz="1200" dirty="0">
-                          <a:solidFill>
-                            <a:srgbClr val="C0392B"/>
-                          </a:solidFill>
-                          <a:latin typeface="Calibri" pitchFamily="34" charset="0"/>
-                          <a:ea typeface="Calibri" pitchFamily="34" charset="-122"/>
-                          <a:cs typeface="Calibri" pitchFamily="34" charset="-120"/>
-                        </a:rPr>
-                        <a:t>-101.0%</a:t>
-                      </a:r>
-                      <a:endParaRPr lang="en-US" sz="1200" dirty="0">
-                        <a:latin typeface="Calibri" charset="0"/>
-                        <a:ea typeface="Calibri" charset="0"/>
-                        <a:cs typeface="Calibri" charset="0"/>
-                      </a:endParaRPr>
-                    </a:p>
-                  </a:txBody>
-                  <a:tcPr marL="91440" marR="91440" marT="45720" marB="45720" anchor="ctr">
-                    <a:lnL w="6350" cap="flat" cmpd="sng" algn="ctr">
-                      <a:solidFill>
-                        <a:srgbClr val="D6CFC4"/>
-                      </a:solidFill>
-                      <a:prstDash val="solid"/>
-                      <a:round/>
-                      <a:headEnd type="none" w="med" len="med"/>
-                      <a:tailEnd type="none" w="med" len="med"/>
-                    </a:lnL>
-                    <a:lnR w="6350" cap="flat" cmpd="sng" algn="ctr">
-                      <a:solidFill>
-                        <a:srgbClr val="D6CFC4"/>
-                      </a:solidFill>
-                      <a:prstDash val="solid"/>
-                      <a:round/>
-                      <a:headEnd type="none" w="med" len="med"/>
-                      <a:tailEnd type="none" w="med" len="med"/>
-                    </a:lnR>
-                    <a:lnT w="6350" cap="flat" cmpd="sng" algn="ctr">
-                      <a:solidFill>
-                        <a:srgbClr val="D6CFC4"/>
-                      </a:solidFill>
-                      <a:prstDash val="solid"/>
-                      <a:round/>
-                      <a:headEnd type="none" w="med" len="med"/>
-                      <a:tailEnd type="none" w="med" len="med"/>
-                    </a:lnT>
-                    <a:lnB w="6350" cap="flat" cmpd="sng" algn="ctr">
-                      <a:solidFill>
-                        <a:srgbClr val="D6CFC4"/>
-                      </a:solidFill>
-                      <a:prstDash val="solid"/>
-                      <a:round/>
-                      <a:headEnd type="none" w="med" len="med"/>
-                      <a:tailEnd type="none" w="med" len="med"/>
-                    </a:lnB>
-                    <a:solidFill>
-                      <a:srgbClr val="FFFFFF"/>
-                    </a:solidFill>
-                  </a:tcPr>
-                </a:tc>
-                <a:tc>
-                  <a:txBody>
-                    <a:bodyPr/>
-                    <a:lstStyle/>
-                    <a:p>
-                      <a:pPr algn="ctr" indent="0" marL="0">
-                        <a:buNone/>
-                      </a:pPr>
-                      <a:r>
-                        <a:rPr lang="en-US" sz="1200" dirty="0">
-                          <a:solidFill>
-                            <a:srgbClr val="C0392B"/>
-                          </a:solidFill>
-                          <a:latin typeface="Calibri" pitchFamily="34" charset="0"/>
-                          <a:ea typeface="Calibri" pitchFamily="34" charset="-122"/>
-                          <a:cs typeface="Calibri" pitchFamily="34" charset="-120"/>
-                        </a:rPr>
-                        <a:t>$-65,698</a:t>
                       </a:r>
                       <a:endParaRPr lang="en-US" sz="1200" dirty="0">
                         <a:latin typeface="Calibri" charset="0"/>
@@ -8776,7 +8776,7 @@
                           <a:ea typeface="Calibri" pitchFamily="34" charset="-122"/>
                           <a:cs typeface="Calibri" pitchFamily="34" charset="-120"/>
                         </a:rPr>
-                        <a:t>$333,851</a:t>
+                        <a:t>$2,998,333</a:t>
                       </a:r>
                       <a:endParaRPr lang="en-US" sz="1200" dirty="0">
                         <a:latin typeface="Calibri" charset="0"/>
@@ -8844,7 +8844,7 @@
                           <a:ea typeface="Calibri" pitchFamily="34" charset="-122"/>
                           <a:cs typeface="Calibri" pitchFamily="34" charset="-120"/>
                         </a:rPr>
-                        <a:t>17.2%</a:t>
+                        <a:t>154.8%</a:t>
                       </a:r>
                       <a:endParaRPr lang="en-US" sz="1200" dirty="0">
                         <a:latin typeface="Calibri" charset="0"/>
@@ -8912,7 +8912,7 @@
                           <a:ea typeface="Calibri" pitchFamily="34" charset="-122"/>
                           <a:cs typeface="Calibri" pitchFamily="34" charset="-120"/>
                         </a:rPr>
-                        <a:t>$340,475</a:t>
+                        <a:t>$3,096,205</a:t>
                       </a:r>
                       <a:endParaRPr lang="en-US" sz="1200" dirty="0">
                         <a:latin typeface="Calibri" charset="0"/>
@@ -9232,7 +9232,7 @@
                 <a:ea typeface="Century Gothic" pitchFamily="34" charset="-122"/>
                 <a:cs typeface="Century Gothic" pitchFamily="34" charset="-120"/>
               </a:rPr>
-              <a:t>$333,851</a:t>
+              <a:t>$2,998,333</a:t>
             </a:r>
             <a:endParaRPr lang="en-US" sz="2600" dirty="0"/>
           </a:p>
@@ -9367,7 +9367,7 @@
                 <a:ea typeface="Century Gothic" pitchFamily="34" charset="-122"/>
                 <a:cs typeface="Century Gothic" pitchFamily="34" charset="-120"/>
               </a:rPr>
-              <a:t>17.2%</a:t>
+              <a:t>154.8%</a:t>
             </a:r>
             <a:endParaRPr lang="en-US" sz="2600" dirty="0"/>
           </a:p>
@@ -9973,7 +9973,7 @@
                 <a:ea typeface="Calibri" pitchFamily="34" charset="-122"/>
                 <a:cs typeface="Calibri" pitchFamily="34" charset="-120"/>
               </a:rPr>
-              <a:t>-3.3%</a:t>
+              <a:t>-2.8%</a:t>
             </a:r>
             <a:endParaRPr lang="en-US" sz="1200" dirty="0"/>
           </a:p>
@@ -10012,7 +10012,7 @@
                 <a:ea typeface="Calibri" pitchFamily="34" charset="-122"/>
                 <a:cs typeface="Calibri" pitchFamily="34" charset="-120"/>
               </a:rPr>
-              <a:t>-2.8%</a:t>
+              <a:t>-3.3%</a:t>
             </a:r>
             <a:endParaRPr lang="en-US" sz="1200" dirty="0"/>
           </a:p>
@@ -11508,7 +11508,7 @@
                 <a:ea typeface="Calibri" pitchFamily="34" charset="-122"/>
                 <a:cs typeface="Calibri" pitchFamily="34" charset="-120"/>
               </a:rPr>
-              <a:t>+0.0%</a:t>
+              <a:t>-1.6%</a:t>
             </a:r>
             <a:endParaRPr lang="en-US" sz="1200" dirty="0"/>
           </a:p>
@@ -12242,6 +12242,45 @@
                 <a:ea typeface="Calibri" pitchFamily="34" charset="-122"/>
                 <a:cs typeface="Calibri" pitchFamily="34" charset="-120"/>
               </a:rPr>
+              <a:t>-12.5%</a:t>
+            </a:r>
+            <a:endParaRPr lang="en-US" sz="1200" dirty="0"/>
+          </a:p>
+        </p:txBody>
+      </p:sp>
+      <p:sp>
+        <p:nvSpPr>
+          <p:cNvPr id="16" name="Text 13"/>
+          <p:cNvSpPr/>
+          <p:nvPr/>
+        </p:nvSpPr>
+        <p:spPr>
+          <a:xfrm>
+            <a:off x="1655064" y="5925312"/>
+            <a:ext cx="1517904" cy="347472"/>
+          </a:xfrm>
+          <a:prstGeom prst="rect">
+            <a:avLst/>
+          </a:prstGeom>
+          <a:noFill/>
+          <a:ln/>
+        </p:spPr>
+        <p:txBody>
+          <a:bodyPr wrap="square" rtlCol="0" anchor="ctr"/>
+          <a:lstStyle/>
+          <a:p>
+            <a:pPr algn="ctr" indent="0" marL="0">
+              <a:buNone/>
+            </a:pPr>
+            <a:r>
+              <a:rPr lang="en-US" sz="1200" b="1" dirty="0">
+                <a:solidFill>
+                  <a:srgbClr val="C0392B"/>
+                </a:solidFill>
+                <a:latin typeface="Calibri" pitchFamily="34" charset="0"/>
+                <a:ea typeface="Calibri" pitchFamily="34" charset="-122"/>
+                <a:cs typeface="Calibri" pitchFamily="34" charset="-120"/>
+              </a:rPr>
               <a:t>-13.8%</a:t>
             </a:r>
             <a:endParaRPr lang="en-US" sz="1200" dirty="0"/>
@@ -12250,13 +12289,13 @@
       </p:sp>
       <p:sp>
         <p:nvSpPr>
-          <p:cNvPr id="16" name="Text 13"/>
-          <p:cNvSpPr/>
-          <p:nvPr/>
-        </p:nvSpPr>
-        <p:spPr>
-          <a:xfrm>
-            <a:off x="1655064" y="5925312"/>
+          <p:cNvPr id="17" name="Text 14"/>
+          <p:cNvSpPr/>
+          <p:nvPr/>
+        </p:nvSpPr>
+        <p:spPr>
+          <a:xfrm>
+            <a:off x="3172968" y="5925312"/>
             <a:ext cx="1517904" cy="347472"/>
           </a:xfrm>
           <a:prstGeom prst="rect">
@@ -12289,13 +12328,13 @@
       </p:sp>
       <p:sp>
         <p:nvSpPr>
-          <p:cNvPr id="17" name="Text 14"/>
-          <p:cNvSpPr/>
-          <p:nvPr/>
-        </p:nvSpPr>
-        <p:spPr>
-          <a:xfrm>
-            <a:off x="3172968" y="5925312"/>
+          <p:cNvPr id="18" name="Text 15"/>
+          <p:cNvSpPr/>
+          <p:nvPr/>
+        </p:nvSpPr>
+        <p:spPr>
+          <a:xfrm>
+            <a:off x="4690872" y="5925312"/>
             <a:ext cx="1517904" cy="347472"/>
           </a:xfrm>
           <a:prstGeom prst="rect">
@@ -12321,45 +12360,6 @@
                 <a:cs typeface="Calibri" pitchFamily="34" charset="-120"/>
               </a:rPr>
               <a:t>-21.6%</a:t>
-            </a:r>
-            <a:endParaRPr lang="en-US" sz="1200" dirty="0"/>
-          </a:p>
-        </p:txBody>
-      </p:sp>
-      <p:sp>
-        <p:nvSpPr>
-          <p:cNvPr id="18" name="Text 15"/>
-          <p:cNvSpPr/>
-          <p:nvPr/>
-        </p:nvSpPr>
-        <p:spPr>
-          <a:xfrm>
-            <a:off x="4690872" y="5925312"/>
-            <a:ext cx="1517904" cy="347472"/>
-          </a:xfrm>
-          <a:prstGeom prst="rect">
-            <a:avLst/>
-          </a:prstGeom>
-          <a:noFill/>
-          <a:ln/>
-        </p:spPr>
-        <p:txBody>
-          <a:bodyPr wrap="square" rtlCol="0" anchor="ctr"/>
-          <a:lstStyle/>
-          <a:p>
-            <a:pPr algn="ctr" indent="0" marL="0">
-              <a:buNone/>
-            </a:pPr>
-            <a:r>
-              <a:rPr lang="en-US" sz="1200" b="1" dirty="0">
-                <a:solidFill>
-                  <a:srgbClr val="718096"/>
-                </a:solidFill>
-                <a:latin typeface="Calibri" pitchFamily="34" charset="0"/>
-                <a:ea typeface="Calibri" pitchFamily="34" charset="-122"/>
-                <a:cs typeface="Calibri" pitchFamily="34" charset="-120"/>
-              </a:rPr>
-              <a:t>-100.0%</a:t>
             </a:r>
             <a:endParaRPr lang="en-US" sz="1200" dirty="0"/>
           </a:p>
@@ -12494,7 +12494,7 @@
                 <a:ea typeface="Century Gothic" pitchFamily="34" charset="-122"/>
                 <a:cs typeface="Century Gothic" pitchFamily="34" charset="-120"/>
               </a:rPr>
-              <a:t>9,521</a:t>
+              <a:t>21,231</a:t>
             </a:r>
             <a:endParaRPr lang="en-US" sz="2600" dirty="0"/>
           </a:p>
@@ -12629,7 +12629,7 @@
                 <a:ea typeface="Century Gothic" pitchFamily="34" charset="-122"/>
                 <a:cs typeface="Century Gothic" pitchFamily="34" charset="-120"/>
               </a:rPr>
-              <a:t>38</a:t>
+              <a:t>69</a:t>
             </a:r>
             <a:endParaRPr lang="en-US" sz="2600" dirty="0"/>
           </a:p>
@@ -12764,7 +12764,7 @@
                 <a:ea typeface="Century Gothic" pitchFamily="34" charset="-122"/>
                 <a:cs typeface="Century Gothic" pitchFamily="34" charset="-120"/>
               </a:rPr>
-              <a:t>-51.3%</a:t>
+              <a:t>-11.5%</a:t>
             </a:r>
             <a:endParaRPr lang="en-US" sz="2600" dirty="0"/>
           </a:p>
@@ -12931,7 +12931,7 @@
                 <a:ea typeface="Calibri" pitchFamily="34" charset="-122"/>
                 <a:cs typeface="Calibri" pitchFamily="34" charset="-120"/>
               </a:rPr>
-              <a:t>Group total: 9,521 applications (-60.8% vs prior month).</a:t>
+              <a:t>Group total: 21,231 applications (-12.7% vs prior month).</a:t>
             </a:r>
             <a:endParaRPr lang="en-US" sz="1200" dirty="0"/>
           </a:p>
@@ -12948,7 +12948,7 @@
                 <a:ea typeface="Calibri" pitchFamily="34" charset="-122"/>
                 <a:cs typeface="Calibri" pitchFamily="34" charset="-120"/>
               </a:rPr>
-              <a:t>Kenya had the highest avg applications per team (69).</a:t>
+              <a:t>Tanzania had the highest avg applications per team (84).</a:t>
             </a:r>
             <a:endParaRPr lang="en-US" sz="1200" dirty="0"/>
           </a:p>
@@ -13431,13 +13431,13 @@
             <a:r>
               <a:rPr lang="en-US" sz="1200" b="1" dirty="0">
                 <a:solidFill>
-                  <a:srgbClr val="C0392B"/>
+                  <a:srgbClr val="1A7A6E"/>
                 </a:solidFill>
                 <a:latin typeface="Calibri" pitchFamily="34" charset="0"/>
                 <a:ea typeface="Calibri" pitchFamily="34" charset="-122"/>
                 <a:cs typeface="Calibri" pitchFamily="34" charset="-120"/>
               </a:rPr>
-              <a:t>↓</a:t>
+              <a:t>↑</a:t>
             </a:r>
             <a:endParaRPr lang="en-US" sz="1200" dirty="0"/>
           </a:p>
@@ -13509,13 +13509,13 @@
             <a:r>
               <a:rPr lang="en-US" sz="1200" b="1" dirty="0">
                 <a:solidFill>
-                  <a:srgbClr val="718096"/>
+                  <a:srgbClr val="C0392B"/>
                 </a:solidFill>
                 <a:latin typeface="Calibri" pitchFamily="34" charset="0"/>
                 <a:ea typeface="Calibri" pitchFamily="34" charset="-122"/>
                 <a:cs typeface="Calibri" pitchFamily="34" charset="-120"/>
               </a:rPr>
-              <a:t>—</a:t>
+              <a:t>↓</a:t>
             </a:r>
             <a:endParaRPr lang="en-US" sz="1200" dirty="0"/>
           </a:p>
@@ -13785,7 +13785,7 @@
                 <a:ea typeface="Century Gothic" pitchFamily="34" charset="-122"/>
                 <a:cs typeface="Century Gothic" pitchFamily="34" charset="-120"/>
               </a:rPr>
-              <a:t>202.4%</a:t>
+              <a:t>90.8%</a:t>
             </a:r>
             <a:endParaRPr lang="en-US" sz="2600" dirty="0"/>
           </a:p>
@@ -13914,13 +13914,13 @@
             <a:r>
               <a:rPr lang="en-US" sz="2600" b="1" dirty="0">
                 <a:solidFill>
-                  <a:srgbClr val="1A7A6E"/>
+                  <a:srgbClr val="C0392B"/>
                 </a:solidFill>
                 <a:latin typeface="Century Gothic" pitchFamily="34" charset="0"/>
                 <a:ea typeface="Century Gothic" pitchFamily="34" charset="-122"/>
                 <a:cs typeface="Century Gothic" pitchFamily="34" charset="-120"/>
               </a:rPr>
-              <a:t>↑</a:t>
+              <a:t>↓</a:t>
             </a:r>
             <a:endParaRPr lang="en-US" sz="2600" dirty="0"/>
           </a:p>
@@ -15076,7 +15076,7 @@
                 <a:ea typeface="Century Gothic" pitchFamily="34" charset="-122"/>
                 <a:cs typeface="Century Gothic" pitchFamily="34" charset="-120"/>
               </a:rPr>
-              <a:t>78</a:t>
+              <a:t>63</a:t>
             </a:r>
             <a:endParaRPr lang="en-US" sz="2600" dirty="0"/>
           </a:p>
@@ -15307,7 +15307,7 @@
                 <a:ea typeface="Century Gothic" pitchFamily="34" charset="-122"/>
                 <a:cs typeface="Century Gothic" pitchFamily="34" charset="-120"/>
               </a:rPr>
-              <a:t>79</a:t>
+              <a:t>139</a:t>
             </a:r>
             <a:endParaRPr lang="en-US" sz="1100" dirty="0"/>
           </a:p>
@@ -17348,6 +17348,45 @@
                 <a:ea typeface="Calibri" pitchFamily="34" charset="-122"/>
                 <a:cs typeface="Calibri" pitchFamily="34" charset="-120"/>
               </a:rPr>
+              <a:t>↓</a:t>
+            </a:r>
+            <a:endParaRPr lang="en-US" sz="1200" dirty="0"/>
+          </a:p>
+        </p:txBody>
+      </p:sp>
+      <p:sp>
+        <p:nvSpPr>
+          <p:cNvPr id="17" name="Text 14"/>
+          <p:cNvSpPr/>
+          <p:nvPr/>
+        </p:nvSpPr>
+        <p:spPr>
+          <a:xfrm>
+            <a:off x="3172968" y="5925312"/>
+            <a:ext cx="1517904" cy="347472"/>
+          </a:xfrm>
+          <a:prstGeom prst="rect">
+            <a:avLst/>
+          </a:prstGeom>
+          <a:noFill/>
+          <a:ln/>
+        </p:spPr>
+        <p:txBody>
+          <a:bodyPr wrap="square" rtlCol="0" anchor="ctr"/>
+          <a:lstStyle/>
+          <a:p>
+            <a:pPr algn="ctr" indent="0" marL="0">
+              <a:buNone/>
+            </a:pPr>
+            <a:r>
+              <a:rPr lang="en-US" sz="1200" b="1" dirty="0">
+                <a:solidFill>
+                  <a:srgbClr val="1A7A6E"/>
+                </a:solidFill>
+                <a:latin typeface="Calibri" pitchFamily="34" charset="0"/>
+                <a:ea typeface="Calibri" pitchFamily="34" charset="-122"/>
+                <a:cs typeface="Calibri" pitchFamily="34" charset="-120"/>
+              </a:rPr>
               <a:t>—</a:t>
             </a:r>
             <a:endParaRPr lang="en-US" sz="1200" dirty="0"/>
@@ -17356,13 +17395,13 @@
       </p:sp>
       <p:sp>
         <p:nvSpPr>
-          <p:cNvPr id="17" name="Text 14"/>
-          <p:cNvSpPr/>
-          <p:nvPr/>
-        </p:nvSpPr>
-        <p:spPr>
-          <a:xfrm>
-            <a:off x="3172968" y="5925312"/>
+          <p:cNvPr id="18" name="Text 15"/>
+          <p:cNvSpPr/>
+          <p:nvPr/>
+        </p:nvSpPr>
+        <p:spPr>
+          <a:xfrm>
+            <a:off x="4690872" y="5925312"/>
             <a:ext cx="1517904" cy="347472"/>
           </a:xfrm>
           <a:prstGeom prst="rect">
@@ -17388,45 +17427,6 @@
                 <a:cs typeface="Calibri" pitchFamily="34" charset="-120"/>
               </a:rPr>
               <a:t>↓</a:t>
-            </a:r>
-            <a:endParaRPr lang="en-US" sz="1200" dirty="0"/>
-          </a:p>
-        </p:txBody>
-      </p:sp>
-      <p:sp>
-        <p:nvSpPr>
-          <p:cNvPr id="18" name="Text 15"/>
-          <p:cNvSpPr/>
-          <p:nvPr/>
-        </p:nvSpPr>
-        <p:spPr>
-          <a:xfrm>
-            <a:off x="4690872" y="5925312"/>
-            <a:ext cx="1517904" cy="347472"/>
-          </a:xfrm>
-          <a:prstGeom prst="rect">
-            <a:avLst/>
-          </a:prstGeom>
-          <a:noFill/>
-          <a:ln/>
-        </p:spPr>
-        <p:txBody>
-          <a:bodyPr wrap="square" rtlCol="0" anchor="ctr"/>
-          <a:lstStyle/>
-          <a:p>
-            <a:pPr algn="ctr" indent="0" marL="0">
-              <a:buNone/>
-            </a:pPr>
-            <a:r>
-              <a:rPr lang="en-US" sz="1200" b="1" dirty="0">
-                <a:solidFill>
-                  <a:srgbClr val="C0392B"/>
-                </a:solidFill>
-                <a:latin typeface="Calibri" pitchFamily="34" charset="0"/>
-                <a:ea typeface="Calibri" pitchFamily="34" charset="-122"/>
-                <a:cs typeface="Calibri" pitchFamily="34" charset="-120"/>
-              </a:rPr>
-              <a:t>↑</a:t>
             </a:r>
             <a:endParaRPr lang="en-US" sz="1200" dirty="0"/>
           </a:p>
@@ -17880,7 +17880,7 @@
                 <a:ea typeface="Calibri" pitchFamily="34" charset="-122"/>
                 <a:cs typeface="Calibri" pitchFamily="34" charset="-120"/>
               </a:rPr>
-              <a:t>Fastest: Kenya (3 days). Slowest: Tanzania (12 days).</a:t>
+              <a:t>Fastest: Tanzania (2 days). Slowest: Kenya (3 days).</a:t>
             </a:r>
             <a:endParaRPr lang="en-US" sz="1200" dirty="0"/>
           </a:p>

</xml_diff>

<commit_message>
Auto-build: 2026-05-08 02:28 UTC
</commit_message>
<xml_diff>
--- a/reports/2026-04.pptx
+++ b/reports/2026-04.pptx
@@ -241,16 +241,16 @@
                     <c:v>Tanzania</c:v>
                   </c:pt>
                   <c:pt idx="1">
+                    <c:v>Uganda</c:v>
+                  </c:pt>
+                  <c:pt idx="2">
                     <c:v>Kenya</c:v>
                   </c:pt>
-                  <c:pt idx="2">
+                  <c:pt idx="3">
                     <c:v>Sierra Leone</c:v>
                   </c:pt>
-                  <c:pt idx="3">
+                  <c:pt idx="4">
                     <c:v>Nigeria</c:v>
-                  </c:pt>
-                  <c:pt idx="4">
-                    <c:v>Uganda</c:v>
                   </c:pt>
                 </c:lvl>
               </c:multiLvlStrCache>
@@ -266,16 +266,16 @@
                   <c:v>84</c:v>
                 </c:pt>
                 <c:pt idx="1">
+                  <c:v>74</c:v>
+                </c:pt>
+                <c:pt idx="2">
                   <c:v>69</c:v>
                 </c:pt>
-                <c:pt idx="2">
+                <c:pt idx="3">
                   <c:v>47</c:v>
                 </c:pt>
-                <c:pt idx="3">
+                <c:pt idx="4">
                   <c:v>29</c:v>
-                </c:pt>
-                <c:pt idx="4">
-                  <c:v>0</c:v>
                 </c:pt>
               </c:numCache>
             </c:numRef>
@@ -563,7 +563,7 @@
                 <c:formatCode>General</c:formatCode>
                 <c:ptCount val="5"/>
                 <c:pt idx="0">
-                  <c:v>0</c:v>
+                  <c:v>8</c:v>
                 </c:pt>
                 <c:pt idx="1">
                   <c:v>20</c:v>
@@ -844,13 +844,13 @@
                     <c:v>Tanzania</c:v>
                   </c:pt>
                   <c:pt idx="2">
+                    <c:v>Uganda</c:v>
+                  </c:pt>
+                  <c:pt idx="3">
                     <c:v>Sierra Leone</c:v>
                   </c:pt>
-                  <c:pt idx="3">
+                  <c:pt idx="4">
                     <c:v>Kenya</c:v>
-                  </c:pt>
-                  <c:pt idx="4">
-                    <c:v>Uganda</c:v>
                   </c:pt>
                 </c:lvl>
               </c:multiLvlStrCache>
@@ -869,13 +869,13 @@
                   <c:v>0.949701</c:v>
                 </c:pt>
                 <c:pt idx="2">
+                  <c:v>0.899073</c:v>
+                </c:pt>
+                <c:pt idx="3">
                   <c:v>0.871729</c:v>
                 </c:pt>
-                <c:pt idx="3">
+                <c:pt idx="4">
                   <c:v>0.831573</c:v>
-                </c:pt>
-                <c:pt idx="4">
-                  <c:v>0</c:v>
                 </c:pt>
               </c:numCache>
             </c:numRef>
@@ -1138,19 +1138,19 @@
                 <c:ptCount val="5"/>
                 <c:lvl>
                   <c:pt idx="0">
+                    <c:v>Uganda</c:v>
+                  </c:pt>
+                  <c:pt idx="1">
                     <c:v>Tanzania</c:v>
                   </c:pt>
-                  <c:pt idx="1">
+                  <c:pt idx="2">
                     <c:v>Kenya</c:v>
                   </c:pt>
-                  <c:pt idx="2">
+                  <c:pt idx="3">
                     <c:v>Sierra Leone</c:v>
                   </c:pt>
-                  <c:pt idx="3">
+                  <c:pt idx="4">
                     <c:v>Nigeria</c:v>
-                  </c:pt>
-                  <c:pt idx="4">
-                    <c:v>Uganda</c:v>
                   </c:pt>
                 </c:lvl>
               </c:multiLvlStrCache>
@@ -1163,19 +1163,19 @@
                 <c:formatCode>General</c:formatCode>
                 <c:ptCount val="5"/>
                 <c:pt idx="0">
+                  <c:v>1958650000</c:v>
+                </c:pt>
+                <c:pt idx="1">
                   <c:v>2578766.939</c:v>
                 </c:pt>
-                <c:pt idx="1">
+                <c:pt idx="2">
                   <c:v>1665440.892</c:v>
                 </c:pt>
-                <c:pt idx="2">
+                <c:pt idx="3">
                   <c:v>670923.5772</c:v>
                 </c:pt>
-                <c:pt idx="3">
+                <c:pt idx="4">
                   <c:v>177919.708</c:v>
-                </c:pt>
-                <c:pt idx="4">
-                  <c:v>0</c:v>
                 </c:pt>
               </c:numCache>
             </c:numRef>
@@ -1438,19 +1438,19 @@
                 <c:ptCount val="5"/>
                 <c:lvl>
                   <c:pt idx="0">
+                    <c:v>Uganda</c:v>
+                  </c:pt>
+                  <c:pt idx="1">
                     <c:v>Tanzania</c:v>
                   </c:pt>
-                  <c:pt idx="1">
+                  <c:pt idx="2">
                     <c:v>Kenya</c:v>
                   </c:pt>
-                  <c:pt idx="2">
+                  <c:pt idx="3">
                     <c:v>Sierra Leone</c:v>
                   </c:pt>
-                  <c:pt idx="3">
+                  <c:pt idx="4">
                     <c:v>Nigeria</c:v>
-                  </c:pt>
-                  <c:pt idx="4">
-                    <c:v>Uganda</c:v>
                   </c:pt>
                 </c:lvl>
               </c:multiLvlStrCache>
@@ -1463,19 +1463,19 @@
                 <c:formatCode>General</c:formatCode>
                 <c:ptCount val="5"/>
                 <c:pt idx="0">
+                  <c:v>779407.0832</c:v>
+                </c:pt>
+                <c:pt idx="1">
                   <c:v>231.8618</c:v>
                 </c:pt>
-                <c:pt idx="1">
+                <c:pt idx="2">
                   <c:v>289.793091</c:v>
                 </c:pt>
-                <c:pt idx="2">
+                <c:pt idx="3">
                   <c:v>457.03241</c:v>
                 </c:pt>
-                <c:pt idx="3">
+                <c:pt idx="4">
                   <c:v>169.770714</c:v>
-                </c:pt>
-                <c:pt idx="4">
-                  <c:v>0</c:v>
                 </c:pt>
               </c:numCache>
             </c:numRef>
@@ -1738,19 +1738,19 @@
                 <c:ptCount val="5"/>
                 <c:lvl>
                   <c:pt idx="0">
+                    <c:v>Uganda</c:v>
+                  </c:pt>
+                  <c:pt idx="1">
                     <c:v>Tanzania</c:v>
                   </c:pt>
-                  <c:pt idx="1">
+                  <c:pt idx="2">
                     <c:v>Kenya</c:v>
                   </c:pt>
-                  <c:pt idx="2">
+                  <c:pt idx="3">
                     <c:v>Sierra Leone</c:v>
                   </c:pt>
-                  <c:pt idx="3">
+                  <c:pt idx="4">
                     <c:v>Nigeria</c:v>
-                  </c:pt>
-                  <c:pt idx="4">
-                    <c:v>Uganda</c:v>
                   </c:pt>
                 </c:lvl>
               </c:multiLvlStrCache>
@@ -1763,19 +1763,19 @@
                 <c:formatCode>General</c:formatCode>
                 <c:ptCount val="5"/>
                 <c:pt idx="0">
+                  <c:v>68</c:v>
+                </c:pt>
+                <c:pt idx="1">
                   <c:v>141</c:v>
                 </c:pt>
-                <c:pt idx="1">
+                <c:pt idx="2">
                   <c:v>76</c:v>
                 </c:pt>
-                <c:pt idx="2">
+                <c:pt idx="3">
                   <c:v>26</c:v>
                 </c:pt>
-                <c:pt idx="3">
+                <c:pt idx="4">
                   <c:v>66</c:v>
-                </c:pt>
-                <c:pt idx="4">
-                  <c:v>0</c:v>
                 </c:pt>
               </c:numCache>
             </c:numRef>
@@ -2044,13 +2044,13 @@
                     <c:v>Kenya</c:v>
                   </c:pt>
                   <c:pt idx="2">
+                    <c:v>Uganda</c:v>
+                  </c:pt>
+                  <c:pt idx="3">
                     <c:v>Sierra Leone</c:v>
                   </c:pt>
-                  <c:pt idx="3">
+                  <c:pt idx="4">
                     <c:v>Nigeria</c:v>
-                  </c:pt>
-                  <c:pt idx="4">
-                    <c:v>Uganda</c:v>
                   </c:pt>
                 </c:lvl>
               </c:multiLvlStrCache>
@@ -2075,7 +2075,7 @@
                   <c:v>3</c:v>
                 </c:pt>
                 <c:pt idx="4">
-                  <c:v>0</c:v>
+                  <c:v>3</c:v>
                 </c:pt>
               </c:numCache>
             </c:numRef>
@@ -2338,19 +2338,19 @@
                 <c:ptCount val="5"/>
                 <c:lvl>
                   <c:pt idx="0">
+                    <c:v>Uganda</c:v>
+                  </c:pt>
+                  <c:pt idx="1">
                     <c:v>Tanzania</c:v>
                   </c:pt>
-                  <c:pt idx="1">
+                  <c:pt idx="2">
                     <c:v>Kenya</c:v>
                   </c:pt>
-                  <c:pt idx="2">
+                  <c:pt idx="3">
                     <c:v>Sierra Leone</c:v>
                   </c:pt>
-                  <c:pt idx="3">
+                  <c:pt idx="4">
                     <c:v>Nigeria</c:v>
-                  </c:pt>
-                  <c:pt idx="4">
-                    <c:v>Uganda</c:v>
                   </c:pt>
                 </c:lvl>
               </c:multiLvlStrCache>
@@ -2363,19 +2363,19 @@
                 <c:formatCode>General</c:formatCode>
                 <c:ptCount val="5"/>
                 <c:pt idx="0">
+                  <c:v>5080472080</c:v>
+                </c:pt>
+                <c:pt idx="1">
                   <c:v>6528403.079</c:v>
                 </c:pt>
-                <c:pt idx="1">
+                <c:pt idx="2">
                   <c:v>4047098.07</c:v>
                 </c:pt>
-                <c:pt idx="2">
+                <c:pt idx="3">
                   <c:v>1367460.185</c:v>
                 </c:pt>
-                <c:pt idx="3">
+                <c:pt idx="4">
                   <c:v>426047.6987</c:v>
-                </c:pt>
-                <c:pt idx="4">
-                  <c:v>0</c:v>
                 </c:pt>
               </c:numCache>
             </c:numRef>
@@ -2638,16 +2638,16 @@
                 <c:ptCount val="5"/>
                 <c:lvl>
                   <c:pt idx="0">
-                    <c:v>Uganda</c:v>
+                    <c:v>Nigeria</c:v>
                   </c:pt>
                   <c:pt idx="1">
-                    <c:v>Nigeria</c:v>
+                    <c:v>Sierra Leone</c:v>
                   </c:pt>
                   <c:pt idx="2">
-                    <c:v>Sierra Leone</c:v>
+                    <c:v>Tanzania</c:v>
                   </c:pt>
                   <c:pt idx="3">
-                    <c:v>Tanzania</c:v>
+                    <c:v>Uganda</c:v>
                   </c:pt>
                   <c:pt idx="4">
                     <c:v>Kenya</c:v>
@@ -2663,16 +2663,16 @@
                 <c:formatCode>General</c:formatCode>
                 <c:ptCount val="5"/>
                 <c:pt idx="0">
-                  <c:v>0</c:v>
+                  <c:v>378</c:v>
                 </c:pt>
                 <c:pt idx="1">
-                  <c:v>378</c:v>
+                  <c:v>850</c:v>
                 </c:pt>
                 <c:pt idx="2">
-                  <c:v>850</c:v>
+                  <c:v>1209</c:v>
                 </c:pt>
                 <c:pt idx="3">
-                  <c:v>1209</c:v>
+                  <c:v>1226</c:v>
                 </c:pt>
                 <c:pt idx="4">
                   <c:v>1456</c:v>
@@ -2938,10 +2938,10 @@
                 <c:ptCount val="5"/>
                 <c:lvl>
                   <c:pt idx="0">
-                    <c:v>Uganda</c:v>
+                    <c:v>Nigeria</c:v>
                   </c:pt>
                   <c:pt idx="1">
-                    <c:v>Nigeria</c:v>
+                    <c:v>Uganda</c:v>
                   </c:pt>
                   <c:pt idx="2">
                     <c:v>Sierra Leone</c:v>
@@ -2963,10 +2963,10 @@
                 <c:formatCode>General</c:formatCode>
                 <c:ptCount val="5"/>
                 <c:pt idx="0">
-                  <c:v>0</c:v>
+                  <c:v>88</c:v>
                 </c:pt>
                 <c:pt idx="1">
-                  <c:v>88</c:v>
+                  <c:v>111</c:v>
                 </c:pt>
                 <c:pt idx="2">
                   <c:v>127</c:v>
@@ -6318,7 +6318,7 @@
                           <a:ea typeface="Calibri" pitchFamily="34" charset="-122"/>
                           <a:cs typeface="Calibri" pitchFamily="34" charset="-120"/>
                         </a:rPr>
-                        <a:t>$-631,748</a:t>
+                        <a:t>$-431,748</a:t>
                       </a:r>
                       <a:endParaRPr lang="en-US" sz="1200" dirty="0">
                         <a:latin typeface="Calibri" charset="0"/>
@@ -6386,7 +6386,7 @@
                           <a:ea typeface="Calibri" pitchFamily="34" charset="-122"/>
                           <a:cs typeface="Calibri" pitchFamily="34" charset="-120"/>
                         </a:rPr>
-                        <a:t>$1,402,657</a:t>
+                        <a:t>$339,160</a:t>
                       </a:r>
                       <a:endParaRPr lang="en-US" sz="1200" dirty="0">
                         <a:latin typeface="Calibri" charset="0"/>
@@ -6454,7 +6454,7 @@
                           <a:ea typeface="Calibri" pitchFamily="34" charset="-122"/>
                           <a:cs typeface="Calibri" pitchFamily="34" charset="-120"/>
                         </a:rPr>
-                        <a:t>142.6%</a:t>
+                        <a:t>34.5%</a:t>
                       </a:r>
                       <a:endParaRPr lang="en-US" sz="1200" dirty="0">
                         <a:latin typeface="Calibri" charset="0"/>
@@ -6522,7 +6522,7 @@
                           <a:ea typeface="Calibri" pitchFamily="34" charset="-122"/>
                           <a:cs typeface="Calibri" pitchFamily="34" charset="-120"/>
                         </a:rPr>
-                        <a:t>$1,528,589</a:t>
+                        <a:t>$336,358</a:t>
                       </a:r>
                       <a:endParaRPr lang="en-US" sz="1200" dirty="0">
                         <a:latin typeface="Calibri" charset="0"/>
@@ -6796,7 +6796,7 @@
                           <a:ea typeface="Calibri" pitchFamily="34" charset="-122"/>
                           <a:cs typeface="Calibri" pitchFamily="34" charset="-120"/>
                         </a:rPr>
-                        <a:t>$-510,760</a:t>
+                        <a:t>$-404,204</a:t>
                       </a:r>
                       <a:endParaRPr lang="en-US" sz="1200" dirty="0">
                         <a:latin typeface="Calibri" charset="0"/>
@@ -6864,7 +6864,7 @@
                           <a:ea typeface="Calibri" pitchFamily="34" charset="-122"/>
                           <a:cs typeface="Calibri" pitchFamily="34" charset="-120"/>
                         </a:rPr>
-                        <a:t>$1,064,339</a:t>
+                        <a:t>$149,375</a:t>
                       </a:r>
                       <a:endParaRPr lang="en-US" sz="1200" dirty="0">
                         <a:latin typeface="Calibri" charset="0"/>
@@ -6932,7 +6932,7 @@
                           <a:ea typeface="Calibri" pitchFamily="34" charset="-122"/>
                           <a:cs typeface="Calibri" pitchFamily="34" charset="-120"/>
                         </a:rPr>
-                        <a:t>159.3%</a:t>
+                        <a:t>22.4%</a:t>
                       </a:r>
                       <a:endParaRPr lang="en-US" sz="1200" dirty="0">
                         <a:latin typeface="Calibri" charset="0"/>
@@ -7000,7 +7000,7 @@
                           <a:ea typeface="Calibri" pitchFamily="34" charset="-122"/>
                           <a:cs typeface="Calibri" pitchFamily="34" charset="-120"/>
                         </a:rPr>
-                        <a:t>$1,005,976</a:t>
+                        <a:t>$137,171</a:t>
                       </a:r>
                       <a:endParaRPr lang="en-US" sz="1200" dirty="0">
                         <a:latin typeface="Calibri" charset="0"/>
@@ -7274,7 +7274,7 @@
                           <a:ea typeface="Calibri" pitchFamily="34" charset="-122"/>
                           <a:cs typeface="Calibri" pitchFamily="34" charset="-120"/>
                         </a:rPr>
-                        <a:t>$-199,921</a:t>
+                        <a:t>$-135,235</a:t>
                       </a:r>
                       <a:endParaRPr lang="en-US" sz="1200" dirty="0">
                         <a:latin typeface="Calibri" charset="0"/>
@@ -7342,7 +7342,7 @@
                           <a:ea typeface="Calibri" pitchFamily="34" charset="-122"/>
                           <a:cs typeface="Calibri" pitchFamily="34" charset="-120"/>
                         </a:rPr>
-                        <a:t>$422,243</a:t>
+                        <a:t>$87,087</a:t>
                       </a:r>
                       <a:endParaRPr lang="en-US" sz="1200" dirty="0">
                         <a:latin typeface="Calibri" charset="0"/>
@@ -7410,7 +7410,7 @@
                           <a:ea typeface="Calibri" pitchFamily="34" charset="-122"/>
                           <a:cs typeface="Calibri" pitchFamily="34" charset="-120"/>
                         </a:rPr>
-                        <a:t>183.8%</a:t>
+                        <a:t>37.9%</a:t>
                       </a:r>
                       <a:endParaRPr lang="en-US" sz="1200" dirty="0">
                         <a:latin typeface="Calibri" charset="0"/>
@@ -7478,7 +7478,7 @@
                           <a:ea typeface="Calibri" pitchFamily="34" charset="-122"/>
                           <a:cs typeface="Calibri" pitchFamily="34" charset="-120"/>
                         </a:rPr>
-                        <a:t>$456,299</a:t>
+                        <a:t>$90,739</a:t>
                       </a:r>
                       <a:endParaRPr lang="en-US" sz="1200" dirty="0">
                         <a:latin typeface="Calibri" charset="0"/>
@@ -7526,6 +7526,484 @@
                     </a:lnB>
                     <a:solidFill>
                       <a:srgbClr val="FFFFFF"/>
+                    </a:solidFill>
+                  </a:tcPr>
+                </a:tc>
+              </a:tr>
+              <a:tr h="457200">
+                <a:tc>
+                  <a:txBody>
+                    <a:bodyPr/>
+                    <a:lstStyle/>
+                    <a:p>
+                      <a:pPr algn="l" indent="0" marL="0">
+                        <a:buNone/>
+                      </a:pPr>
+                      <a:r>
+                        <a:rPr lang="en-US" sz="1200" b="1" dirty="0">
+                          <a:solidFill>
+                            <a:srgbClr val="2D2A26"/>
+                          </a:solidFill>
+                          <a:latin typeface="Century Gothic" pitchFamily="34" charset="0"/>
+                          <a:ea typeface="Century Gothic" pitchFamily="34" charset="-122"/>
+                          <a:cs typeface="Century Gothic" pitchFamily="34" charset="-120"/>
+                        </a:rPr>
+                        <a:t>Uganda</a:t>
+                      </a:r>
+                      <a:endParaRPr lang="en-US" sz="1200" dirty="0">
+                        <a:latin typeface="Century Gothic" charset="0"/>
+                        <a:ea typeface="Century Gothic" charset="0"/>
+                        <a:cs typeface="Century Gothic" charset="0"/>
+                      </a:endParaRPr>
+                    </a:p>
+                  </a:txBody>
+                  <a:tcPr marL="91440" marR="91440" marT="45720" marB="45720" anchor="ctr">
+                    <a:lnL w="6350" cap="flat" cmpd="sng" algn="ctr">
+                      <a:solidFill>
+                        <a:srgbClr val="D6CFC4"/>
+                      </a:solidFill>
+                      <a:prstDash val="solid"/>
+                      <a:round/>
+                      <a:headEnd type="none" w="med" len="med"/>
+                      <a:tailEnd type="none" w="med" len="med"/>
+                    </a:lnL>
+                    <a:lnR w="6350" cap="flat" cmpd="sng" algn="ctr">
+                      <a:solidFill>
+                        <a:srgbClr val="D6CFC4"/>
+                      </a:solidFill>
+                      <a:prstDash val="solid"/>
+                      <a:round/>
+                      <a:headEnd type="none" w="med" len="med"/>
+                      <a:tailEnd type="none" w="med" len="med"/>
+                    </a:lnR>
+                    <a:lnT w="6350" cap="flat" cmpd="sng" algn="ctr">
+                      <a:solidFill>
+                        <a:srgbClr val="D6CFC4"/>
+                      </a:solidFill>
+                      <a:prstDash val="solid"/>
+                      <a:round/>
+                      <a:headEnd type="none" w="med" len="med"/>
+                      <a:tailEnd type="none" w="med" len="med"/>
+                    </a:lnT>
+                    <a:lnB w="6350" cap="flat" cmpd="sng" algn="ctr">
+                      <a:solidFill>
+                        <a:srgbClr val="D6CFC4"/>
+                      </a:solidFill>
+                      <a:prstDash val="solid"/>
+                      <a:round/>
+                      <a:headEnd type="none" w="med" len="med"/>
+                      <a:tailEnd type="none" w="med" len="med"/>
+                    </a:lnB>
+                    <a:solidFill>
+                      <a:srgbClr val="FAF7F2"/>
+                    </a:solidFill>
+                  </a:tcPr>
+                </a:tc>
+                <a:tc>
+                  <a:txBody>
+                    <a:bodyPr/>
+                    <a:lstStyle/>
+                    <a:p>
+                      <a:pPr algn="ctr" indent="0" marL="0">
+                        <a:buNone/>
+                      </a:pPr>
+                      <a:r>
+                        <a:rPr lang="en-US" sz="1200" dirty="0">
+                          <a:solidFill>
+                            <a:srgbClr val="2D2A26"/>
+                          </a:solidFill>
+                          <a:latin typeface="Calibri" pitchFamily="34" charset="0"/>
+                          <a:ea typeface="Calibri" pitchFamily="34" charset="-122"/>
+                          <a:cs typeface="Calibri" pitchFamily="34" charset="-120"/>
+                        </a:rPr>
+                        <a:t>$186,262</a:t>
+                      </a:r>
+                      <a:endParaRPr lang="en-US" sz="1200" dirty="0">
+                        <a:latin typeface="Calibri" charset="0"/>
+                        <a:ea typeface="Calibri" charset="0"/>
+                        <a:cs typeface="Calibri" charset="0"/>
+                      </a:endParaRPr>
+                    </a:p>
+                  </a:txBody>
+                  <a:tcPr marL="91440" marR="91440" marT="45720" marB="45720" anchor="ctr">
+                    <a:lnL w="6350" cap="flat" cmpd="sng" algn="ctr">
+                      <a:solidFill>
+                        <a:srgbClr val="D6CFC4"/>
+                      </a:solidFill>
+                      <a:prstDash val="solid"/>
+                      <a:round/>
+                      <a:headEnd type="none" w="med" len="med"/>
+                      <a:tailEnd type="none" w="med" len="med"/>
+                    </a:lnL>
+                    <a:lnR w="6350" cap="flat" cmpd="sng" algn="ctr">
+                      <a:solidFill>
+                        <a:srgbClr val="D6CFC4"/>
+                      </a:solidFill>
+                      <a:prstDash val="solid"/>
+                      <a:round/>
+                      <a:headEnd type="none" w="med" len="med"/>
+                      <a:tailEnd type="none" w="med" len="med"/>
+                    </a:lnR>
+                    <a:lnT w="6350" cap="flat" cmpd="sng" algn="ctr">
+                      <a:solidFill>
+                        <a:srgbClr val="D6CFC4"/>
+                      </a:solidFill>
+                      <a:prstDash val="solid"/>
+                      <a:round/>
+                      <a:headEnd type="none" w="med" len="med"/>
+                      <a:tailEnd type="none" w="med" len="med"/>
+                    </a:lnT>
+                    <a:lnB w="6350" cap="flat" cmpd="sng" algn="ctr">
+                      <a:solidFill>
+                        <a:srgbClr val="D6CFC4"/>
+                      </a:solidFill>
+                      <a:prstDash val="solid"/>
+                      <a:round/>
+                      <a:headEnd type="none" w="med" len="med"/>
+                      <a:tailEnd type="none" w="med" len="med"/>
+                    </a:lnB>
+                    <a:solidFill>
+                      <a:srgbClr val="FAF7F2"/>
+                    </a:solidFill>
+                  </a:tcPr>
+                </a:tc>
+                <a:tc>
+                  <a:txBody>
+                    <a:bodyPr/>
+                    <a:lstStyle/>
+                    <a:p>
+                      <a:pPr algn="ctr" indent="0" marL="0">
+                        <a:buNone/>
+                      </a:pPr>
+                      <a:r>
+                        <a:rPr lang="en-US" sz="1200" dirty="0">
+                          <a:solidFill>
+                            <a:srgbClr val="2D2A26"/>
+                          </a:solidFill>
+                          <a:latin typeface="Calibri" pitchFamily="34" charset="0"/>
+                          <a:ea typeface="Calibri" pitchFamily="34" charset="-122"/>
+                          <a:cs typeface="Calibri" pitchFamily="34" charset="-120"/>
+                        </a:rPr>
+                        <a:t>$-47,749</a:t>
+                      </a:r>
+                      <a:endParaRPr lang="en-US" sz="1200" dirty="0">
+                        <a:latin typeface="Calibri" charset="0"/>
+                        <a:ea typeface="Calibri" charset="0"/>
+                        <a:cs typeface="Calibri" charset="0"/>
+                      </a:endParaRPr>
+                    </a:p>
+                  </a:txBody>
+                  <a:tcPr marL="91440" marR="91440" marT="45720" marB="45720" anchor="ctr">
+                    <a:lnL w="6350" cap="flat" cmpd="sng" algn="ctr">
+                      <a:solidFill>
+                        <a:srgbClr val="D6CFC4"/>
+                      </a:solidFill>
+                      <a:prstDash val="solid"/>
+                      <a:round/>
+                      <a:headEnd type="none" w="med" len="med"/>
+                      <a:tailEnd type="none" w="med" len="med"/>
+                    </a:lnL>
+                    <a:lnR w="6350" cap="flat" cmpd="sng" algn="ctr">
+                      <a:solidFill>
+                        <a:srgbClr val="D6CFC4"/>
+                      </a:solidFill>
+                      <a:prstDash val="solid"/>
+                      <a:round/>
+                      <a:headEnd type="none" w="med" len="med"/>
+                      <a:tailEnd type="none" w="med" len="med"/>
+                    </a:lnR>
+                    <a:lnT w="6350" cap="flat" cmpd="sng" algn="ctr">
+                      <a:solidFill>
+                        <a:srgbClr val="D6CFC4"/>
+                      </a:solidFill>
+                      <a:prstDash val="solid"/>
+                      <a:round/>
+                      <a:headEnd type="none" w="med" len="med"/>
+                      <a:tailEnd type="none" w="med" len="med"/>
+                    </a:lnT>
+                    <a:lnB w="6350" cap="flat" cmpd="sng" algn="ctr">
+                      <a:solidFill>
+                        <a:srgbClr val="D6CFC4"/>
+                      </a:solidFill>
+                      <a:prstDash val="solid"/>
+                      <a:round/>
+                      <a:headEnd type="none" w="med" len="med"/>
+                      <a:tailEnd type="none" w="med" len="med"/>
+                    </a:lnB>
+                    <a:solidFill>
+                      <a:srgbClr val="FAF7F2"/>
+                    </a:solidFill>
+                  </a:tcPr>
+                </a:tc>
+                <a:tc>
+                  <a:txBody>
+                    <a:bodyPr/>
+                    <a:lstStyle/>
+                    <a:p>
+                      <a:pPr algn="ctr" indent="0" marL="0">
+                        <a:buNone/>
+                      </a:pPr>
+                      <a:r>
+                        <a:rPr lang="en-US" sz="1200" dirty="0">
+                          <a:solidFill>
+                            <a:srgbClr val="2D2A26"/>
+                          </a:solidFill>
+                          <a:latin typeface="Calibri" pitchFamily="34" charset="0"/>
+                          <a:ea typeface="Calibri" pitchFamily="34" charset="-122"/>
+                          <a:cs typeface="Calibri" pitchFamily="34" charset="-120"/>
+                        </a:rPr>
+                        <a:t>$-161,850</a:t>
+                      </a:r>
+                      <a:endParaRPr lang="en-US" sz="1200" dirty="0">
+                        <a:latin typeface="Calibri" charset="0"/>
+                        <a:ea typeface="Calibri" charset="0"/>
+                        <a:cs typeface="Calibri" charset="0"/>
+                      </a:endParaRPr>
+                    </a:p>
+                  </a:txBody>
+                  <a:tcPr marL="91440" marR="91440" marT="45720" marB="45720" anchor="ctr">
+                    <a:lnL w="6350" cap="flat" cmpd="sng" algn="ctr">
+                      <a:solidFill>
+                        <a:srgbClr val="D6CFC4"/>
+                      </a:solidFill>
+                      <a:prstDash val="solid"/>
+                      <a:round/>
+                      <a:headEnd type="none" w="med" len="med"/>
+                      <a:tailEnd type="none" w="med" len="med"/>
+                    </a:lnL>
+                    <a:lnR w="6350" cap="flat" cmpd="sng" algn="ctr">
+                      <a:solidFill>
+                        <a:srgbClr val="D6CFC4"/>
+                      </a:solidFill>
+                      <a:prstDash val="solid"/>
+                      <a:round/>
+                      <a:headEnd type="none" w="med" len="med"/>
+                      <a:tailEnd type="none" w="med" len="med"/>
+                    </a:lnR>
+                    <a:lnT w="6350" cap="flat" cmpd="sng" algn="ctr">
+                      <a:solidFill>
+                        <a:srgbClr val="D6CFC4"/>
+                      </a:solidFill>
+                      <a:prstDash val="solid"/>
+                      <a:round/>
+                      <a:headEnd type="none" w="med" len="med"/>
+                      <a:tailEnd type="none" w="med" len="med"/>
+                    </a:lnT>
+                    <a:lnB w="6350" cap="flat" cmpd="sng" algn="ctr">
+                      <a:solidFill>
+                        <a:srgbClr val="D6CFC4"/>
+                      </a:solidFill>
+                      <a:prstDash val="solid"/>
+                      <a:round/>
+                      <a:headEnd type="none" w="med" len="med"/>
+                      <a:tailEnd type="none" w="med" len="med"/>
+                    </a:lnB>
+                    <a:solidFill>
+                      <a:srgbClr val="FAF7F2"/>
+                    </a:solidFill>
+                  </a:tcPr>
+                </a:tc>
+                <a:tc>
+                  <a:txBody>
+                    <a:bodyPr/>
+                    <a:lstStyle/>
+                    <a:p>
+                      <a:pPr algn="ctr" indent="0" marL="0">
+                        <a:buNone/>
+                      </a:pPr>
+                      <a:r>
+                        <a:rPr lang="en-US" sz="1200" dirty="0">
+                          <a:solidFill>
+                            <a:srgbClr val="C0392B"/>
+                          </a:solidFill>
+                          <a:latin typeface="Calibri" pitchFamily="34" charset="0"/>
+                          <a:ea typeface="Calibri" pitchFamily="34" charset="-122"/>
+                          <a:cs typeface="Calibri" pitchFamily="34" charset="-120"/>
+                        </a:rPr>
+                        <a:t>$-23,337</a:t>
+                      </a:r>
+                      <a:endParaRPr lang="en-US" sz="1200" dirty="0">
+                        <a:latin typeface="Calibri" charset="0"/>
+                        <a:ea typeface="Calibri" charset="0"/>
+                        <a:cs typeface="Calibri" charset="0"/>
+                      </a:endParaRPr>
+                    </a:p>
+                  </a:txBody>
+                  <a:tcPr marL="91440" marR="91440" marT="45720" marB="45720" anchor="ctr">
+                    <a:lnL w="6350" cap="flat" cmpd="sng" algn="ctr">
+                      <a:solidFill>
+                        <a:srgbClr val="D6CFC4"/>
+                      </a:solidFill>
+                      <a:prstDash val="solid"/>
+                      <a:round/>
+                      <a:headEnd type="none" w="med" len="med"/>
+                      <a:tailEnd type="none" w="med" len="med"/>
+                    </a:lnL>
+                    <a:lnR w="6350" cap="flat" cmpd="sng" algn="ctr">
+                      <a:solidFill>
+                        <a:srgbClr val="D6CFC4"/>
+                      </a:solidFill>
+                      <a:prstDash val="solid"/>
+                      <a:round/>
+                      <a:headEnd type="none" w="med" len="med"/>
+                      <a:tailEnd type="none" w="med" len="med"/>
+                    </a:lnR>
+                    <a:lnT w="6350" cap="flat" cmpd="sng" algn="ctr">
+                      <a:solidFill>
+                        <a:srgbClr val="D6CFC4"/>
+                      </a:solidFill>
+                      <a:prstDash val="solid"/>
+                      <a:round/>
+                      <a:headEnd type="none" w="med" len="med"/>
+                      <a:tailEnd type="none" w="med" len="med"/>
+                    </a:lnT>
+                    <a:lnB w="6350" cap="flat" cmpd="sng" algn="ctr">
+                      <a:solidFill>
+                        <a:srgbClr val="D6CFC4"/>
+                      </a:solidFill>
+                      <a:prstDash val="solid"/>
+                      <a:round/>
+                      <a:headEnd type="none" w="med" len="med"/>
+                      <a:tailEnd type="none" w="med" len="med"/>
+                    </a:lnB>
+                    <a:solidFill>
+                      <a:srgbClr val="FAF7F2"/>
+                    </a:solidFill>
+                  </a:tcPr>
+                </a:tc>
+                <a:tc>
+                  <a:txBody>
+                    <a:bodyPr/>
+                    <a:lstStyle/>
+                    <a:p>
+                      <a:pPr algn="ctr" indent="0" marL="0">
+                        <a:buNone/>
+                      </a:pPr>
+                      <a:r>
+                        <a:rPr lang="en-US" sz="1200" dirty="0">
+                          <a:solidFill>
+                            <a:srgbClr val="C0392B"/>
+                          </a:solidFill>
+                          <a:latin typeface="Calibri" pitchFamily="34" charset="0"/>
+                          <a:ea typeface="Calibri" pitchFamily="34" charset="-122"/>
+                          <a:cs typeface="Calibri" pitchFamily="34" charset="-120"/>
+                        </a:rPr>
+                        <a:t>-12.5%</a:t>
+                      </a:r>
+                      <a:endParaRPr lang="en-US" sz="1200" dirty="0">
+                        <a:latin typeface="Calibri" charset="0"/>
+                        <a:ea typeface="Calibri" charset="0"/>
+                        <a:cs typeface="Calibri" charset="0"/>
+                      </a:endParaRPr>
+                    </a:p>
+                  </a:txBody>
+                  <a:tcPr marL="91440" marR="91440" marT="45720" marB="45720" anchor="ctr">
+                    <a:lnL w="6350" cap="flat" cmpd="sng" algn="ctr">
+                      <a:solidFill>
+                        <a:srgbClr val="D6CFC4"/>
+                      </a:solidFill>
+                      <a:prstDash val="solid"/>
+                      <a:round/>
+                      <a:headEnd type="none" w="med" len="med"/>
+                      <a:tailEnd type="none" w="med" len="med"/>
+                    </a:lnL>
+                    <a:lnR w="6350" cap="flat" cmpd="sng" algn="ctr">
+                      <a:solidFill>
+                        <a:srgbClr val="D6CFC4"/>
+                      </a:solidFill>
+                      <a:prstDash val="solid"/>
+                      <a:round/>
+                      <a:headEnd type="none" w="med" len="med"/>
+                      <a:tailEnd type="none" w="med" len="med"/>
+                    </a:lnR>
+                    <a:lnT w="6350" cap="flat" cmpd="sng" algn="ctr">
+                      <a:solidFill>
+                        <a:srgbClr val="D6CFC4"/>
+                      </a:solidFill>
+                      <a:prstDash val="solid"/>
+                      <a:round/>
+                      <a:headEnd type="none" w="med" len="med"/>
+                      <a:tailEnd type="none" w="med" len="med"/>
+                    </a:lnT>
+                    <a:lnB w="6350" cap="flat" cmpd="sng" algn="ctr">
+                      <a:solidFill>
+                        <a:srgbClr val="D6CFC4"/>
+                      </a:solidFill>
+                      <a:prstDash val="solid"/>
+                      <a:round/>
+                      <a:headEnd type="none" w="med" len="med"/>
+                      <a:tailEnd type="none" w="med" len="med"/>
+                    </a:lnB>
+                    <a:solidFill>
+                      <a:srgbClr val="FAF7F2"/>
+                    </a:solidFill>
+                  </a:tcPr>
+                </a:tc>
+                <a:tc>
+                  <a:txBody>
+                    <a:bodyPr/>
+                    <a:lstStyle/>
+                    <a:p>
+                      <a:pPr algn="ctr" indent="0" marL="0">
+                        <a:buNone/>
+                      </a:pPr>
+                      <a:r>
+                        <a:rPr lang="en-US" sz="1200" dirty="0">
+                          <a:solidFill>
+                            <a:srgbClr val="C0392B"/>
+                          </a:solidFill>
+                          <a:latin typeface="Calibri" pitchFamily="34" charset="0"/>
+                          <a:ea typeface="Calibri" pitchFamily="34" charset="-122"/>
+                          <a:cs typeface="Calibri" pitchFamily="34" charset="-120"/>
+                        </a:rPr>
+                        <a:t>$-421</a:t>
+                      </a:r>
+                      <a:endParaRPr lang="en-US" sz="1200" dirty="0">
+                        <a:latin typeface="Calibri" charset="0"/>
+                        <a:ea typeface="Calibri" charset="0"/>
+                        <a:cs typeface="Calibri" charset="0"/>
+                      </a:endParaRPr>
+                    </a:p>
+                  </a:txBody>
+                  <a:tcPr marL="91440" marR="91440" marT="45720" marB="45720" anchor="ctr">
+                    <a:lnL w="6350" cap="flat" cmpd="sng" algn="ctr">
+                      <a:solidFill>
+                        <a:srgbClr val="D6CFC4"/>
+                      </a:solidFill>
+                      <a:prstDash val="solid"/>
+                      <a:round/>
+                      <a:headEnd type="none" w="med" len="med"/>
+                      <a:tailEnd type="none" w="med" len="med"/>
+                    </a:lnL>
+                    <a:lnR w="6350" cap="flat" cmpd="sng" algn="ctr">
+                      <a:solidFill>
+                        <a:srgbClr val="D6CFC4"/>
+                      </a:solidFill>
+                      <a:prstDash val="solid"/>
+                      <a:round/>
+                      <a:headEnd type="none" w="med" len="med"/>
+                      <a:tailEnd type="none" w="med" len="med"/>
+                    </a:lnR>
+                    <a:lnT w="6350" cap="flat" cmpd="sng" algn="ctr">
+                      <a:solidFill>
+                        <a:srgbClr val="D6CFC4"/>
+                      </a:solidFill>
+                      <a:prstDash val="solid"/>
+                      <a:round/>
+                      <a:headEnd type="none" w="med" len="med"/>
+                      <a:tailEnd type="none" w="med" len="med"/>
+                    </a:lnT>
+                    <a:lnB w="6350" cap="flat" cmpd="sng" algn="ctr">
+                      <a:solidFill>
+                        <a:srgbClr val="D6CFC4"/>
+                      </a:solidFill>
+                      <a:prstDash val="solid"/>
+                      <a:round/>
+                      <a:headEnd type="none" w="med" len="med"/>
+                      <a:tailEnd type="none" w="med" len="med"/>
+                    </a:lnB>
+                    <a:solidFill>
+                      <a:srgbClr val="FAF7F2"/>
                     </a:solidFill>
                   </a:tcPr>
                 </a:tc>
@@ -7595,7 +8073,7 @@
                       <a:tailEnd type="none" w="med" len="med"/>
                     </a:lnB>
                     <a:solidFill>
-                      <a:srgbClr val="FAF7F2"/>
+                      <a:srgbClr val="FFFFFF"/>
                     </a:solidFill>
                   </a:tcPr>
                 </a:tc>
@@ -7663,7 +8141,7 @@
                       <a:tailEnd type="none" w="med" len="med"/>
                     </a:lnB>
                     <a:solidFill>
-                      <a:srgbClr val="FAF7F2"/>
+                      <a:srgbClr val="FFFFFF"/>
                     </a:solidFill>
                   </a:tcPr>
                 </a:tc>
@@ -7731,7 +8209,7 @@
                       <a:tailEnd type="none" w="med" len="med"/>
                     </a:lnB>
                     <a:solidFill>
-                      <a:srgbClr val="FAF7F2"/>
+                      <a:srgbClr val="FFFFFF"/>
                     </a:solidFill>
                   </a:tcPr>
                 </a:tc>
@@ -7799,7 +8277,7 @@
                       <a:tailEnd type="none" w="med" len="med"/>
                     </a:lnB>
                     <a:solidFill>
-                      <a:srgbClr val="FAF7F2"/>
+                      <a:srgbClr val="FFFFFF"/>
                     </a:solidFill>
                   </a:tcPr>
                 </a:tc>
@@ -7814,224 +8292,18 @@
                       <a:r>
                         <a:rPr lang="en-US" sz="1200" dirty="0">
                           <a:solidFill>
-                            <a:srgbClr val="2D2A26"/>
+                            <a:srgbClr val="C0392B"/>
                           </a:solidFill>
                           <a:latin typeface="Calibri" pitchFamily="34" charset="0"/>
                           <a:ea typeface="Calibri" pitchFamily="34" charset="-122"/>
                           <a:cs typeface="Calibri" pitchFamily="34" charset="-120"/>
                         </a:rPr>
-                        <a:t>$109,094</a:t>
+                        <a:t>$-56,151</a:t>
                       </a:r>
                       <a:endParaRPr lang="en-US" sz="1200" dirty="0">
                         <a:latin typeface="Calibri" charset="0"/>
                         <a:ea typeface="Calibri" charset="0"/>
                         <a:cs typeface="Calibri" charset="0"/>
-                      </a:endParaRPr>
-                    </a:p>
-                  </a:txBody>
-                  <a:tcPr marL="91440" marR="91440" marT="45720" marB="45720" anchor="ctr">
-                    <a:lnL w="6350" cap="flat" cmpd="sng" algn="ctr">
-                      <a:solidFill>
-                        <a:srgbClr val="D6CFC4"/>
-                      </a:solidFill>
-                      <a:prstDash val="solid"/>
-                      <a:round/>
-                      <a:headEnd type="none" w="med" len="med"/>
-                      <a:tailEnd type="none" w="med" len="med"/>
-                    </a:lnL>
-                    <a:lnR w="6350" cap="flat" cmpd="sng" algn="ctr">
-                      <a:solidFill>
-                        <a:srgbClr val="D6CFC4"/>
-                      </a:solidFill>
-                      <a:prstDash val="solid"/>
-                      <a:round/>
-                      <a:headEnd type="none" w="med" len="med"/>
-                      <a:tailEnd type="none" w="med" len="med"/>
-                    </a:lnR>
-                    <a:lnT w="6350" cap="flat" cmpd="sng" algn="ctr">
-                      <a:solidFill>
-                        <a:srgbClr val="D6CFC4"/>
-                      </a:solidFill>
-                      <a:prstDash val="solid"/>
-                      <a:round/>
-                      <a:headEnd type="none" w="med" len="med"/>
-                      <a:tailEnd type="none" w="med" len="med"/>
-                    </a:lnT>
-                    <a:lnB w="6350" cap="flat" cmpd="sng" algn="ctr">
-                      <a:solidFill>
-                        <a:srgbClr val="D6CFC4"/>
-                      </a:solidFill>
-                      <a:prstDash val="solid"/>
-                      <a:round/>
-                      <a:headEnd type="none" w="med" len="med"/>
-                      <a:tailEnd type="none" w="med" len="med"/>
-                    </a:lnB>
-                    <a:solidFill>
-                      <a:srgbClr val="FAF7F2"/>
-                    </a:solidFill>
-                  </a:tcPr>
-                </a:tc>
-                <a:tc>
-                  <a:txBody>
-                    <a:bodyPr/>
-                    <a:lstStyle/>
-                    <a:p>
-                      <a:pPr algn="ctr" indent="0" marL="0">
-                        <a:buNone/>
-                      </a:pPr>
-                      <a:r>
-                        <a:rPr lang="en-US" sz="1200" dirty="0">
-                          <a:solidFill>
-                            <a:srgbClr val="2D2A26"/>
-                          </a:solidFill>
-                          <a:latin typeface="Calibri" pitchFamily="34" charset="0"/>
-                          <a:ea typeface="Calibri" pitchFamily="34" charset="-122"/>
-                          <a:cs typeface="Calibri" pitchFamily="34" charset="-120"/>
-                        </a:rPr>
-                        <a:t>196.3%</a:t>
-                      </a:r>
-                      <a:endParaRPr lang="en-US" sz="1200" dirty="0">
-                        <a:latin typeface="Calibri" charset="0"/>
-                        <a:ea typeface="Calibri" charset="0"/>
-                        <a:cs typeface="Calibri" charset="0"/>
-                      </a:endParaRPr>
-                    </a:p>
-                  </a:txBody>
-                  <a:tcPr marL="91440" marR="91440" marT="45720" marB="45720" anchor="ctr">
-                    <a:lnL w="6350" cap="flat" cmpd="sng" algn="ctr">
-                      <a:solidFill>
-                        <a:srgbClr val="D6CFC4"/>
-                      </a:solidFill>
-                      <a:prstDash val="solid"/>
-                      <a:round/>
-                      <a:headEnd type="none" w="med" len="med"/>
-                      <a:tailEnd type="none" w="med" len="med"/>
-                    </a:lnL>
-                    <a:lnR w="6350" cap="flat" cmpd="sng" algn="ctr">
-                      <a:solidFill>
-                        <a:srgbClr val="D6CFC4"/>
-                      </a:solidFill>
-                      <a:prstDash val="solid"/>
-                      <a:round/>
-                      <a:headEnd type="none" w="med" len="med"/>
-                      <a:tailEnd type="none" w="med" len="med"/>
-                    </a:lnR>
-                    <a:lnT w="6350" cap="flat" cmpd="sng" algn="ctr">
-                      <a:solidFill>
-                        <a:srgbClr val="D6CFC4"/>
-                      </a:solidFill>
-                      <a:prstDash val="solid"/>
-                      <a:round/>
-                      <a:headEnd type="none" w="med" len="med"/>
-                      <a:tailEnd type="none" w="med" len="med"/>
-                    </a:lnT>
-                    <a:lnB w="6350" cap="flat" cmpd="sng" algn="ctr">
-                      <a:solidFill>
-                        <a:srgbClr val="D6CFC4"/>
-                      </a:solidFill>
-                      <a:prstDash val="solid"/>
-                      <a:round/>
-                      <a:headEnd type="none" w="med" len="med"/>
-                      <a:tailEnd type="none" w="med" len="med"/>
-                    </a:lnB>
-                    <a:solidFill>
-                      <a:srgbClr val="FAF7F2"/>
-                    </a:solidFill>
-                  </a:tcPr>
-                </a:tc>
-                <a:tc>
-                  <a:txBody>
-                    <a:bodyPr/>
-                    <a:lstStyle/>
-                    <a:p>
-                      <a:pPr algn="ctr" indent="0" marL="0">
-                        <a:buNone/>
-                      </a:pPr>
-                      <a:r>
-                        <a:rPr lang="en-US" sz="1200" dirty="0">
-                          <a:solidFill>
-                            <a:srgbClr val="2D2A26"/>
-                          </a:solidFill>
-                          <a:latin typeface="Calibri" pitchFamily="34" charset="0"/>
-                          <a:ea typeface="Calibri" pitchFamily="34" charset="-122"/>
-                          <a:cs typeface="Calibri" pitchFamily="34" charset="-120"/>
-                        </a:rPr>
-                        <a:t>$105,341</a:t>
-                      </a:r>
-                      <a:endParaRPr lang="en-US" sz="1200" dirty="0">
-                        <a:latin typeface="Calibri" charset="0"/>
-                        <a:ea typeface="Calibri" charset="0"/>
-                        <a:cs typeface="Calibri" charset="0"/>
-                      </a:endParaRPr>
-                    </a:p>
-                  </a:txBody>
-                  <a:tcPr marL="91440" marR="91440" marT="45720" marB="45720" anchor="ctr">
-                    <a:lnL w="6350" cap="flat" cmpd="sng" algn="ctr">
-                      <a:solidFill>
-                        <a:srgbClr val="D6CFC4"/>
-                      </a:solidFill>
-                      <a:prstDash val="solid"/>
-                      <a:round/>
-                      <a:headEnd type="none" w="med" len="med"/>
-                      <a:tailEnd type="none" w="med" len="med"/>
-                    </a:lnL>
-                    <a:lnR w="6350" cap="flat" cmpd="sng" algn="ctr">
-                      <a:solidFill>
-                        <a:srgbClr val="D6CFC4"/>
-                      </a:solidFill>
-                      <a:prstDash val="solid"/>
-                      <a:round/>
-                      <a:headEnd type="none" w="med" len="med"/>
-                      <a:tailEnd type="none" w="med" len="med"/>
-                    </a:lnR>
-                    <a:lnT w="6350" cap="flat" cmpd="sng" algn="ctr">
-                      <a:solidFill>
-                        <a:srgbClr val="D6CFC4"/>
-                      </a:solidFill>
-                      <a:prstDash val="solid"/>
-                      <a:round/>
-                      <a:headEnd type="none" w="med" len="med"/>
-                      <a:tailEnd type="none" w="med" len="med"/>
-                    </a:lnT>
-                    <a:lnB w="6350" cap="flat" cmpd="sng" algn="ctr">
-                      <a:solidFill>
-                        <a:srgbClr val="D6CFC4"/>
-                      </a:solidFill>
-                      <a:prstDash val="solid"/>
-                      <a:round/>
-                      <a:headEnd type="none" w="med" len="med"/>
-                      <a:tailEnd type="none" w="med" len="med"/>
-                    </a:lnB>
-                    <a:solidFill>
-                      <a:srgbClr val="FAF7F2"/>
-                    </a:solidFill>
-                  </a:tcPr>
-                </a:tc>
-              </a:tr>
-              <a:tr h="457200">
-                <a:tc>
-                  <a:txBody>
-                    <a:bodyPr/>
-                    <a:lstStyle/>
-                    <a:p>
-                      <a:pPr algn="l" indent="0" marL="0">
-                        <a:buNone/>
-                      </a:pPr>
-                      <a:r>
-                        <a:rPr lang="en-US" sz="1200" b="1" dirty="0">
-                          <a:solidFill>
-                            <a:srgbClr val="2D2A26"/>
-                          </a:solidFill>
-                          <a:latin typeface="Century Gothic" pitchFamily="34" charset="0"/>
-                          <a:ea typeface="Century Gothic" pitchFamily="34" charset="-122"/>
-                          <a:cs typeface="Century Gothic" pitchFamily="34" charset="-120"/>
-                        </a:rPr>
-                        <a:t>Uganda</a:t>
-                      </a:r>
-                      <a:endParaRPr lang="en-US" sz="1200" dirty="0">
-                        <a:latin typeface="Century Gothic" charset="0"/>
-                        <a:ea typeface="Century Gothic" charset="0"/>
-                        <a:cs typeface="Century Gothic" charset="0"/>
                       </a:endParaRPr>
                     </a:p>
                   </a:txBody>
@@ -8088,13 +8360,13 @@
                       <a:r>
                         <a:rPr lang="en-US" sz="1200" dirty="0">
                           <a:solidFill>
-                            <a:srgbClr val="2D2A26"/>
+                            <a:srgbClr val="C0392B"/>
                           </a:solidFill>
                           <a:latin typeface="Calibri" pitchFamily="34" charset="0"/>
                           <a:ea typeface="Calibri" pitchFamily="34" charset="-122"/>
                           <a:cs typeface="Calibri" pitchFamily="34" charset="-120"/>
                         </a:rPr>
-                        <a:t>—</a:t>
+                        <a:t>-101.0%</a:t>
                       </a:r>
                       <a:endParaRPr lang="en-US" sz="1200" dirty="0">
                         <a:latin typeface="Calibri" charset="0"/>
@@ -8156,285 +8428,13 @@
                       <a:r>
                         <a:rPr lang="en-US" sz="1200" dirty="0">
                           <a:solidFill>
-                            <a:srgbClr val="2D2A26"/>
+                            <a:srgbClr val="C0392B"/>
                           </a:solidFill>
                           <a:latin typeface="Calibri" pitchFamily="34" charset="0"/>
                           <a:ea typeface="Calibri" pitchFamily="34" charset="-122"/>
                           <a:cs typeface="Calibri" pitchFamily="34" charset="-120"/>
                         </a:rPr>
-                        <a:t>—</a:t>
-                      </a:r>
-                      <a:endParaRPr lang="en-US" sz="1200" dirty="0">
-                        <a:latin typeface="Calibri" charset="0"/>
-                        <a:ea typeface="Calibri" charset="0"/>
-                        <a:cs typeface="Calibri" charset="0"/>
-                      </a:endParaRPr>
-                    </a:p>
-                  </a:txBody>
-                  <a:tcPr marL="91440" marR="91440" marT="45720" marB="45720" anchor="ctr">
-                    <a:lnL w="6350" cap="flat" cmpd="sng" algn="ctr">
-                      <a:solidFill>
-                        <a:srgbClr val="D6CFC4"/>
-                      </a:solidFill>
-                      <a:prstDash val="solid"/>
-                      <a:round/>
-                      <a:headEnd type="none" w="med" len="med"/>
-                      <a:tailEnd type="none" w="med" len="med"/>
-                    </a:lnL>
-                    <a:lnR w="6350" cap="flat" cmpd="sng" algn="ctr">
-                      <a:solidFill>
-                        <a:srgbClr val="D6CFC4"/>
-                      </a:solidFill>
-                      <a:prstDash val="solid"/>
-                      <a:round/>
-                      <a:headEnd type="none" w="med" len="med"/>
-                      <a:tailEnd type="none" w="med" len="med"/>
-                    </a:lnR>
-                    <a:lnT w="6350" cap="flat" cmpd="sng" algn="ctr">
-                      <a:solidFill>
-                        <a:srgbClr val="D6CFC4"/>
-                      </a:solidFill>
-                      <a:prstDash val="solid"/>
-                      <a:round/>
-                      <a:headEnd type="none" w="med" len="med"/>
-                      <a:tailEnd type="none" w="med" len="med"/>
-                    </a:lnT>
-                    <a:lnB w="6350" cap="flat" cmpd="sng" algn="ctr">
-                      <a:solidFill>
-                        <a:srgbClr val="D6CFC4"/>
-                      </a:solidFill>
-                      <a:prstDash val="solid"/>
-                      <a:round/>
-                      <a:headEnd type="none" w="med" len="med"/>
-                      <a:tailEnd type="none" w="med" len="med"/>
-                    </a:lnB>
-                    <a:solidFill>
-                      <a:srgbClr val="FFFFFF"/>
-                    </a:solidFill>
-                  </a:tcPr>
-                </a:tc>
-                <a:tc>
-                  <a:txBody>
-                    <a:bodyPr/>
-                    <a:lstStyle/>
-                    <a:p>
-                      <a:pPr algn="ctr" indent="0" marL="0">
-                        <a:buNone/>
-                      </a:pPr>
-                      <a:r>
-                        <a:rPr lang="en-US" sz="1200" dirty="0">
-                          <a:solidFill>
-                            <a:srgbClr val="2D2A26"/>
-                          </a:solidFill>
-                          <a:latin typeface="Calibri" pitchFamily="34" charset="0"/>
-                          <a:ea typeface="Calibri" pitchFamily="34" charset="-122"/>
-                          <a:cs typeface="Calibri" pitchFamily="34" charset="-120"/>
-                        </a:rPr>
-                        <a:t>—</a:t>
-                      </a:r>
-                      <a:endParaRPr lang="en-US" sz="1200" dirty="0">
-                        <a:latin typeface="Calibri" charset="0"/>
-                        <a:ea typeface="Calibri" charset="0"/>
-                        <a:cs typeface="Calibri" charset="0"/>
-                      </a:endParaRPr>
-                    </a:p>
-                  </a:txBody>
-                  <a:tcPr marL="91440" marR="91440" marT="45720" marB="45720" anchor="ctr">
-                    <a:lnL w="6350" cap="flat" cmpd="sng" algn="ctr">
-                      <a:solidFill>
-                        <a:srgbClr val="D6CFC4"/>
-                      </a:solidFill>
-                      <a:prstDash val="solid"/>
-                      <a:round/>
-                      <a:headEnd type="none" w="med" len="med"/>
-                      <a:tailEnd type="none" w="med" len="med"/>
-                    </a:lnL>
-                    <a:lnR w="6350" cap="flat" cmpd="sng" algn="ctr">
-                      <a:solidFill>
-                        <a:srgbClr val="D6CFC4"/>
-                      </a:solidFill>
-                      <a:prstDash val="solid"/>
-                      <a:round/>
-                      <a:headEnd type="none" w="med" len="med"/>
-                      <a:tailEnd type="none" w="med" len="med"/>
-                    </a:lnR>
-                    <a:lnT w="6350" cap="flat" cmpd="sng" algn="ctr">
-                      <a:solidFill>
-                        <a:srgbClr val="D6CFC4"/>
-                      </a:solidFill>
-                      <a:prstDash val="solid"/>
-                      <a:round/>
-                      <a:headEnd type="none" w="med" len="med"/>
-                      <a:tailEnd type="none" w="med" len="med"/>
-                    </a:lnT>
-                    <a:lnB w="6350" cap="flat" cmpd="sng" algn="ctr">
-                      <a:solidFill>
-                        <a:srgbClr val="D6CFC4"/>
-                      </a:solidFill>
-                      <a:prstDash val="solid"/>
-                      <a:round/>
-                      <a:headEnd type="none" w="med" len="med"/>
-                      <a:tailEnd type="none" w="med" len="med"/>
-                    </a:lnB>
-                    <a:solidFill>
-                      <a:srgbClr val="FFFFFF"/>
-                    </a:solidFill>
-                  </a:tcPr>
-                </a:tc>
-                <a:tc>
-                  <a:txBody>
-                    <a:bodyPr/>
-                    <a:lstStyle/>
-                    <a:p>
-                      <a:pPr algn="ctr" indent="0" marL="0">
-                        <a:buNone/>
-                      </a:pPr>
-                      <a:r>
-                        <a:rPr lang="en-US" sz="1200" dirty="0">
-                          <a:solidFill>
-                            <a:srgbClr val="2D2A26"/>
-                          </a:solidFill>
-                          <a:latin typeface="Calibri" pitchFamily="34" charset="0"/>
-                          <a:ea typeface="Calibri" pitchFamily="34" charset="-122"/>
-                          <a:cs typeface="Calibri" pitchFamily="34" charset="-120"/>
-                        </a:rPr>
-                        <a:t>—</a:t>
-                      </a:r>
-                      <a:endParaRPr lang="en-US" sz="1200" dirty="0">
-                        <a:latin typeface="Calibri" charset="0"/>
-                        <a:ea typeface="Calibri" charset="0"/>
-                        <a:cs typeface="Calibri" charset="0"/>
-                      </a:endParaRPr>
-                    </a:p>
-                  </a:txBody>
-                  <a:tcPr marL="91440" marR="91440" marT="45720" marB="45720" anchor="ctr">
-                    <a:lnL w="6350" cap="flat" cmpd="sng" algn="ctr">
-                      <a:solidFill>
-                        <a:srgbClr val="D6CFC4"/>
-                      </a:solidFill>
-                      <a:prstDash val="solid"/>
-                      <a:round/>
-                      <a:headEnd type="none" w="med" len="med"/>
-                      <a:tailEnd type="none" w="med" len="med"/>
-                    </a:lnL>
-                    <a:lnR w="6350" cap="flat" cmpd="sng" algn="ctr">
-                      <a:solidFill>
-                        <a:srgbClr val="D6CFC4"/>
-                      </a:solidFill>
-                      <a:prstDash val="solid"/>
-                      <a:round/>
-                      <a:headEnd type="none" w="med" len="med"/>
-                      <a:tailEnd type="none" w="med" len="med"/>
-                    </a:lnR>
-                    <a:lnT w="6350" cap="flat" cmpd="sng" algn="ctr">
-                      <a:solidFill>
-                        <a:srgbClr val="D6CFC4"/>
-                      </a:solidFill>
-                      <a:prstDash val="solid"/>
-                      <a:round/>
-                      <a:headEnd type="none" w="med" len="med"/>
-                      <a:tailEnd type="none" w="med" len="med"/>
-                    </a:lnT>
-                    <a:lnB w="6350" cap="flat" cmpd="sng" algn="ctr">
-                      <a:solidFill>
-                        <a:srgbClr val="D6CFC4"/>
-                      </a:solidFill>
-                      <a:prstDash val="solid"/>
-                      <a:round/>
-                      <a:headEnd type="none" w="med" len="med"/>
-                      <a:tailEnd type="none" w="med" len="med"/>
-                    </a:lnB>
-                    <a:solidFill>
-                      <a:srgbClr val="FFFFFF"/>
-                    </a:solidFill>
-                  </a:tcPr>
-                </a:tc>
-                <a:tc>
-                  <a:txBody>
-                    <a:bodyPr/>
-                    <a:lstStyle/>
-                    <a:p>
-                      <a:pPr algn="ctr" indent="0" marL="0">
-                        <a:buNone/>
-                      </a:pPr>
-                      <a:r>
-                        <a:rPr lang="en-US" sz="1200" dirty="0">
-                          <a:solidFill>
-                            <a:srgbClr val="2D2A26"/>
-                          </a:solidFill>
-                          <a:latin typeface="Calibri" pitchFamily="34" charset="0"/>
-                          <a:ea typeface="Calibri" pitchFamily="34" charset="-122"/>
-                          <a:cs typeface="Calibri" pitchFamily="34" charset="-120"/>
-                        </a:rPr>
-                        <a:t>N/M</a:t>
-                      </a:r>
-                      <a:endParaRPr lang="en-US" sz="1200" dirty="0">
-                        <a:latin typeface="Calibri" charset="0"/>
-                        <a:ea typeface="Calibri" charset="0"/>
-                        <a:cs typeface="Calibri" charset="0"/>
-                      </a:endParaRPr>
-                    </a:p>
-                  </a:txBody>
-                  <a:tcPr marL="91440" marR="91440" marT="45720" marB="45720" anchor="ctr">
-                    <a:lnL w="6350" cap="flat" cmpd="sng" algn="ctr">
-                      <a:solidFill>
-                        <a:srgbClr val="D6CFC4"/>
-                      </a:solidFill>
-                      <a:prstDash val="solid"/>
-                      <a:round/>
-                      <a:headEnd type="none" w="med" len="med"/>
-                      <a:tailEnd type="none" w="med" len="med"/>
-                    </a:lnL>
-                    <a:lnR w="6350" cap="flat" cmpd="sng" algn="ctr">
-                      <a:solidFill>
-                        <a:srgbClr val="D6CFC4"/>
-                      </a:solidFill>
-                      <a:prstDash val="solid"/>
-                      <a:round/>
-                      <a:headEnd type="none" w="med" len="med"/>
-                      <a:tailEnd type="none" w="med" len="med"/>
-                    </a:lnR>
-                    <a:lnT w="6350" cap="flat" cmpd="sng" algn="ctr">
-                      <a:solidFill>
-                        <a:srgbClr val="D6CFC4"/>
-                      </a:solidFill>
-                      <a:prstDash val="solid"/>
-                      <a:round/>
-                      <a:headEnd type="none" w="med" len="med"/>
-                      <a:tailEnd type="none" w="med" len="med"/>
-                    </a:lnT>
-                    <a:lnB w="6350" cap="flat" cmpd="sng" algn="ctr">
-                      <a:solidFill>
-                        <a:srgbClr val="D6CFC4"/>
-                      </a:solidFill>
-                      <a:prstDash val="solid"/>
-                      <a:round/>
-                      <a:headEnd type="none" w="med" len="med"/>
-                      <a:tailEnd type="none" w="med" len="med"/>
-                    </a:lnB>
-                    <a:solidFill>
-                      <a:srgbClr val="FFFFFF"/>
-                    </a:solidFill>
-                  </a:tcPr>
-                </a:tc>
-                <a:tc>
-                  <a:txBody>
-                    <a:bodyPr/>
-                    <a:lstStyle/>
-                    <a:p>
-                      <a:pPr algn="ctr" indent="0" marL="0">
-                        <a:buNone/>
-                      </a:pPr>
-                      <a:r>
-                        <a:rPr lang="en-US" sz="1200" dirty="0">
-                          <a:solidFill>
-                            <a:srgbClr val="2D2A26"/>
-                          </a:solidFill>
-                          <a:latin typeface="Calibri" pitchFamily="34" charset="0"/>
-                          <a:ea typeface="Calibri" pitchFamily="34" charset="-122"/>
-                          <a:cs typeface="Calibri" pitchFamily="34" charset="-120"/>
-                        </a:rPr>
-                        <a:t>—</a:t>
+                        <a:t>$-65,698</a:t>
                       </a:r>
                       <a:endParaRPr lang="en-US" sz="1200" dirty="0">
                         <a:latin typeface="Calibri" charset="0"/>
@@ -8572,7 +8572,7 @@
                           <a:ea typeface="Calibri" pitchFamily="34" charset="-122"/>
                           <a:cs typeface="Calibri" pitchFamily="34" charset="-120"/>
                         </a:rPr>
-                        <a:t>$1,937,394</a:t>
+                        <a:t>$2,123,656</a:t>
                       </a:r>
                       <a:endParaRPr lang="en-US" sz="1200" dirty="0">
                         <a:latin typeface="Calibri" charset="0"/>
@@ -8640,7 +8640,7 @@
                           <a:ea typeface="Calibri" pitchFamily="34" charset="-122"/>
                           <a:cs typeface="Calibri" pitchFamily="34" charset="-120"/>
                         </a:rPr>
-                        <a:t>$-364,113</a:t>
+                        <a:t>$-411,861</a:t>
                       </a:r>
                       <a:endParaRPr lang="en-US" sz="1200" dirty="0">
                         <a:latin typeface="Calibri" charset="0"/>
@@ -8708,7 +8708,7 @@
                           <a:ea typeface="Calibri" pitchFamily="34" charset="-122"/>
                           <a:cs typeface="Calibri" pitchFamily="34" charset="-120"/>
                         </a:rPr>
-                        <a:t>$-1,425,052</a:t>
+                        <a:t>$-1,215,660</a:t>
                       </a:r>
                       <a:endParaRPr lang="en-US" sz="1200" dirty="0">
                         <a:latin typeface="Calibri" charset="0"/>
@@ -8776,7 +8776,7 @@
                           <a:ea typeface="Calibri" pitchFamily="34" charset="-122"/>
                           <a:cs typeface="Calibri" pitchFamily="34" charset="-120"/>
                         </a:rPr>
-                        <a:t>$2,998,333</a:t>
+                        <a:t>$496,135</a:t>
                       </a:r>
                       <a:endParaRPr lang="en-US" sz="1200" dirty="0">
                         <a:latin typeface="Calibri" charset="0"/>
@@ -8844,7 +8844,7 @@
                           <a:ea typeface="Calibri" pitchFamily="34" charset="-122"/>
                           <a:cs typeface="Calibri" pitchFamily="34" charset="-120"/>
                         </a:rPr>
-                        <a:t>154.8%</a:t>
+                        <a:t>23.4%</a:t>
                       </a:r>
                       <a:endParaRPr lang="en-US" sz="1200" dirty="0">
                         <a:latin typeface="Calibri" charset="0"/>
@@ -8912,7 +8912,7 @@
                           <a:ea typeface="Calibri" pitchFamily="34" charset="-122"/>
                           <a:cs typeface="Calibri" pitchFamily="34" charset="-120"/>
                         </a:rPr>
-                        <a:t>$3,096,205</a:t>
+                        <a:t>$498,150</a:t>
                       </a:r>
                       <a:endParaRPr lang="en-US" sz="1200" dirty="0">
                         <a:latin typeface="Calibri" charset="0"/>
@@ -9097,7 +9097,7 @@
                 <a:ea typeface="Century Gothic" pitchFamily="34" charset="-122"/>
                 <a:cs typeface="Century Gothic" pitchFamily="34" charset="-120"/>
               </a:rPr>
-              <a:t>$1,937,394</a:t>
+              <a:t>$2,123,656</a:t>
             </a:r>
             <a:endParaRPr lang="en-US" sz="2600" dirty="0"/>
           </a:p>
@@ -9232,7 +9232,7 @@
                 <a:ea typeface="Century Gothic" pitchFamily="34" charset="-122"/>
                 <a:cs typeface="Century Gothic" pitchFamily="34" charset="-120"/>
               </a:rPr>
-              <a:t>$2,998,333</a:t>
+              <a:t>$496,135</a:t>
             </a:r>
             <a:endParaRPr lang="en-US" sz="2600" dirty="0"/>
           </a:p>
@@ -9367,7 +9367,7 @@
                 <a:ea typeface="Century Gothic" pitchFamily="34" charset="-122"/>
                 <a:cs typeface="Century Gothic" pitchFamily="34" charset="-120"/>
               </a:rPr>
-              <a:t>154.8%</a:t>
+              <a:t>23.4%</a:t>
             </a:r>
             <a:endParaRPr lang="en-US" sz="2600" dirty="0"/>
           </a:p>
@@ -9850,45 +9850,6 @@
             <a:r>
               <a:rPr lang="en-US" sz="1200" b="1" dirty="0">
                 <a:solidFill>
-                  <a:srgbClr val="718096"/>
-                </a:solidFill>
-                <a:latin typeface="Calibri" pitchFamily="34" charset="0"/>
-                <a:ea typeface="Calibri" pitchFamily="34" charset="-122"/>
-                <a:cs typeface="Calibri" pitchFamily="34" charset="-120"/>
-              </a:rPr>
-              <a:t>—</a:t>
-            </a:r>
-            <a:endParaRPr lang="en-US" sz="1200" dirty="0"/>
-          </a:p>
-        </p:txBody>
-      </p:sp>
-      <p:sp>
-        <p:nvSpPr>
-          <p:cNvPr id="16" name="Text 13"/>
-          <p:cNvSpPr/>
-          <p:nvPr/>
-        </p:nvSpPr>
-        <p:spPr>
-          <a:xfrm>
-            <a:off x="2514600" y="5943600"/>
-            <a:ext cx="2377440" cy="347472"/>
-          </a:xfrm>
-          <a:prstGeom prst="rect">
-            <a:avLst/>
-          </a:prstGeom>
-          <a:noFill/>
-          <a:ln/>
-        </p:spPr>
-        <p:txBody>
-          <a:bodyPr wrap="square" rtlCol="0" anchor="ctr"/>
-          <a:lstStyle/>
-          <a:p>
-            <a:pPr algn="ctr" indent="0" marL="0">
-              <a:buNone/>
-            </a:pPr>
-            <a:r>
-              <a:rPr lang="en-US" sz="1200" b="1" dirty="0">
-                <a:solidFill>
                   <a:srgbClr val="C0392B"/>
                 </a:solidFill>
                 <a:latin typeface="Calibri" pitchFamily="34" charset="0"/>
@@ -9903,13 +9864,13 @@
       </p:sp>
       <p:sp>
         <p:nvSpPr>
-          <p:cNvPr id="17" name="Text 14"/>
-          <p:cNvSpPr/>
-          <p:nvPr/>
-        </p:nvSpPr>
-        <p:spPr>
-          <a:xfrm>
-            <a:off x="4892040" y="5943600"/>
+          <p:cNvPr id="16" name="Text 13"/>
+          <p:cNvSpPr/>
+          <p:nvPr/>
+        </p:nvSpPr>
+        <p:spPr>
+          <a:xfrm>
+            <a:off x="2514600" y="5943600"/>
             <a:ext cx="2377440" cy="347472"/>
           </a:xfrm>
           <a:prstGeom prst="rect">
@@ -9942,13 +9903,13 @@
       </p:sp>
       <p:sp>
         <p:nvSpPr>
-          <p:cNvPr id="18" name="Text 15"/>
-          <p:cNvSpPr/>
-          <p:nvPr/>
-        </p:nvSpPr>
-        <p:spPr>
-          <a:xfrm>
-            <a:off x="7269480" y="5943600"/>
+          <p:cNvPr id="17" name="Text 14"/>
+          <p:cNvSpPr/>
+          <p:nvPr/>
+        </p:nvSpPr>
+        <p:spPr>
+          <a:xfrm>
+            <a:off x="4892040" y="5943600"/>
             <a:ext cx="2377440" cy="347472"/>
           </a:xfrm>
           <a:prstGeom prst="rect">
@@ -9974,6 +9935,45 @@
                 <a:cs typeface="Calibri" pitchFamily="34" charset="-120"/>
               </a:rPr>
               <a:t>-2.8%</a:t>
+            </a:r>
+            <a:endParaRPr lang="en-US" sz="1200" dirty="0"/>
+          </a:p>
+        </p:txBody>
+      </p:sp>
+      <p:sp>
+        <p:nvSpPr>
+          <p:cNvPr id="18" name="Text 15"/>
+          <p:cNvSpPr/>
+          <p:nvPr/>
+        </p:nvSpPr>
+        <p:spPr>
+          <a:xfrm>
+            <a:off x="7269480" y="5943600"/>
+            <a:ext cx="2377440" cy="347472"/>
+          </a:xfrm>
+          <a:prstGeom prst="rect">
+            <a:avLst/>
+          </a:prstGeom>
+          <a:noFill/>
+          <a:ln/>
+        </p:spPr>
+        <p:txBody>
+          <a:bodyPr wrap="square" rtlCol="0" anchor="ctr"/>
+          <a:lstStyle/>
+          <a:p>
+            <a:pPr algn="ctr" indent="0" marL="0">
+              <a:buNone/>
+            </a:pPr>
+            <a:r>
+              <a:rPr lang="en-US" sz="1200" b="1" dirty="0">
+                <a:solidFill>
+                  <a:srgbClr val="C0392B"/>
+                </a:solidFill>
+                <a:latin typeface="Calibri" pitchFamily="34" charset="0"/>
+                <a:ea typeface="Calibri" pitchFamily="34" charset="-122"/>
+                <a:cs typeface="Calibri" pitchFamily="34" charset="-120"/>
+              </a:rPr>
+              <a:t>+9.3%</a:t>
             </a:r>
             <a:endParaRPr lang="en-US" sz="1200" dirty="0"/>
           </a:p>
@@ -10456,45 +10456,6 @@
             <a:r>
               <a:rPr lang="en-US" sz="1200" b="1" dirty="0">
                 <a:solidFill>
-                  <a:srgbClr val="718096"/>
-                </a:solidFill>
-                <a:latin typeface="Calibri" pitchFamily="34" charset="0"/>
-                <a:ea typeface="Calibri" pitchFamily="34" charset="-122"/>
-                <a:cs typeface="Calibri" pitchFamily="34" charset="-120"/>
-              </a:rPr>
-              <a:t>—</a:t>
-            </a:r>
-            <a:endParaRPr lang="en-US" sz="1200" dirty="0"/>
-          </a:p>
-        </p:txBody>
-      </p:sp>
-      <p:sp>
-        <p:nvSpPr>
-          <p:cNvPr id="16" name="Text 13"/>
-          <p:cNvSpPr/>
-          <p:nvPr/>
-        </p:nvSpPr>
-        <p:spPr>
-          <a:xfrm>
-            <a:off x="2514600" y="5486400"/>
-            <a:ext cx="2377440" cy="347472"/>
-          </a:xfrm>
-          <a:prstGeom prst="rect">
-            <a:avLst/>
-          </a:prstGeom>
-          <a:noFill/>
-          <a:ln/>
-        </p:spPr>
-        <p:txBody>
-          <a:bodyPr wrap="square" rtlCol="0" anchor="ctr"/>
-          <a:lstStyle/>
-          <a:p>
-            <a:pPr algn="ctr" indent="0" marL="0">
-              <a:buNone/>
-            </a:pPr>
-            <a:r>
-              <a:rPr lang="en-US" sz="1200" b="1" dirty="0">
-                <a:solidFill>
                   <a:srgbClr val="C0392B"/>
                 </a:solidFill>
                 <a:latin typeface="Calibri" pitchFamily="34" charset="0"/>
@@ -10502,6 +10463,45 @@
                 <a:cs typeface="Calibri" pitchFamily="34" charset="-120"/>
               </a:rPr>
               <a:t>+3.5%</a:t>
+            </a:r>
+            <a:endParaRPr lang="en-US" sz="1200" dirty="0"/>
+          </a:p>
+        </p:txBody>
+      </p:sp>
+      <p:sp>
+        <p:nvSpPr>
+          <p:cNvPr id="16" name="Text 13"/>
+          <p:cNvSpPr/>
+          <p:nvPr/>
+        </p:nvSpPr>
+        <p:spPr>
+          <a:xfrm>
+            <a:off x="2514600" y="5486400"/>
+            <a:ext cx="2377440" cy="347472"/>
+          </a:xfrm>
+          <a:prstGeom prst="rect">
+            <a:avLst/>
+          </a:prstGeom>
+          <a:noFill/>
+          <a:ln/>
+        </p:spPr>
+        <p:txBody>
+          <a:bodyPr wrap="square" rtlCol="0" anchor="ctr"/>
+          <a:lstStyle/>
+          <a:p>
+            <a:pPr algn="ctr" indent="0" marL="0">
+              <a:buNone/>
+            </a:pPr>
+            <a:r>
+              <a:rPr lang="en-US" sz="1200" b="1" dirty="0">
+                <a:solidFill>
+                  <a:srgbClr val="1A7A6E"/>
+                </a:solidFill>
+                <a:latin typeface="Calibri" pitchFamily="34" charset="0"/>
+                <a:ea typeface="Calibri" pitchFamily="34" charset="-122"/>
+                <a:cs typeface="Calibri" pitchFamily="34" charset="-120"/>
+              </a:rPr>
+              <a:t>-3.5%</a:t>
             </a:r>
             <a:endParaRPr lang="en-US" sz="1200" dirty="0"/>
           </a:p>
@@ -10740,45 +10740,6 @@
             <a:r>
               <a:rPr lang="en-US" sz="1200" b="1" dirty="0">
                 <a:solidFill>
-                  <a:srgbClr val="718096"/>
-                </a:solidFill>
-                <a:latin typeface="Calibri" pitchFamily="34" charset="0"/>
-                <a:ea typeface="Calibri" pitchFamily="34" charset="-122"/>
-                <a:cs typeface="Calibri" pitchFamily="34" charset="-120"/>
-              </a:rPr>
-              <a:t>—</a:t>
-            </a:r>
-            <a:endParaRPr lang="en-US" sz="1200" dirty="0"/>
-          </a:p>
-        </p:txBody>
-      </p:sp>
-      <p:sp>
-        <p:nvSpPr>
-          <p:cNvPr id="24" name="Text 21"/>
-          <p:cNvSpPr/>
-          <p:nvPr/>
-        </p:nvSpPr>
-        <p:spPr>
-          <a:xfrm>
-            <a:off x="2514600" y="6199632"/>
-            <a:ext cx="2377440" cy="347472"/>
-          </a:xfrm>
-          <a:prstGeom prst="rect">
-            <a:avLst/>
-          </a:prstGeom>
-          <a:noFill/>
-          <a:ln/>
-        </p:spPr>
-        <p:txBody>
-          <a:bodyPr wrap="square" rtlCol="0" anchor="ctr"/>
-          <a:lstStyle/>
-          <a:p>
-            <a:pPr algn="ctr" indent="0" marL="0">
-              <a:buNone/>
-            </a:pPr>
-            <a:r>
-              <a:rPr lang="en-US" sz="1200" b="1" dirty="0">
-                <a:solidFill>
                   <a:srgbClr val="1A7A6E"/>
                 </a:solidFill>
                 <a:latin typeface="Calibri" pitchFamily="34" charset="0"/>
@@ -10786,6 +10747,45 @@
                 <a:cs typeface="Calibri" pitchFamily="34" charset="-120"/>
               </a:rPr>
               <a:t>+24.5%</a:t>
+            </a:r>
+            <a:endParaRPr lang="en-US" sz="1200" dirty="0"/>
+          </a:p>
+        </p:txBody>
+      </p:sp>
+      <p:sp>
+        <p:nvSpPr>
+          <p:cNvPr id="24" name="Text 21"/>
+          <p:cNvSpPr/>
+          <p:nvPr/>
+        </p:nvSpPr>
+        <p:spPr>
+          <a:xfrm>
+            <a:off x="2514600" y="6199632"/>
+            <a:ext cx="2377440" cy="347472"/>
+          </a:xfrm>
+          <a:prstGeom prst="rect">
+            <a:avLst/>
+          </a:prstGeom>
+          <a:noFill/>
+          <a:ln/>
+        </p:spPr>
+        <p:txBody>
+          <a:bodyPr wrap="square" rtlCol="0" anchor="ctr"/>
+          <a:lstStyle/>
+          <a:p>
+            <a:pPr algn="ctr" indent="0" marL="0">
+              <a:buNone/>
+            </a:pPr>
+            <a:r>
+              <a:rPr lang="en-US" sz="1200" b="1" dirty="0">
+                <a:solidFill>
+                  <a:srgbClr val="C0392B"/>
+                </a:solidFill>
+                <a:latin typeface="Calibri" pitchFamily="34" charset="0"/>
+                <a:ea typeface="Calibri" pitchFamily="34" charset="-122"/>
+                <a:cs typeface="Calibri" pitchFamily="34" charset="-120"/>
+              </a:rPr>
+              <a:t>-18.1%</a:t>
             </a:r>
             <a:endParaRPr lang="en-US" sz="1200" dirty="0"/>
           </a:p>
@@ -11630,13 +11630,13 @@
             <a:r>
               <a:rPr lang="en-US" sz="1200" b="1" dirty="0">
                 <a:solidFill>
-                  <a:srgbClr val="718096"/>
+                  <a:srgbClr val="C0392B"/>
                 </a:solidFill>
                 <a:latin typeface="Calibri" pitchFamily="34" charset="0"/>
                 <a:ea typeface="Calibri" pitchFamily="34" charset="-122"/>
                 <a:cs typeface="Calibri" pitchFamily="34" charset="-120"/>
               </a:rPr>
-              <a:t>—</a:t>
+              <a:t>-18.1%</a:t>
             </a:r>
             <a:endParaRPr lang="en-US" sz="1200" dirty="0"/>
           </a:p>
@@ -12281,6 +12281,45 @@
                 <a:ea typeface="Calibri" pitchFamily="34" charset="-122"/>
                 <a:cs typeface="Calibri" pitchFamily="34" charset="-120"/>
               </a:rPr>
+              <a:t>+0.0%</a:t>
+            </a:r>
+            <a:endParaRPr lang="en-US" sz="1200" dirty="0"/>
+          </a:p>
+        </p:txBody>
+      </p:sp>
+      <p:sp>
+        <p:nvSpPr>
+          <p:cNvPr id="17" name="Text 14"/>
+          <p:cNvSpPr/>
+          <p:nvPr/>
+        </p:nvSpPr>
+        <p:spPr>
+          <a:xfrm>
+            <a:off x="3172968" y="5925312"/>
+            <a:ext cx="1517904" cy="347472"/>
+          </a:xfrm>
+          <a:prstGeom prst="rect">
+            <a:avLst/>
+          </a:prstGeom>
+          <a:noFill/>
+          <a:ln/>
+        </p:spPr>
+        <p:txBody>
+          <a:bodyPr wrap="square" rtlCol="0" anchor="ctr"/>
+          <a:lstStyle/>
+          <a:p>
+            <a:pPr algn="ctr" indent="0" marL="0">
+              <a:buNone/>
+            </a:pPr>
+            <a:r>
+              <a:rPr lang="en-US" sz="1200" b="1" dirty="0">
+                <a:solidFill>
+                  <a:srgbClr val="C0392B"/>
+                </a:solidFill>
+                <a:latin typeface="Calibri" pitchFamily="34" charset="0"/>
+                <a:ea typeface="Calibri" pitchFamily="34" charset="-122"/>
+                <a:cs typeface="Calibri" pitchFamily="34" charset="-120"/>
+              </a:rPr>
               <a:t>-13.8%</a:t>
             </a:r>
             <a:endParaRPr lang="en-US" sz="1200" dirty="0"/>
@@ -12289,13 +12328,13 @@
       </p:sp>
       <p:sp>
         <p:nvSpPr>
-          <p:cNvPr id="17" name="Text 14"/>
-          <p:cNvSpPr/>
-          <p:nvPr/>
-        </p:nvSpPr>
-        <p:spPr>
-          <a:xfrm>
-            <a:off x="3172968" y="5925312"/>
+          <p:cNvPr id="18" name="Text 15"/>
+          <p:cNvSpPr/>
+          <p:nvPr/>
+        </p:nvSpPr>
+        <p:spPr>
+          <a:xfrm>
+            <a:off x="4690872" y="5925312"/>
             <a:ext cx="1517904" cy="347472"/>
           </a:xfrm>
           <a:prstGeom prst="rect">
@@ -12328,13 +12367,13 @@
       </p:sp>
       <p:sp>
         <p:nvSpPr>
-          <p:cNvPr id="18" name="Text 15"/>
-          <p:cNvSpPr/>
-          <p:nvPr/>
-        </p:nvSpPr>
-        <p:spPr>
-          <a:xfrm>
-            <a:off x="4690872" y="5925312"/>
+          <p:cNvPr id="19" name="Text 16"/>
+          <p:cNvSpPr/>
+          <p:nvPr/>
+        </p:nvSpPr>
+        <p:spPr>
+          <a:xfrm>
+            <a:off x="6208776" y="5925312"/>
             <a:ext cx="1517904" cy="347472"/>
           </a:xfrm>
           <a:prstGeom prst="rect">
@@ -12360,45 +12399,6 @@
                 <a:cs typeface="Calibri" pitchFamily="34" charset="-120"/>
               </a:rPr>
               <a:t>-21.6%</a:t>
-            </a:r>
-            <a:endParaRPr lang="en-US" sz="1200" dirty="0"/>
-          </a:p>
-        </p:txBody>
-      </p:sp>
-      <p:sp>
-        <p:nvSpPr>
-          <p:cNvPr id="19" name="Text 16"/>
-          <p:cNvSpPr/>
-          <p:nvPr/>
-        </p:nvSpPr>
-        <p:spPr>
-          <a:xfrm>
-            <a:off x="6208776" y="5925312"/>
-            <a:ext cx="1517904" cy="347472"/>
-          </a:xfrm>
-          <a:prstGeom prst="rect">
-            <a:avLst/>
-          </a:prstGeom>
-          <a:noFill/>
-          <a:ln/>
-        </p:spPr>
-        <p:txBody>
-          <a:bodyPr wrap="square" rtlCol="0" anchor="ctr"/>
-          <a:lstStyle/>
-          <a:p>
-            <a:pPr algn="ctr" indent="0" marL="0">
-              <a:buNone/>
-            </a:pPr>
-            <a:r>
-              <a:rPr lang="en-US" sz="1200" b="1" dirty="0">
-                <a:solidFill>
-                  <a:srgbClr val="718096"/>
-                </a:solidFill>
-                <a:latin typeface="Calibri" pitchFamily="34" charset="0"/>
-                <a:ea typeface="Calibri" pitchFamily="34" charset="-122"/>
-                <a:cs typeface="Calibri" pitchFamily="34" charset="-120"/>
-              </a:rPr>
-              <a:t>—</a:t>
             </a:r>
             <a:endParaRPr lang="en-US" sz="1200" dirty="0"/>
           </a:p>
@@ -12494,7 +12494,7 @@
                 <a:ea typeface="Century Gothic" pitchFamily="34" charset="-122"/>
                 <a:cs typeface="Century Gothic" pitchFamily="34" charset="-120"/>
               </a:rPr>
-              <a:t>21,231</a:t>
+              <a:t>24,035</a:t>
             </a:r>
             <a:endParaRPr lang="en-US" sz="2600" dirty="0"/>
           </a:p>
@@ -12931,7 +12931,7 @@
                 <a:ea typeface="Calibri" pitchFamily="34" charset="-122"/>
                 <a:cs typeface="Calibri" pitchFamily="34" charset="-120"/>
               </a:rPr>
-              <a:t>Group total: 21,231 applications (-12.7% vs prior month).</a:t>
+              <a:t>Group total: 24,035 applications (-11.4% vs prior month).</a:t>
             </a:r>
             <a:endParaRPr lang="en-US" sz="1200" dirty="0"/>
           </a:p>
@@ -13548,13 +13548,13 @@
             <a:r>
               <a:rPr lang="en-US" sz="1200" b="1" dirty="0">
                 <a:solidFill>
-                  <a:srgbClr val="718096"/>
+                  <a:srgbClr val="C0392B"/>
                 </a:solidFill>
                 <a:latin typeface="Calibri" pitchFamily="34" charset="0"/>
                 <a:ea typeface="Calibri" pitchFamily="34" charset="-122"/>
                 <a:cs typeface="Calibri" pitchFamily="34" charset="-120"/>
               </a:rPr>
-              <a:t>—</a:t>
+              <a:t>↓</a:t>
             </a:r>
             <a:endParaRPr lang="en-US" sz="1200" dirty="0"/>
           </a:p>
@@ -13650,7 +13650,7 @@
                 <a:ea typeface="Century Gothic" pitchFamily="34" charset="-122"/>
                 <a:cs typeface="Century Gothic" pitchFamily="34" charset="-120"/>
               </a:rPr>
-              <a:t>19,270</a:t>
+              <a:t>21,791</a:t>
             </a:r>
             <a:endParaRPr lang="en-US" sz="2600" dirty="0"/>
           </a:p>
@@ -13785,7 +13785,7 @@
                 <a:ea typeface="Century Gothic" pitchFamily="34" charset="-122"/>
                 <a:cs typeface="Century Gothic" pitchFamily="34" charset="-120"/>
               </a:rPr>
-              <a:t>90.8%</a:t>
+              <a:t>90.7%</a:t>
             </a:r>
             <a:endParaRPr lang="en-US" sz="2600" dirty="0"/>
           </a:p>
@@ -14087,7 +14087,7 @@
                 <a:ea typeface="Calibri" pitchFamily="34" charset="-122"/>
                 <a:cs typeface="Calibri" pitchFamily="34" charset="-120"/>
               </a:rPr>
-              <a:t>Group total approvals: 19,270.</a:t>
+              <a:t>Group total approvals: 21,791.</a:t>
             </a:r>
             <a:endParaRPr lang="en-US" sz="1200" dirty="0"/>
           </a:p>
@@ -14548,6 +14548,45 @@
             <a:r>
               <a:rPr lang="en-US" sz="1200" b="1" dirty="0">
                 <a:solidFill>
+                  <a:srgbClr val="1A7A6E"/>
+                </a:solidFill>
+                <a:latin typeface="Calibri" pitchFamily="34" charset="0"/>
+                <a:ea typeface="Calibri" pitchFamily="34" charset="-122"/>
+                <a:cs typeface="Calibri" pitchFamily="34" charset="-120"/>
+              </a:rPr>
+              <a:t>+355244.0%</a:t>
+            </a:r>
+            <a:endParaRPr lang="en-US" sz="1200" dirty="0"/>
+          </a:p>
+        </p:txBody>
+      </p:sp>
+      <p:sp>
+        <p:nvSpPr>
+          <p:cNvPr id="16" name="Text 13"/>
+          <p:cNvSpPr/>
+          <p:nvPr/>
+        </p:nvSpPr>
+        <p:spPr>
+          <a:xfrm>
+            <a:off x="1655064" y="5925312"/>
+            <a:ext cx="1517904" cy="347472"/>
+          </a:xfrm>
+          <a:prstGeom prst="rect">
+            <a:avLst/>
+          </a:prstGeom>
+          <a:noFill/>
+          <a:ln/>
+        </p:spPr>
+        <p:txBody>
+          <a:bodyPr wrap="square" rtlCol="0" anchor="ctr"/>
+          <a:lstStyle/>
+          <a:p>
+            <a:pPr algn="ctr" indent="0" marL="0">
+              <a:buNone/>
+            </a:pPr>
+            <a:r>
+              <a:rPr lang="en-US" sz="1200" b="1" dirty="0">
+                <a:solidFill>
                   <a:srgbClr val="C0392B"/>
                 </a:solidFill>
                 <a:latin typeface="Calibri" pitchFamily="34" charset="0"/>
@@ -14562,13 +14601,13 @@
       </p:sp>
       <p:sp>
         <p:nvSpPr>
-          <p:cNvPr id="16" name="Text 13"/>
-          <p:cNvSpPr/>
-          <p:nvPr/>
-        </p:nvSpPr>
-        <p:spPr>
-          <a:xfrm>
-            <a:off x="1655064" y="5925312"/>
+          <p:cNvPr id="17" name="Text 14"/>
+          <p:cNvSpPr/>
+          <p:nvPr/>
+        </p:nvSpPr>
+        <p:spPr>
+          <a:xfrm>
+            <a:off x="3172968" y="5925312"/>
             <a:ext cx="1517904" cy="347472"/>
           </a:xfrm>
           <a:prstGeom prst="rect">
@@ -14601,13 +14640,13 @@
       </p:sp>
       <p:sp>
         <p:nvSpPr>
-          <p:cNvPr id="17" name="Text 14"/>
-          <p:cNvSpPr/>
-          <p:nvPr/>
-        </p:nvSpPr>
-        <p:spPr>
-          <a:xfrm>
-            <a:off x="3172968" y="5925312"/>
+          <p:cNvPr id="18" name="Text 15"/>
+          <p:cNvSpPr/>
+          <p:nvPr/>
+        </p:nvSpPr>
+        <p:spPr>
+          <a:xfrm>
+            <a:off x="4690872" y="5925312"/>
             <a:ext cx="1517904" cy="347472"/>
           </a:xfrm>
           <a:prstGeom prst="rect">
@@ -14640,13 +14679,13 @@
       </p:sp>
       <p:sp>
         <p:nvSpPr>
-          <p:cNvPr id="18" name="Text 15"/>
-          <p:cNvSpPr/>
-          <p:nvPr/>
-        </p:nvSpPr>
-        <p:spPr>
-          <a:xfrm>
-            <a:off x="4690872" y="5925312"/>
+          <p:cNvPr id="19" name="Text 16"/>
+          <p:cNvSpPr/>
+          <p:nvPr/>
+        </p:nvSpPr>
+        <p:spPr>
+          <a:xfrm>
+            <a:off x="6208776" y="5925312"/>
             <a:ext cx="1517904" cy="347472"/>
           </a:xfrm>
           <a:prstGeom prst="rect">
@@ -14672,45 +14711,6 @@
                 <a:cs typeface="Calibri" pitchFamily="34" charset="-120"/>
               </a:rPr>
               <a:t>-14.5%</a:t>
-            </a:r>
-            <a:endParaRPr lang="en-US" sz="1200" dirty="0"/>
-          </a:p>
-        </p:txBody>
-      </p:sp>
-      <p:sp>
-        <p:nvSpPr>
-          <p:cNvPr id="19" name="Text 16"/>
-          <p:cNvSpPr/>
-          <p:nvPr/>
-        </p:nvSpPr>
-        <p:spPr>
-          <a:xfrm>
-            <a:off x="6208776" y="5925312"/>
-            <a:ext cx="1517904" cy="347472"/>
-          </a:xfrm>
-          <a:prstGeom prst="rect">
-            <a:avLst/>
-          </a:prstGeom>
-          <a:noFill/>
-          <a:ln/>
-        </p:spPr>
-        <p:txBody>
-          <a:bodyPr wrap="square" rtlCol="0" anchor="ctr"/>
-          <a:lstStyle/>
-          <a:p>
-            <a:pPr algn="ctr" indent="0" marL="0">
-              <a:buNone/>
-            </a:pPr>
-            <a:r>
-              <a:rPr lang="en-US" sz="1200" b="1" dirty="0">
-                <a:solidFill>
-                  <a:srgbClr val="718096"/>
-                </a:solidFill>
-                <a:latin typeface="Calibri" pitchFamily="34" charset="0"/>
-                <a:ea typeface="Calibri" pitchFamily="34" charset="-122"/>
-                <a:cs typeface="Calibri" pitchFamily="34" charset="-120"/>
-              </a:rPr>
-              <a:t>—</a:t>
             </a:r>
             <a:endParaRPr lang="en-US" sz="1200" dirty="0"/>
           </a:p>
@@ -14806,7 +14806,7 @@
                 <a:ea typeface="Century Gothic" pitchFamily="34" charset="-122"/>
                 <a:cs typeface="Century Gothic" pitchFamily="34" charset="-120"/>
               </a:rPr>
-              <a:t>$5,093,051</a:t>
+              <a:t>$1,963,743,051</a:t>
             </a:r>
             <a:endParaRPr lang="en-US" sz="2600" dirty="0"/>
           </a:p>
@@ -14941,7 +14941,7 @@
                 <a:ea typeface="Century Gothic" pitchFamily="34" charset="-122"/>
                 <a:cs typeface="Century Gothic" pitchFamily="34" charset="-120"/>
               </a:rPr>
-              <a:t>-9.7%</a:t>
+              <a:t>+31627.6%</a:t>
             </a:r>
             <a:endParaRPr lang="en-US" sz="2600" dirty="0"/>
           </a:p>
@@ -15268,6 +15268,109 @@
                 <a:ea typeface="Calibri" pitchFamily="34" charset="-122"/>
                 <a:cs typeface="Calibri" pitchFamily="34" charset="-120"/>
               </a:rPr>
+              <a:t>Uganda</a:t>
+            </a:r>
+            <a:endParaRPr lang="en-US" sz="1100" dirty="0"/>
+          </a:p>
+        </p:txBody>
+      </p:sp>
+      <p:sp>
+        <p:nvSpPr>
+          <p:cNvPr id="37" name="Text 34"/>
+          <p:cNvSpPr/>
+          <p:nvPr/>
+        </p:nvSpPr>
+        <p:spPr>
+          <a:xfrm>
+            <a:off x="7955280" y="4261104"/>
+            <a:ext cx="1234440" cy="292608"/>
+          </a:xfrm>
+          <a:prstGeom prst="rect">
+            <a:avLst/>
+          </a:prstGeom>
+          <a:noFill/>
+          <a:ln/>
+        </p:spPr>
+        <p:txBody>
+          <a:bodyPr wrap="square" rtlCol="0" anchor="ctr"/>
+          <a:lstStyle/>
+          <a:p>
+            <a:pPr algn="ctr" indent="0" marL="0">
+              <a:buNone/>
+            </a:pPr>
+            <a:r>
+              <a:rPr lang="en-US" sz="1100" b="1" dirty="0">
+                <a:solidFill>
+                  <a:srgbClr val="5D300F"/>
+                </a:solidFill>
+                <a:latin typeface="Century Gothic" pitchFamily="34" charset="0"/>
+                <a:ea typeface="Century Gothic" pitchFamily="34" charset="-122"/>
+                <a:cs typeface="Century Gothic" pitchFamily="34" charset="-120"/>
+              </a:rPr>
+              <a:t>38</a:t>
+            </a:r>
+            <a:endParaRPr lang="en-US" sz="1100" dirty="0"/>
+          </a:p>
+        </p:txBody>
+      </p:sp>
+      <p:sp>
+        <p:nvSpPr>
+          <p:cNvPr id="38" name="Shape 35"/>
+          <p:cNvSpPr/>
+          <p:nvPr/>
+        </p:nvSpPr>
+        <p:spPr>
+          <a:xfrm>
+            <a:off x="9308592" y="4023360"/>
+            <a:ext cx="1234440" cy="530352"/>
+          </a:xfrm>
+          <a:prstGeom prst="rect">
+            <a:avLst/>
+          </a:prstGeom>
+          <a:solidFill>
+            <a:srgbClr val="FFF9D9"/>
+          </a:solidFill>
+          <a:ln w="12700">
+            <a:solidFill>
+              <a:srgbClr val="D6CFC4"/>
+            </a:solidFill>
+            <a:prstDash val="solid"/>
+          </a:ln>
+        </p:spPr>
+      </p:sp>
+      <p:sp>
+        <p:nvSpPr>
+          <p:cNvPr id="39" name="Text 36"/>
+          <p:cNvSpPr/>
+          <p:nvPr/>
+        </p:nvSpPr>
+        <p:spPr>
+          <a:xfrm>
+            <a:off x="9308592" y="4023360"/>
+            <a:ext cx="1234440" cy="237744"/>
+          </a:xfrm>
+          <a:prstGeom prst="rect">
+            <a:avLst/>
+          </a:prstGeom>
+          <a:noFill/>
+          <a:ln/>
+        </p:spPr>
+        <p:txBody>
+          <a:bodyPr wrap="square" rtlCol="0" anchor="b"/>
+          <a:lstStyle/>
+          <a:p>
+            <a:pPr algn="ctr" indent="0" marL="0">
+              <a:buNone/>
+            </a:pPr>
+            <a:r>
+              <a:rPr lang="en-US" sz="1100" dirty="0">
+                <a:solidFill>
+                  <a:srgbClr val="718096"/>
+                </a:solidFill>
+                <a:latin typeface="Calibri" pitchFamily="34" charset="0"/>
+                <a:ea typeface="Calibri" pitchFamily="34" charset="-122"/>
+                <a:cs typeface="Calibri" pitchFamily="34" charset="-120"/>
+              </a:rPr>
               <a:t>Tanzania</a:t>
             </a:r>
             <a:endParaRPr lang="en-US" sz="1100" dirty="0"/>
@@ -15276,13 +15379,13 @@
       </p:sp>
       <p:sp>
         <p:nvSpPr>
-          <p:cNvPr id="37" name="Text 34"/>
-          <p:cNvSpPr/>
-          <p:nvPr/>
-        </p:nvSpPr>
-        <p:spPr>
-          <a:xfrm>
-            <a:off x="7955280" y="4261104"/>
+          <p:cNvPr id="40" name="Text 37"/>
+          <p:cNvSpPr/>
+          <p:nvPr/>
+        </p:nvSpPr>
+        <p:spPr>
+          <a:xfrm>
+            <a:off x="9308592" y="4261104"/>
             <a:ext cx="1234440" cy="292608"/>
           </a:xfrm>
           <a:prstGeom prst="rect">
@@ -15315,13 +15418,13 @@
       </p:sp>
       <p:sp>
         <p:nvSpPr>
-          <p:cNvPr id="38" name="Shape 35"/>
-          <p:cNvSpPr/>
-          <p:nvPr/>
-        </p:nvSpPr>
-        <p:spPr>
-          <a:xfrm>
-            <a:off x="9308592" y="4023360"/>
+          <p:cNvPr id="41" name="Shape 38"/>
+          <p:cNvSpPr/>
+          <p:nvPr/>
+        </p:nvSpPr>
+        <p:spPr>
+          <a:xfrm>
+            <a:off x="10661904" y="4023360"/>
             <a:ext cx="1234440" cy="530352"/>
           </a:xfrm>
           <a:prstGeom prst="rect">
@@ -15340,13 +15443,13 @@
       </p:sp>
       <p:sp>
         <p:nvSpPr>
-          <p:cNvPr id="39" name="Text 36"/>
-          <p:cNvSpPr/>
-          <p:nvPr/>
-        </p:nvSpPr>
-        <p:spPr>
-          <a:xfrm>
-            <a:off x="9308592" y="4023360"/>
+          <p:cNvPr id="42" name="Text 39"/>
+          <p:cNvSpPr/>
+          <p:nvPr/>
+        </p:nvSpPr>
+        <p:spPr>
+          <a:xfrm>
+            <a:off x="10661904" y="4023360"/>
             <a:ext cx="1234440" cy="237744"/>
           </a:xfrm>
           <a:prstGeom prst="rect">
@@ -15379,13 +15482,13 @@
       </p:sp>
       <p:sp>
         <p:nvSpPr>
-          <p:cNvPr id="40" name="Text 37"/>
-          <p:cNvSpPr/>
-          <p:nvPr/>
-        </p:nvSpPr>
-        <p:spPr>
-          <a:xfrm>
-            <a:off x="9308592" y="4261104"/>
+          <p:cNvPr id="43" name="Text 40"/>
+          <p:cNvSpPr/>
+          <p:nvPr/>
+        </p:nvSpPr>
+        <p:spPr>
+          <a:xfrm>
+            <a:off x="10661904" y="4261104"/>
             <a:ext cx="1234440" cy="292608"/>
           </a:xfrm>
           <a:prstGeom prst="rect">
@@ -15418,13 +15521,13 @@
       </p:sp>
       <p:sp>
         <p:nvSpPr>
-          <p:cNvPr id="41" name="Shape 38"/>
-          <p:cNvSpPr/>
-          <p:nvPr/>
-        </p:nvSpPr>
-        <p:spPr>
-          <a:xfrm>
-            <a:off x="10661904" y="4023360"/>
+          <p:cNvPr id="44" name="Shape 41"/>
+          <p:cNvSpPr/>
+          <p:nvPr/>
+        </p:nvSpPr>
+        <p:spPr>
+          <a:xfrm>
+            <a:off x="7955280" y="4617720"/>
             <a:ext cx="1234440" cy="530352"/>
           </a:xfrm>
           <a:prstGeom prst="rect">
@@ -15443,13 +15546,13 @@
       </p:sp>
       <p:sp>
         <p:nvSpPr>
-          <p:cNvPr id="42" name="Text 39"/>
-          <p:cNvSpPr/>
-          <p:nvPr/>
-        </p:nvSpPr>
-        <p:spPr>
-          <a:xfrm>
-            <a:off x="10661904" y="4023360"/>
+          <p:cNvPr id="45" name="Text 42"/>
+          <p:cNvSpPr/>
+          <p:nvPr/>
+        </p:nvSpPr>
+        <p:spPr>
+          <a:xfrm>
+            <a:off x="7955280" y="4617720"/>
             <a:ext cx="1234440" cy="237744"/>
           </a:xfrm>
           <a:prstGeom prst="rect">
@@ -15482,13 +15585,13 @@
       </p:sp>
       <p:sp>
         <p:nvSpPr>
-          <p:cNvPr id="43" name="Text 40"/>
-          <p:cNvSpPr/>
-          <p:nvPr/>
-        </p:nvSpPr>
-        <p:spPr>
-          <a:xfrm>
-            <a:off x="10661904" y="4261104"/>
+          <p:cNvPr id="46" name="Text 43"/>
+          <p:cNvSpPr/>
+          <p:nvPr/>
+        </p:nvSpPr>
+        <p:spPr>
+          <a:xfrm>
+            <a:off x="7955280" y="4855464"/>
             <a:ext cx="1234440" cy="292608"/>
           </a:xfrm>
           <a:prstGeom prst="rect">
@@ -15521,13 +15624,13 @@
       </p:sp>
       <p:sp>
         <p:nvSpPr>
-          <p:cNvPr id="44" name="Shape 41"/>
-          <p:cNvSpPr/>
-          <p:nvPr/>
-        </p:nvSpPr>
-        <p:spPr>
-          <a:xfrm>
-            <a:off x="7955280" y="4617720"/>
+          <p:cNvPr id="47" name="Shape 44"/>
+          <p:cNvSpPr/>
+          <p:nvPr/>
+        </p:nvSpPr>
+        <p:spPr>
+          <a:xfrm>
+            <a:off x="9308592" y="4617720"/>
             <a:ext cx="1234440" cy="530352"/>
           </a:xfrm>
           <a:prstGeom prst="rect">
@@ -15546,13 +15649,13 @@
       </p:sp>
       <p:sp>
         <p:nvSpPr>
-          <p:cNvPr id="45" name="Text 42"/>
-          <p:cNvSpPr/>
-          <p:nvPr/>
-        </p:nvSpPr>
-        <p:spPr>
-          <a:xfrm>
-            <a:off x="7955280" y="4617720"/>
+          <p:cNvPr id="48" name="Text 45"/>
+          <p:cNvSpPr/>
+          <p:nvPr/>
+        </p:nvSpPr>
+        <p:spPr>
+          <a:xfrm>
+            <a:off x="9308592" y="4617720"/>
             <a:ext cx="1234440" cy="237744"/>
           </a:xfrm>
           <a:prstGeom prst="rect">
@@ -15585,13 +15688,13 @@
       </p:sp>
       <p:sp>
         <p:nvSpPr>
-          <p:cNvPr id="46" name="Text 43"/>
-          <p:cNvSpPr/>
-          <p:nvPr/>
-        </p:nvSpPr>
-        <p:spPr>
-          <a:xfrm>
-            <a:off x="7955280" y="4855464"/>
+          <p:cNvPr id="49" name="Text 46"/>
+          <p:cNvSpPr/>
+          <p:nvPr/>
+        </p:nvSpPr>
+        <p:spPr>
+          <a:xfrm>
+            <a:off x="9308592" y="4855464"/>
             <a:ext cx="1234440" cy="292608"/>
           </a:xfrm>
           <a:prstGeom prst="rect">
@@ -15624,109 +15727,6 @@
       </p:sp>
       <p:sp>
         <p:nvSpPr>
-          <p:cNvPr id="47" name="Shape 44"/>
-          <p:cNvSpPr/>
-          <p:nvPr/>
-        </p:nvSpPr>
-        <p:spPr>
-          <a:xfrm>
-            <a:off x="9308592" y="4617720"/>
-            <a:ext cx="1234440" cy="530352"/>
-          </a:xfrm>
-          <a:prstGeom prst="rect">
-            <a:avLst/>
-          </a:prstGeom>
-          <a:solidFill>
-            <a:srgbClr val="FFF9D9"/>
-          </a:solidFill>
-          <a:ln w="12700">
-            <a:solidFill>
-              <a:srgbClr val="D6CFC4"/>
-            </a:solidFill>
-            <a:prstDash val="solid"/>
-          </a:ln>
-        </p:spPr>
-      </p:sp>
-      <p:sp>
-        <p:nvSpPr>
-          <p:cNvPr id="48" name="Text 45"/>
-          <p:cNvSpPr/>
-          <p:nvPr/>
-        </p:nvSpPr>
-        <p:spPr>
-          <a:xfrm>
-            <a:off x="9308592" y="4617720"/>
-            <a:ext cx="1234440" cy="237744"/>
-          </a:xfrm>
-          <a:prstGeom prst="rect">
-            <a:avLst/>
-          </a:prstGeom>
-          <a:noFill/>
-          <a:ln/>
-        </p:spPr>
-        <p:txBody>
-          <a:bodyPr wrap="square" rtlCol="0" anchor="b"/>
-          <a:lstStyle/>
-          <a:p>
-            <a:pPr algn="ctr" indent="0" marL="0">
-              <a:buNone/>
-            </a:pPr>
-            <a:r>
-              <a:rPr lang="en-US" sz="1100" dirty="0">
-                <a:solidFill>
-                  <a:srgbClr val="718096"/>
-                </a:solidFill>
-                <a:latin typeface="Calibri" pitchFamily="34" charset="0"/>
-                <a:ea typeface="Calibri" pitchFamily="34" charset="-122"/>
-                <a:cs typeface="Calibri" pitchFamily="34" charset="-120"/>
-              </a:rPr>
-              <a:t>Uganda</a:t>
-            </a:r>
-            <a:endParaRPr lang="en-US" sz="1100" dirty="0"/>
-          </a:p>
-        </p:txBody>
-      </p:sp>
-      <p:sp>
-        <p:nvSpPr>
-          <p:cNvPr id="49" name="Text 46"/>
-          <p:cNvSpPr/>
-          <p:nvPr/>
-        </p:nvSpPr>
-        <p:spPr>
-          <a:xfrm>
-            <a:off x="9308592" y="4855464"/>
-            <a:ext cx="1234440" cy="292608"/>
-          </a:xfrm>
-          <a:prstGeom prst="rect">
-            <a:avLst/>
-          </a:prstGeom>
-          <a:noFill/>
-          <a:ln/>
-        </p:spPr>
-        <p:txBody>
-          <a:bodyPr wrap="square" rtlCol="0" anchor="ctr"/>
-          <a:lstStyle/>
-          <a:p>
-            <a:pPr algn="ctr" indent="0" marL="0">
-              <a:buNone/>
-            </a:pPr>
-            <a:r>
-              <a:rPr lang="en-US" sz="1100" b="1" dirty="0">
-                <a:solidFill>
-                  <a:srgbClr val="5D300F"/>
-                </a:solidFill>
-                <a:latin typeface="Century Gothic" pitchFamily="34" charset="0"/>
-                <a:ea typeface="Century Gothic" pitchFamily="34" charset="-122"/>
-                <a:cs typeface="Century Gothic" pitchFamily="34" charset="-120"/>
-              </a:rPr>
-              <a:t>—</a:t>
-            </a:r>
-            <a:endParaRPr lang="en-US" sz="1100" dirty="0"/>
-          </a:p>
-        </p:txBody>
-      </p:sp>
-      <p:sp>
-        <p:nvSpPr>
           <p:cNvPr id="50" name="Shape 47"/>
           <p:cNvSpPr/>
           <p:nvPr/>
@@ -15847,7 +15847,7 @@
                 <a:ea typeface="Calibri" pitchFamily="34" charset="-122"/>
                 <a:cs typeface="Calibri" pitchFamily="34" charset="-120"/>
               </a:rPr>
-              <a:t>Total disbursed: $5,093,051 (-9.7% vs prior month).</a:t>
+              <a:t>Total disbursed: $1,963,743,051 (+31627.6% vs prior month).</a:t>
             </a:r>
             <a:endParaRPr lang="en-US" sz="1200" dirty="0"/>
           </a:p>
@@ -15864,7 +15864,7 @@
                 <a:ea typeface="Calibri" pitchFamily="34" charset="-122"/>
                 <a:cs typeface="Calibri" pitchFamily="34" charset="-120"/>
               </a:rPr>
-              <a:t>Tanzania had the highest disbursements ($2,578,767).</a:t>
+              <a:t>Uganda had the highest disbursements ($1,958,650,000).</a:t>
             </a:r>
             <a:endParaRPr lang="en-US" sz="1200" dirty="0"/>
           </a:p>
@@ -16419,6 +16419,45 @@
                 <a:ea typeface="Calibri" pitchFamily="34" charset="-122"/>
                 <a:cs typeface="Calibri" pitchFamily="34" charset="-120"/>
               </a:rPr>
+              <a:t>+386635.3%</a:t>
+            </a:r>
+            <a:endParaRPr lang="en-US" sz="1200" dirty="0"/>
+          </a:p>
+        </p:txBody>
+      </p:sp>
+      <p:sp>
+        <p:nvSpPr>
+          <p:cNvPr id="20" name="Text 16"/>
+          <p:cNvSpPr/>
+          <p:nvPr/>
+        </p:nvSpPr>
+        <p:spPr>
+          <a:xfrm>
+            <a:off x="1298448" y="5925312"/>
+            <a:ext cx="1161288" cy="347472"/>
+          </a:xfrm>
+          <a:prstGeom prst="rect">
+            <a:avLst/>
+          </a:prstGeom>
+          <a:noFill/>
+          <a:ln/>
+        </p:spPr>
+        <p:txBody>
+          <a:bodyPr wrap="square" rtlCol="0" anchor="ctr"/>
+          <a:lstStyle/>
+          <a:p>
+            <a:pPr algn="ctr" indent="0" marL="0">
+              <a:buNone/>
+            </a:pPr>
+            <a:r>
+              <a:rPr lang="en-US" sz="1200" b="1" dirty="0">
+                <a:solidFill>
+                  <a:srgbClr val="1A7A6E"/>
+                </a:solidFill>
+                <a:latin typeface="Calibri" pitchFamily="34" charset="0"/>
+                <a:ea typeface="Calibri" pitchFamily="34" charset="-122"/>
+                <a:cs typeface="Calibri" pitchFamily="34" charset="-120"/>
+              </a:rPr>
               <a:t>+0.8%</a:t>
             </a:r>
             <a:endParaRPr lang="en-US" sz="1200" dirty="0"/>
@@ -16427,13 +16466,13 @@
       </p:sp>
       <p:sp>
         <p:nvSpPr>
-          <p:cNvPr id="20" name="Text 16"/>
-          <p:cNvSpPr/>
-          <p:nvPr/>
-        </p:nvSpPr>
-        <p:spPr>
-          <a:xfrm>
-            <a:off x="1298448" y="5925312"/>
+          <p:cNvPr id="21" name="Text 17"/>
+          <p:cNvSpPr/>
+          <p:nvPr/>
+        </p:nvSpPr>
+        <p:spPr>
+          <a:xfrm>
+            <a:off x="2459736" y="5925312"/>
             <a:ext cx="1161288" cy="347472"/>
           </a:xfrm>
           <a:prstGeom prst="rect">
@@ -16466,13 +16505,13 @@
       </p:sp>
       <p:sp>
         <p:nvSpPr>
-          <p:cNvPr id="21" name="Text 17"/>
-          <p:cNvSpPr/>
-          <p:nvPr/>
-        </p:nvSpPr>
-        <p:spPr>
-          <a:xfrm>
-            <a:off x="2459736" y="5925312"/>
+          <p:cNvPr id="22" name="Text 18"/>
+          <p:cNvSpPr/>
+          <p:nvPr/>
+        </p:nvSpPr>
+        <p:spPr>
+          <a:xfrm>
+            <a:off x="3621024" y="5925312"/>
             <a:ext cx="1161288" cy="347472"/>
           </a:xfrm>
           <a:prstGeom prst="rect">
@@ -16505,13 +16544,13 @@
       </p:sp>
       <p:sp>
         <p:nvSpPr>
-          <p:cNvPr id="22" name="Text 18"/>
-          <p:cNvSpPr/>
-          <p:nvPr/>
-        </p:nvSpPr>
-        <p:spPr>
-          <a:xfrm>
-            <a:off x="3621024" y="5925312"/>
+          <p:cNvPr id="23" name="Text 19"/>
+          <p:cNvSpPr/>
+          <p:nvPr/>
+        </p:nvSpPr>
+        <p:spPr>
+          <a:xfrm>
+            <a:off x="4782312" y="5925312"/>
             <a:ext cx="1161288" cy="347472"/>
           </a:xfrm>
           <a:prstGeom prst="rect">
@@ -16544,45 +16583,6 @@
       </p:sp>
       <p:sp>
         <p:nvSpPr>
-          <p:cNvPr id="23" name="Text 19"/>
-          <p:cNvSpPr/>
-          <p:nvPr/>
-        </p:nvSpPr>
-        <p:spPr>
-          <a:xfrm>
-            <a:off x="4782312" y="5925312"/>
-            <a:ext cx="1161288" cy="347472"/>
-          </a:xfrm>
-          <a:prstGeom prst="rect">
-            <a:avLst/>
-          </a:prstGeom>
-          <a:noFill/>
-          <a:ln/>
-        </p:spPr>
-        <p:txBody>
-          <a:bodyPr wrap="square" rtlCol="0" anchor="ctr"/>
-          <a:lstStyle/>
-          <a:p>
-            <a:pPr algn="ctr" indent="0" marL="0">
-              <a:buNone/>
-            </a:pPr>
-            <a:r>
-              <a:rPr lang="en-US" sz="1200" b="1" dirty="0">
-                <a:solidFill>
-                  <a:srgbClr val="718096"/>
-                </a:solidFill>
-                <a:latin typeface="Calibri" pitchFamily="34" charset="0"/>
-                <a:ea typeface="Calibri" pitchFamily="34" charset="-122"/>
-                <a:cs typeface="Calibri" pitchFamily="34" charset="-120"/>
-              </a:rPr>
-              <a:t>—</a:t>
-            </a:r>
-            <a:endParaRPr lang="en-US" sz="1200" dirty="0"/>
-          </a:p>
-        </p:txBody>
-      </p:sp>
-      <p:sp>
-        <p:nvSpPr>
           <p:cNvPr id="24" name="Shape 20"/>
           <p:cNvSpPr/>
           <p:nvPr/>
@@ -16703,6 +16703,45 @@
                 <a:ea typeface="Calibri" pitchFamily="34" charset="-122"/>
                 <a:cs typeface="Calibri" pitchFamily="34" charset="-120"/>
               </a:rPr>
+              <a:t>-18.1%</a:t>
+            </a:r>
+            <a:endParaRPr lang="en-US" sz="1200" dirty="0"/>
+          </a:p>
+        </p:txBody>
+      </p:sp>
+      <p:sp>
+        <p:nvSpPr>
+          <p:cNvPr id="28" name="Text 24"/>
+          <p:cNvSpPr/>
+          <p:nvPr/>
+        </p:nvSpPr>
+        <p:spPr>
+          <a:xfrm>
+            <a:off x="7333488" y="5925312"/>
+            <a:ext cx="1161288" cy="347472"/>
+          </a:xfrm>
+          <a:prstGeom prst="rect">
+            <a:avLst/>
+          </a:prstGeom>
+          <a:noFill/>
+          <a:ln/>
+        </p:spPr>
+        <p:txBody>
+          <a:bodyPr wrap="square" rtlCol="0" anchor="ctr"/>
+          <a:lstStyle/>
+          <a:p>
+            <a:pPr algn="ctr" indent="0" marL="0">
+              <a:buNone/>
+            </a:pPr>
+            <a:r>
+              <a:rPr lang="en-US" sz="1200" b="1" dirty="0">
+                <a:solidFill>
+                  <a:srgbClr val="C0392B"/>
+                </a:solidFill>
+                <a:latin typeface="Calibri" pitchFamily="34" charset="0"/>
+                <a:ea typeface="Calibri" pitchFamily="34" charset="-122"/>
+                <a:cs typeface="Calibri" pitchFamily="34" charset="-120"/>
+              </a:rPr>
               <a:t>-11.9%</a:t>
             </a:r>
             <a:endParaRPr lang="en-US" sz="1200" dirty="0"/>
@@ -16711,13 +16750,13 @@
       </p:sp>
       <p:sp>
         <p:nvSpPr>
-          <p:cNvPr id="28" name="Text 24"/>
-          <p:cNvSpPr/>
-          <p:nvPr/>
-        </p:nvSpPr>
-        <p:spPr>
-          <a:xfrm>
-            <a:off x="7333488" y="5925312"/>
+          <p:cNvPr id="29" name="Text 25"/>
+          <p:cNvSpPr/>
+          <p:nvPr/>
+        </p:nvSpPr>
+        <p:spPr>
+          <a:xfrm>
+            <a:off x="8494776" y="5925312"/>
             <a:ext cx="1161288" cy="347472"/>
           </a:xfrm>
           <a:prstGeom prst="rect">
@@ -16750,13 +16789,13 @@
       </p:sp>
       <p:sp>
         <p:nvSpPr>
-          <p:cNvPr id="29" name="Text 25"/>
-          <p:cNvSpPr/>
-          <p:nvPr/>
-        </p:nvSpPr>
-        <p:spPr>
-          <a:xfrm>
-            <a:off x="8494776" y="5925312"/>
+          <p:cNvPr id="30" name="Text 26"/>
+          <p:cNvSpPr/>
+          <p:nvPr/>
+        </p:nvSpPr>
+        <p:spPr>
+          <a:xfrm>
+            <a:off x="9656064" y="5925312"/>
             <a:ext cx="1161288" cy="347472"/>
           </a:xfrm>
           <a:prstGeom prst="rect">
@@ -16789,13 +16828,13 @@
       </p:sp>
       <p:sp>
         <p:nvSpPr>
-          <p:cNvPr id="30" name="Text 26"/>
-          <p:cNvSpPr/>
-          <p:nvPr/>
-        </p:nvSpPr>
-        <p:spPr>
-          <a:xfrm>
-            <a:off x="9656064" y="5925312"/>
+          <p:cNvPr id="31" name="Text 27"/>
+          <p:cNvSpPr/>
+          <p:nvPr/>
+        </p:nvSpPr>
+        <p:spPr>
+          <a:xfrm>
+            <a:off x="10817352" y="5925312"/>
             <a:ext cx="1161288" cy="347472"/>
           </a:xfrm>
           <a:prstGeom prst="rect">
@@ -16821,45 +16860,6 @@
                 <a:cs typeface="Calibri" pitchFamily="34" charset="-120"/>
               </a:rPr>
               <a:t>+24.5%</a:t>
-            </a:r>
-            <a:endParaRPr lang="en-US" sz="1200" dirty="0"/>
-          </a:p>
-        </p:txBody>
-      </p:sp>
-      <p:sp>
-        <p:nvSpPr>
-          <p:cNvPr id="31" name="Text 27"/>
-          <p:cNvSpPr/>
-          <p:nvPr/>
-        </p:nvSpPr>
-        <p:spPr>
-          <a:xfrm>
-            <a:off x="10817352" y="5925312"/>
-            <a:ext cx="1161288" cy="347472"/>
-          </a:xfrm>
-          <a:prstGeom prst="rect">
-            <a:avLst/>
-          </a:prstGeom>
-          <a:noFill/>
-          <a:ln/>
-        </p:spPr>
-        <p:txBody>
-          <a:bodyPr wrap="square" rtlCol="0" anchor="ctr"/>
-          <a:lstStyle/>
-          <a:p>
-            <a:pPr algn="ctr" indent="0" marL="0">
-              <a:buNone/>
-            </a:pPr>
-            <a:r>
-              <a:rPr lang="en-US" sz="1200" b="1" dirty="0">
-                <a:solidFill>
-                  <a:srgbClr val="718096"/>
-                </a:solidFill>
-                <a:latin typeface="Calibri" pitchFamily="34" charset="0"/>
-                <a:ea typeface="Calibri" pitchFamily="34" charset="-122"/>
-                <a:cs typeface="Calibri" pitchFamily="34" charset="-120"/>
-              </a:rPr>
-              <a:t>—</a:t>
             </a:r>
             <a:endParaRPr lang="en-US" sz="1200" dirty="0"/>
           </a:p>
@@ -17387,6 +17387,45 @@
                 <a:ea typeface="Calibri" pitchFamily="34" charset="-122"/>
                 <a:cs typeface="Calibri" pitchFamily="34" charset="-120"/>
               </a:rPr>
+              <a:t>↓</a:t>
+            </a:r>
+            <a:endParaRPr lang="en-US" sz="1200" dirty="0"/>
+          </a:p>
+        </p:txBody>
+      </p:sp>
+      <p:sp>
+        <p:nvSpPr>
+          <p:cNvPr id="18" name="Text 15"/>
+          <p:cNvSpPr/>
+          <p:nvPr/>
+        </p:nvSpPr>
+        <p:spPr>
+          <a:xfrm>
+            <a:off x="4690872" y="5925312"/>
+            <a:ext cx="1517904" cy="347472"/>
+          </a:xfrm>
+          <a:prstGeom prst="rect">
+            <a:avLst/>
+          </a:prstGeom>
+          <a:noFill/>
+          <a:ln/>
+        </p:spPr>
+        <p:txBody>
+          <a:bodyPr wrap="square" rtlCol="0" anchor="ctr"/>
+          <a:lstStyle/>
+          <a:p>
+            <a:pPr algn="ctr" indent="0" marL="0">
+              <a:buNone/>
+            </a:pPr>
+            <a:r>
+              <a:rPr lang="en-US" sz="1200" b="1" dirty="0">
+                <a:solidFill>
+                  <a:srgbClr val="1A7A6E"/>
+                </a:solidFill>
+                <a:latin typeface="Calibri" pitchFamily="34" charset="0"/>
+                <a:ea typeface="Calibri" pitchFamily="34" charset="-122"/>
+                <a:cs typeface="Calibri" pitchFamily="34" charset="-120"/>
+              </a:rPr>
               <a:t>—</a:t>
             </a:r>
             <a:endParaRPr lang="en-US" sz="1200" dirty="0"/>
@@ -17395,13 +17434,13 @@
       </p:sp>
       <p:sp>
         <p:nvSpPr>
-          <p:cNvPr id="18" name="Text 15"/>
-          <p:cNvSpPr/>
-          <p:nvPr/>
-        </p:nvSpPr>
-        <p:spPr>
-          <a:xfrm>
-            <a:off x="4690872" y="5925312"/>
+          <p:cNvPr id="19" name="Text 16"/>
+          <p:cNvSpPr/>
+          <p:nvPr/>
+        </p:nvSpPr>
+        <p:spPr>
+          <a:xfrm>
+            <a:off x="6208776" y="5925312"/>
             <a:ext cx="1517904" cy="347472"/>
           </a:xfrm>
           <a:prstGeom prst="rect">
@@ -17427,45 +17466,6 @@
                 <a:cs typeface="Calibri" pitchFamily="34" charset="-120"/>
               </a:rPr>
               <a:t>↓</a:t>
-            </a:r>
-            <a:endParaRPr lang="en-US" sz="1200" dirty="0"/>
-          </a:p>
-        </p:txBody>
-      </p:sp>
-      <p:sp>
-        <p:nvSpPr>
-          <p:cNvPr id="19" name="Text 16"/>
-          <p:cNvSpPr/>
-          <p:nvPr/>
-        </p:nvSpPr>
-        <p:spPr>
-          <a:xfrm>
-            <a:off x="6208776" y="5925312"/>
-            <a:ext cx="1517904" cy="347472"/>
-          </a:xfrm>
-          <a:prstGeom prst="rect">
-            <a:avLst/>
-          </a:prstGeom>
-          <a:noFill/>
-          <a:ln/>
-        </p:spPr>
-        <p:txBody>
-          <a:bodyPr wrap="square" rtlCol="0" anchor="ctr"/>
-          <a:lstStyle/>
-          <a:p>
-            <a:pPr algn="ctr" indent="0" marL="0">
-              <a:buNone/>
-            </a:pPr>
-            <a:r>
-              <a:rPr lang="en-US" sz="1200" b="1" dirty="0">
-                <a:solidFill>
-                  <a:srgbClr val="718096"/>
-                </a:solidFill>
-                <a:latin typeface="Calibri" pitchFamily="34" charset="0"/>
-                <a:ea typeface="Calibri" pitchFamily="34" charset="-122"/>
-                <a:cs typeface="Calibri" pitchFamily="34" charset="-120"/>
-              </a:rPr>
-              <a:t>—</a:t>
             </a:r>
             <a:endParaRPr lang="en-US" sz="1200" dirty="0"/>
           </a:p>
@@ -18324,6 +18324,45 @@
             <a:r>
               <a:rPr lang="en-US" sz="1200" b="1" dirty="0">
                 <a:solidFill>
+                  <a:srgbClr val="1A7A6E"/>
+                </a:solidFill>
+                <a:latin typeface="Calibri" pitchFamily="34" charset="0"/>
+                <a:ea typeface="Calibri" pitchFamily="34" charset="-122"/>
+                <a:cs typeface="Calibri" pitchFamily="34" charset="-120"/>
+              </a:rPr>
+              <a:t>+387968.7%</a:t>
+            </a:r>
+            <a:endParaRPr lang="en-US" sz="1200" dirty="0"/>
+          </a:p>
+        </p:txBody>
+      </p:sp>
+      <p:sp>
+        <p:nvSpPr>
+          <p:cNvPr id="16" name="Text 13"/>
+          <p:cNvSpPr/>
+          <p:nvPr/>
+        </p:nvSpPr>
+        <p:spPr>
+          <a:xfrm>
+            <a:off x="1655064" y="5925312"/>
+            <a:ext cx="1517904" cy="347472"/>
+          </a:xfrm>
+          <a:prstGeom prst="rect">
+            <a:avLst/>
+          </a:prstGeom>
+          <a:noFill/>
+          <a:ln/>
+        </p:spPr>
+        <p:txBody>
+          <a:bodyPr wrap="square" rtlCol="0" anchor="ctr"/>
+          <a:lstStyle/>
+          <a:p>
+            <a:pPr algn="ctr" indent="0" marL="0">
+              <a:buNone/>
+            </a:pPr>
+            <a:r>
+              <a:rPr lang="en-US" sz="1200" b="1" dirty="0">
+                <a:solidFill>
                   <a:srgbClr val="C0392B"/>
                 </a:solidFill>
                 <a:latin typeface="Calibri" pitchFamily="34" charset="0"/>
@@ -18338,13 +18377,13 @@
       </p:sp>
       <p:sp>
         <p:nvSpPr>
-          <p:cNvPr id="16" name="Text 13"/>
-          <p:cNvSpPr/>
-          <p:nvPr/>
-        </p:nvSpPr>
-        <p:spPr>
-          <a:xfrm>
-            <a:off x="1655064" y="5925312"/>
+          <p:cNvPr id="17" name="Text 14"/>
+          <p:cNvSpPr/>
+          <p:nvPr/>
+        </p:nvSpPr>
+        <p:spPr>
+          <a:xfrm>
+            <a:off x="3172968" y="5925312"/>
             <a:ext cx="1517904" cy="347472"/>
           </a:xfrm>
           <a:prstGeom prst="rect">
@@ -18377,13 +18416,13 @@
       </p:sp>
       <p:sp>
         <p:nvSpPr>
-          <p:cNvPr id="17" name="Text 14"/>
-          <p:cNvSpPr/>
-          <p:nvPr/>
-        </p:nvSpPr>
-        <p:spPr>
-          <a:xfrm>
-            <a:off x="3172968" y="5925312"/>
+          <p:cNvPr id="18" name="Text 15"/>
+          <p:cNvSpPr/>
+          <p:nvPr/>
+        </p:nvSpPr>
+        <p:spPr>
+          <a:xfrm>
+            <a:off x="4690872" y="5925312"/>
             <a:ext cx="1517904" cy="347472"/>
           </a:xfrm>
           <a:prstGeom prst="rect">
@@ -18416,13 +18455,13 @@
       </p:sp>
       <p:sp>
         <p:nvSpPr>
-          <p:cNvPr id="18" name="Text 15"/>
-          <p:cNvSpPr/>
-          <p:nvPr/>
-        </p:nvSpPr>
-        <p:spPr>
-          <a:xfrm>
-            <a:off x="4690872" y="5925312"/>
+          <p:cNvPr id="19" name="Text 16"/>
+          <p:cNvSpPr/>
+          <p:nvPr/>
+        </p:nvSpPr>
+        <p:spPr>
+          <a:xfrm>
+            <a:off x="6208776" y="5925312"/>
             <a:ext cx="1517904" cy="347472"/>
           </a:xfrm>
           <a:prstGeom prst="rect">
@@ -18448,45 +18487,6 @@
                 <a:cs typeface="Calibri" pitchFamily="34" charset="-120"/>
               </a:rPr>
               <a:t>-7.1%</a:t>
-            </a:r>
-            <a:endParaRPr lang="en-US" sz="1200" dirty="0"/>
-          </a:p>
-        </p:txBody>
-      </p:sp>
-      <p:sp>
-        <p:nvSpPr>
-          <p:cNvPr id="19" name="Text 16"/>
-          <p:cNvSpPr/>
-          <p:nvPr/>
-        </p:nvSpPr>
-        <p:spPr>
-          <a:xfrm>
-            <a:off x="6208776" y="5925312"/>
-            <a:ext cx="1517904" cy="347472"/>
-          </a:xfrm>
-          <a:prstGeom prst="rect">
-            <a:avLst/>
-          </a:prstGeom>
-          <a:noFill/>
-          <a:ln/>
-        </p:spPr>
-        <p:txBody>
-          <a:bodyPr wrap="square" rtlCol="0" anchor="ctr"/>
-          <a:lstStyle/>
-          <a:p>
-            <a:pPr algn="ctr" indent="0" marL="0">
-              <a:buNone/>
-            </a:pPr>
-            <a:r>
-              <a:rPr lang="en-US" sz="1200" b="1" dirty="0">
-                <a:solidFill>
-                  <a:srgbClr val="718096"/>
-                </a:solidFill>
-                <a:latin typeface="Calibri" pitchFamily="34" charset="0"/>
-                <a:ea typeface="Calibri" pitchFamily="34" charset="-122"/>
-                <a:cs typeface="Calibri" pitchFamily="34" charset="-120"/>
-              </a:rPr>
-              <a:t>—</a:t>
             </a:r>
             <a:endParaRPr lang="en-US" sz="1200" dirty="0"/>
           </a:p>
@@ -18582,7 +18582,7 @@
                 <a:ea typeface="Century Gothic" pitchFamily="34" charset="-122"/>
                 <a:cs typeface="Century Gothic" pitchFamily="34" charset="-120"/>
               </a:rPr>
-              <a:t>$12,369,009</a:t>
+              <a:t>$5,092,841,089</a:t>
             </a:r>
             <a:endParaRPr lang="en-US" sz="2600" dirty="0"/>
           </a:p>
@@ -18717,7 +18717,7 @@
                 <a:ea typeface="Century Gothic" pitchFamily="34" charset="-122"/>
                 <a:cs typeface="Century Gothic" pitchFamily="34" charset="-120"/>
               </a:rPr>
-              <a:t>-2.7%</a:t>
+              <a:t>+36218.7%</a:t>
             </a:r>
             <a:endParaRPr lang="en-US" sz="2600" dirty="0"/>
           </a:p>
@@ -18884,7 +18884,7 @@
                 <a:ea typeface="Calibri" pitchFamily="34" charset="-122"/>
                 <a:cs typeface="Calibri" pitchFamily="34" charset="-120"/>
               </a:rPr>
-              <a:t>Total loan book: $12,369,009 (-2.7% vs prior month).</a:t>
+              <a:t>Total loan book: $5,092,841,089 (+36218.7% vs prior month).</a:t>
             </a:r>
             <a:endParaRPr lang="en-US" sz="1200" dirty="0"/>
           </a:p>
@@ -18901,7 +18901,7 @@
                 <a:ea typeface="Calibri" pitchFamily="34" charset="-122"/>
                 <a:cs typeface="Calibri" pitchFamily="34" charset="-120"/>
               </a:rPr>
-              <a:t>Tanzania has the largest loan book ($6,528,403).</a:t>
+              <a:t>Uganda has the largest loan book ($5,080,472,080).</a:t>
             </a:r>
             <a:endParaRPr lang="en-US" sz="1200" dirty="0"/>
           </a:p>
@@ -19533,280 +19533,6 @@
                           <a:ea typeface="Century Gothic" pitchFamily="34" charset="-122"/>
                           <a:cs typeface="Century Gothic" pitchFamily="34" charset="-120"/>
                         </a:rPr>
-                        <a:t>Uganda</a:t>
-                      </a:r>
-                      <a:endParaRPr lang="en-US" sz="1200" dirty="0">
-                        <a:latin typeface="Century Gothic" charset="0"/>
-                        <a:ea typeface="Century Gothic" charset="0"/>
-                        <a:cs typeface="Century Gothic" charset="0"/>
-                      </a:endParaRPr>
-                    </a:p>
-                  </a:txBody>
-                  <a:tcPr marL="91440" marR="91440" marT="45720" marB="45720" anchor="ctr">
-                    <a:lnL w="6350" cap="flat" cmpd="sng" algn="ctr">
-                      <a:solidFill>
-                        <a:srgbClr val="D6CFC4"/>
-                      </a:solidFill>
-                      <a:prstDash val="solid"/>
-                      <a:round/>
-                      <a:headEnd type="none" w="med" len="med"/>
-                      <a:tailEnd type="none" w="med" len="med"/>
-                    </a:lnL>
-                    <a:lnR w="6350" cap="flat" cmpd="sng" algn="ctr">
-                      <a:solidFill>
-                        <a:srgbClr val="D6CFC4"/>
-                      </a:solidFill>
-                      <a:prstDash val="solid"/>
-                      <a:round/>
-                      <a:headEnd type="none" w="med" len="med"/>
-                      <a:tailEnd type="none" w="med" len="med"/>
-                    </a:lnR>
-                    <a:lnT w="6350" cap="flat" cmpd="sng" algn="ctr">
-                      <a:solidFill>
-                        <a:srgbClr val="D6CFC4"/>
-                      </a:solidFill>
-                      <a:prstDash val="solid"/>
-                      <a:round/>
-                      <a:headEnd type="none" w="med" len="med"/>
-                      <a:tailEnd type="none" w="med" len="med"/>
-                    </a:lnT>
-                    <a:lnB w="6350" cap="flat" cmpd="sng" algn="ctr">
-                      <a:solidFill>
-                        <a:srgbClr val="D6CFC4"/>
-                      </a:solidFill>
-                      <a:prstDash val="solid"/>
-                      <a:round/>
-                      <a:headEnd type="none" w="med" len="med"/>
-                      <a:tailEnd type="none" w="med" len="med"/>
-                    </a:lnB>
-                    <a:solidFill>
-                      <a:srgbClr val="FFFFFF"/>
-                    </a:solidFill>
-                  </a:tcPr>
-                </a:tc>
-                <a:tc>
-                  <a:txBody>
-                    <a:bodyPr/>
-                    <a:lstStyle/>
-                    <a:p>
-                      <a:pPr algn="ctr" indent="0" marL="0">
-                        <a:buNone/>
-                      </a:pPr>
-                      <a:r>
-                        <a:rPr lang="en-US" sz="1200" dirty="0">
-                          <a:solidFill>
-                            <a:srgbClr val="2D2A26"/>
-                          </a:solidFill>
-                          <a:latin typeface="Calibri" pitchFamily="34" charset="0"/>
-                          <a:ea typeface="Calibri" pitchFamily="34" charset="-122"/>
-                          <a:cs typeface="Calibri" pitchFamily="34" charset="-120"/>
-                        </a:rPr>
-                        <a:t>—</a:t>
-                      </a:r>
-                      <a:endParaRPr lang="en-US" sz="1200" dirty="0">
-                        <a:latin typeface="Calibri" charset="0"/>
-                        <a:ea typeface="Calibri" charset="0"/>
-                        <a:cs typeface="Calibri" charset="0"/>
-                      </a:endParaRPr>
-                    </a:p>
-                  </a:txBody>
-                  <a:tcPr marL="91440" marR="91440" marT="45720" marB="45720" anchor="ctr">
-                    <a:lnL w="6350" cap="flat" cmpd="sng" algn="ctr">
-                      <a:solidFill>
-                        <a:srgbClr val="D6CFC4"/>
-                      </a:solidFill>
-                      <a:prstDash val="solid"/>
-                      <a:round/>
-                      <a:headEnd type="none" w="med" len="med"/>
-                      <a:tailEnd type="none" w="med" len="med"/>
-                    </a:lnL>
-                    <a:lnR w="6350" cap="flat" cmpd="sng" algn="ctr">
-                      <a:solidFill>
-                        <a:srgbClr val="D6CFC4"/>
-                      </a:solidFill>
-                      <a:prstDash val="solid"/>
-                      <a:round/>
-                      <a:headEnd type="none" w="med" len="med"/>
-                      <a:tailEnd type="none" w="med" len="med"/>
-                    </a:lnR>
-                    <a:lnT w="6350" cap="flat" cmpd="sng" algn="ctr">
-                      <a:solidFill>
-                        <a:srgbClr val="D6CFC4"/>
-                      </a:solidFill>
-                      <a:prstDash val="solid"/>
-                      <a:round/>
-                      <a:headEnd type="none" w="med" len="med"/>
-                      <a:tailEnd type="none" w="med" len="med"/>
-                    </a:lnT>
-                    <a:lnB w="6350" cap="flat" cmpd="sng" algn="ctr">
-                      <a:solidFill>
-                        <a:srgbClr val="D6CFC4"/>
-                      </a:solidFill>
-                      <a:prstDash val="solid"/>
-                      <a:round/>
-                      <a:headEnd type="none" w="med" len="med"/>
-                      <a:tailEnd type="none" w="med" len="med"/>
-                    </a:lnB>
-                    <a:solidFill>
-                      <a:srgbClr val="FFFFFF"/>
-                    </a:solidFill>
-                  </a:tcPr>
-                </a:tc>
-                <a:tc>
-                  <a:txBody>
-                    <a:bodyPr/>
-                    <a:lstStyle/>
-                    <a:p>
-                      <a:pPr algn="ctr" indent="0" marL="0">
-                        <a:buNone/>
-                      </a:pPr>
-                      <a:r>
-                        <a:rPr lang="en-US" sz="1200" dirty="0">
-                          <a:solidFill>
-                            <a:srgbClr val="2D2A26"/>
-                          </a:solidFill>
-                          <a:latin typeface="Calibri" pitchFamily="34" charset="0"/>
-                          <a:ea typeface="Calibri" pitchFamily="34" charset="-122"/>
-                          <a:cs typeface="Calibri" pitchFamily="34" charset="-120"/>
-                        </a:rPr>
-                        <a:t>—</a:t>
-                      </a:r>
-                      <a:endParaRPr lang="en-US" sz="1200" dirty="0">
-                        <a:latin typeface="Calibri" charset="0"/>
-                        <a:ea typeface="Calibri" charset="0"/>
-                        <a:cs typeface="Calibri" charset="0"/>
-                      </a:endParaRPr>
-                    </a:p>
-                  </a:txBody>
-                  <a:tcPr marL="91440" marR="91440" marT="45720" marB="45720" anchor="ctr">
-                    <a:lnL w="6350" cap="flat" cmpd="sng" algn="ctr">
-                      <a:solidFill>
-                        <a:srgbClr val="D6CFC4"/>
-                      </a:solidFill>
-                      <a:prstDash val="solid"/>
-                      <a:round/>
-                      <a:headEnd type="none" w="med" len="med"/>
-                      <a:tailEnd type="none" w="med" len="med"/>
-                    </a:lnL>
-                    <a:lnR w="6350" cap="flat" cmpd="sng" algn="ctr">
-                      <a:solidFill>
-                        <a:srgbClr val="D6CFC4"/>
-                      </a:solidFill>
-                      <a:prstDash val="solid"/>
-                      <a:round/>
-                      <a:headEnd type="none" w="med" len="med"/>
-                      <a:tailEnd type="none" w="med" len="med"/>
-                    </a:lnR>
-                    <a:lnT w="6350" cap="flat" cmpd="sng" algn="ctr">
-                      <a:solidFill>
-                        <a:srgbClr val="D6CFC4"/>
-                      </a:solidFill>
-                      <a:prstDash val="solid"/>
-                      <a:round/>
-                      <a:headEnd type="none" w="med" len="med"/>
-                      <a:tailEnd type="none" w="med" len="med"/>
-                    </a:lnT>
-                    <a:lnB w="6350" cap="flat" cmpd="sng" algn="ctr">
-                      <a:solidFill>
-                        <a:srgbClr val="D6CFC4"/>
-                      </a:solidFill>
-                      <a:prstDash val="solid"/>
-                      <a:round/>
-                      <a:headEnd type="none" w="med" len="med"/>
-                      <a:tailEnd type="none" w="med" len="med"/>
-                    </a:lnB>
-                    <a:solidFill>
-                      <a:srgbClr val="FFFFFF"/>
-                    </a:solidFill>
-                  </a:tcPr>
-                </a:tc>
-                <a:tc>
-                  <a:txBody>
-                    <a:bodyPr/>
-                    <a:lstStyle/>
-                    <a:p>
-                      <a:pPr algn="ctr" indent="0" marL="0">
-                        <a:buNone/>
-                      </a:pPr>
-                      <a:r>
-                        <a:rPr lang="en-US" sz="1200" dirty="0">
-                          <a:solidFill>
-                            <a:srgbClr val="718096"/>
-                          </a:solidFill>
-                          <a:latin typeface="Calibri" pitchFamily="34" charset="0"/>
-                          <a:ea typeface="Calibri" pitchFamily="34" charset="-122"/>
-                          <a:cs typeface="Calibri" pitchFamily="34" charset="-120"/>
-                        </a:rPr>
-                        <a:t>—</a:t>
-                      </a:r>
-                      <a:endParaRPr lang="en-US" sz="1200" dirty="0">
-                        <a:latin typeface="Calibri" charset="0"/>
-                        <a:ea typeface="Calibri" charset="0"/>
-                        <a:cs typeface="Calibri" charset="0"/>
-                      </a:endParaRPr>
-                    </a:p>
-                  </a:txBody>
-                  <a:tcPr marL="91440" marR="91440" marT="45720" marB="45720" anchor="ctr">
-                    <a:lnL w="6350" cap="flat" cmpd="sng" algn="ctr">
-                      <a:solidFill>
-                        <a:srgbClr val="D6CFC4"/>
-                      </a:solidFill>
-                      <a:prstDash val="solid"/>
-                      <a:round/>
-                      <a:headEnd type="none" w="med" len="med"/>
-                      <a:tailEnd type="none" w="med" len="med"/>
-                    </a:lnL>
-                    <a:lnR w="6350" cap="flat" cmpd="sng" algn="ctr">
-                      <a:solidFill>
-                        <a:srgbClr val="D6CFC4"/>
-                      </a:solidFill>
-                      <a:prstDash val="solid"/>
-                      <a:round/>
-                      <a:headEnd type="none" w="med" len="med"/>
-                      <a:tailEnd type="none" w="med" len="med"/>
-                    </a:lnR>
-                    <a:lnT w="6350" cap="flat" cmpd="sng" algn="ctr">
-                      <a:solidFill>
-                        <a:srgbClr val="D6CFC4"/>
-                      </a:solidFill>
-                      <a:prstDash val="solid"/>
-                      <a:round/>
-                      <a:headEnd type="none" w="med" len="med"/>
-                      <a:tailEnd type="none" w="med" len="med"/>
-                    </a:lnT>
-                    <a:lnB w="6350" cap="flat" cmpd="sng" algn="ctr">
-                      <a:solidFill>
-                        <a:srgbClr val="D6CFC4"/>
-                      </a:solidFill>
-                      <a:prstDash val="solid"/>
-                      <a:round/>
-                      <a:headEnd type="none" w="med" len="med"/>
-                      <a:tailEnd type="none" w="med" len="med"/>
-                    </a:lnB>
-                    <a:solidFill>
-                      <a:srgbClr val="FFFFFF"/>
-                    </a:solidFill>
-                  </a:tcPr>
-                </a:tc>
-              </a:tr>
-              <a:tr h="384048">
-                <a:tc>
-                  <a:txBody>
-                    <a:bodyPr/>
-                    <a:lstStyle/>
-                    <a:p>
-                      <a:pPr algn="l" indent="0" marL="0">
-                        <a:buNone/>
-                      </a:pPr>
-                      <a:r>
-                        <a:rPr lang="en-US" sz="1200" b="1" dirty="0">
-                          <a:solidFill>
-                            <a:srgbClr val="2D2A26"/>
-                          </a:solidFill>
-                          <a:latin typeface="Century Gothic" pitchFamily="34" charset="0"/>
-                          <a:ea typeface="Century Gothic" pitchFamily="34" charset="-122"/>
-                          <a:cs typeface="Century Gothic" pitchFamily="34" charset="-120"/>
-                        </a:rPr>
                         <a:t>Sierra Leone</a:t>
                       </a:r>
                       <a:endParaRPr lang="en-US" sz="1200" dirty="0">
@@ -19854,7 +19580,7 @@
                       <a:tailEnd type="none" w="med" len="med"/>
                     </a:lnB>
                     <a:solidFill>
-                      <a:srgbClr val="FFF9D9"/>
+                      <a:srgbClr val="FFFFFF"/>
                     </a:solidFill>
                   </a:tcPr>
                 </a:tc>
@@ -19922,7 +19648,7 @@
                       <a:tailEnd type="none" w="med" len="med"/>
                     </a:lnB>
                     <a:solidFill>
-                      <a:srgbClr val="FFF9D9"/>
+                      <a:srgbClr val="FFFFFF"/>
                     </a:solidFill>
                   </a:tcPr>
                 </a:tc>
@@ -19990,7 +19716,7 @@
                       <a:tailEnd type="none" w="med" len="med"/>
                     </a:lnB>
                     <a:solidFill>
-                      <a:srgbClr val="FFF9D9"/>
+                      <a:srgbClr val="FFFFFF"/>
                     </a:solidFill>
                   </a:tcPr>
                 </a:tc>
@@ -20058,7 +19784,7 @@
                       <a:tailEnd type="none" w="med" len="med"/>
                     </a:lnB>
                     <a:solidFill>
-                      <a:srgbClr val="FFF9D9"/>
+                      <a:srgbClr val="FFFFFF"/>
                     </a:solidFill>
                   </a:tcPr>
                 </a:tc>
@@ -20128,7 +19854,7 @@
                       <a:tailEnd type="none" w="med" len="med"/>
                     </a:lnB>
                     <a:solidFill>
-                      <a:srgbClr val="FFFFFF"/>
+                      <a:srgbClr val="FFF9D9"/>
                     </a:solidFill>
                   </a:tcPr>
                 </a:tc>
@@ -20196,6 +19922,212 @@
                       <a:tailEnd type="none" w="med" len="med"/>
                     </a:lnB>
                     <a:solidFill>
+                      <a:srgbClr val="FFF9D9"/>
+                    </a:solidFill>
+                  </a:tcPr>
+                </a:tc>
+                <a:tc>
+                  <a:txBody>
+                    <a:bodyPr/>
+                    <a:lstStyle/>
+                    <a:p>
+                      <a:pPr algn="ctr" indent="0" marL="0">
+                        <a:buNone/>
+                      </a:pPr>
+                      <a:r>
+                        <a:rPr lang="en-US" sz="1200" dirty="0">
+                          <a:solidFill>
+                            <a:srgbClr val="2D2A26"/>
+                          </a:solidFill>
+                          <a:latin typeface="Calibri" pitchFamily="34" charset="0"/>
+                          <a:ea typeface="Calibri" pitchFamily="34" charset="-122"/>
+                          <a:cs typeface="Calibri" pitchFamily="34" charset="-120"/>
+                        </a:rPr>
+                        <a:t>7.2%</a:t>
+                      </a:r>
+                      <a:endParaRPr lang="en-US" sz="1200" dirty="0">
+                        <a:latin typeface="Calibri" charset="0"/>
+                        <a:ea typeface="Calibri" charset="0"/>
+                        <a:cs typeface="Calibri" charset="0"/>
+                      </a:endParaRPr>
+                    </a:p>
+                  </a:txBody>
+                  <a:tcPr marL="91440" marR="91440" marT="45720" marB="45720" anchor="ctr">
+                    <a:lnL w="6350" cap="flat" cmpd="sng" algn="ctr">
+                      <a:solidFill>
+                        <a:srgbClr val="D6CFC4"/>
+                      </a:solidFill>
+                      <a:prstDash val="solid"/>
+                      <a:round/>
+                      <a:headEnd type="none" w="med" len="med"/>
+                      <a:tailEnd type="none" w="med" len="med"/>
+                    </a:lnL>
+                    <a:lnR w="6350" cap="flat" cmpd="sng" algn="ctr">
+                      <a:solidFill>
+                        <a:srgbClr val="D6CFC4"/>
+                      </a:solidFill>
+                      <a:prstDash val="solid"/>
+                      <a:round/>
+                      <a:headEnd type="none" w="med" len="med"/>
+                      <a:tailEnd type="none" w="med" len="med"/>
+                    </a:lnR>
+                    <a:lnT w="6350" cap="flat" cmpd="sng" algn="ctr">
+                      <a:solidFill>
+                        <a:srgbClr val="D6CFC4"/>
+                      </a:solidFill>
+                      <a:prstDash val="solid"/>
+                      <a:round/>
+                      <a:headEnd type="none" w="med" len="med"/>
+                      <a:tailEnd type="none" w="med" len="med"/>
+                    </a:lnT>
+                    <a:lnB w="6350" cap="flat" cmpd="sng" algn="ctr">
+                      <a:solidFill>
+                        <a:srgbClr val="D6CFC4"/>
+                      </a:solidFill>
+                      <a:prstDash val="solid"/>
+                      <a:round/>
+                      <a:headEnd type="none" w="med" len="med"/>
+                      <a:tailEnd type="none" w="med" len="med"/>
+                    </a:lnB>
+                    <a:solidFill>
+                      <a:srgbClr val="FFF9D9"/>
+                    </a:solidFill>
+                  </a:tcPr>
+                </a:tc>
+                <a:tc>
+                  <a:txBody>
+                    <a:bodyPr/>
+                    <a:lstStyle/>
+                    <a:p>
+                      <a:pPr algn="ctr" indent="0" marL="0">
+                        <a:buNone/>
+                      </a:pPr>
+                      <a:r>
+                        <a:rPr lang="en-US" sz="1200" dirty="0">
+                          <a:solidFill>
+                            <a:srgbClr val="C0392B"/>
+                          </a:solidFill>
+                          <a:latin typeface="Calibri" pitchFamily="34" charset="0"/>
+                          <a:ea typeface="Calibri" pitchFamily="34" charset="-122"/>
+                          <a:cs typeface="Calibri" pitchFamily="34" charset="-120"/>
+                        </a:rPr>
+                        <a:t>↑</a:t>
+                      </a:r>
+                      <a:endParaRPr lang="en-US" sz="1200" dirty="0">
+                        <a:latin typeface="Calibri" charset="0"/>
+                        <a:ea typeface="Calibri" charset="0"/>
+                        <a:cs typeface="Calibri" charset="0"/>
+                      </a:endParaRPr>
+                    </a:p>
+                  </a:txBody>
+                  <a:tcPr marL="91440" marR="91440" marT="45720" marB="45720" anchor="ctr">
+                    <a:lnL w="6350" cap="flat" cmpd="sng" algn="ctr">
+                      <a:solidFill>
+                        <a:srgbClr val="D6CFC4"/>
+                      </a:solidFill>
+                      <a:prstDash val="solid"/>
+                      <a:round/>
+                      <a:headEnd type="none" w="med" len="med"/>
+                      <a:tailEnd type="none" w="med" len="med"/>
+                    </a:lnL>
+                    <a:lnR w="6350" cap="flat" cmpd="sng" algn="ctr">
+                      <a:solidFill>
+                        <a:srgbClr val="D6CFC4"/>
+                      </a:solidFill>
+                      <a:prstDash val="solid"/>
+                      <a:round/>
+                      <a:headEnd type="none" w="med" len="med"/>
+                      <a:tailEnd type="none" w="med" len="med"/>
+                    </a:lnR>
+                    <a:lnT w="6350" cap="flat" cmpd="sng" algn="ctr">
+                      <a:solidFill>
+                        <a:srgbClr val="D6CFC4"/>
+                      </a:solidFill>
+                      <a:prstDash val="solid"/>
+                      <a:round/>
+                      <a:headEnd type="none" w="med" len="med"/>
+                      <a:tailEnd type="none" w="med" len="med"/>
+                    </a:lnT>
+                    <a:lnB w="6350" cap="flat" cmpd="sng" algn="ctr">
+                      <a:solidFill>
+                        <a:srgbClr val="D6CFC4"/>
+                      </a:solidFill>
+                      <a:prstDash val="solid"/>
+                      <a:round/>
+                      <a:headEnd type="none" w="med" len="med"/>
+                      <a:tailEnd type="none" w="med" len="med"/>
+                    </a:lnB>
+                    <a:solidFill>
+                      <a:srgbClr val="FFF9D9"/>
+                    </a:solidFill>
+                  </a:tcPr>
+                </a:tc>
+              </a:tr>
+              <a:tr h="384048">
+                <a:tc>
+                  <a:txBody>
+                    <a:bodyPr/>
+                    <a:lstStyle/>
+                    <a:p>
+                      <a:pPr algn="l" indent="0" marL="0">
+                        <a:buNone/>
+                      </a:pPr>
+                      <a:r>
+                        <a:rPr lang="en-US" sz="1200" b="1" dirty="0">
+                          <a:solidFill>
+                            <a:srgbClr val="2D2A26"/>
+                          </a:solidFill>
+                          <a:latin typeface="Century Gothic" pitchFamily="34" charset="0"/>
+                          <a:ea typeface="Century Gothic" pitchFamily="34" charset="-122"/>
+                          <a:cs typeface="Century Gothic" pitchFamily="34" charset="-120"/>
+                        </a:rPr>
+                        <a:t>Tanzania</a:t>
+                      </a:r>
+                      <a:endParaRPr lang="en-US" sz="1200" dirty="0">
+                        <a:latin typeface="Century Gothic" charset="0"/>
+                        <a:ea typeface="Century Gothic" charset="0"/>
+                        <a:cs typeface="Century Gothic" charset="0"/>
+                      </a:endParaRPr>
+                    </a:p>
+                  </a:txBody>
+                  <a:tcPr marL="91440" marR="91440" marT="45720" marB="45720" anchor="ctr">
+                    <a:lnL w="6350" cap="flat" cmpd="sng" algn="ctr">
+                      <a:solidFill>
+                        <a:srgbClr val="D6CFC4"/>
+                      </a:solidFill>
+                      <a:prstDash val="solid"/>
+                      <a:round/>
+                      <a:headEnd type="none" w="med" len="med"/>
+                      <a:tailEnd type="none" w="med" len="med"/>
+                    </a:lnL>
+                    <a:lnR w="6350" cap="flat" cmpd="sng" algn="ctr">
+                      <a:solidFill>
+                        <a:srgbClr val="D6CFC4"/>
+                      </a:solidFill>
+                      <a:prstDash val="solid"/>
+                      <a:round/>
+                      <a:headEnd type="none" w="med" len="med"/>
+                      <a:tailEnd type="none" w="med" len="med"/>
+                    </a:lnR>
+                    <a:lnT w="6350" cap="flat" cmpd="sng" algn="ctr">
+                      <a:solidFill>
+                        <a:srgbClr val="D6CFC4"/>
+                      </a:solidFill>
+                      <a:prstDash val="solid"/>
+                      <a:round/>
+                      <a:headEnd type="none" w="med" len="med"/>
+                      <a:tailEnd type="none" w="med" len="med"/>
+                    </a:lnT>
+                    <a:lnB w="6350" cap="flat" cmpd="sng" algn="ctr">
+                      <a:solidFill>
+                        <a:srgbClr val="D6CFC4"/>
+                      </a:solidFill>
+                      <a:prstDash val="solid"/>
+                      <a:round/>
+                      <a:headEnd type="none" w="med" len="med"/>
+                      <a:tailEnd type="none" w="med" len="med"/>
+                    </a:lnB>
+                    <a:solidFill>
                       <a:srgbClr val="FFFFFF"/>
                     </a:solidFill>
                   </a:tcPr>
@@ -20217,7 +20149,75 @@
                           <a:ea typeface="Calibri" pitchFamily="34" charset="-122"/>
                           <a:cs typeface="Calibri" pitchFamily="34" charset="-120"/>
                         </a:rPr>
-                        <a:t>7.2%</a:t>
+                        <a:t>8.0%</a:t>
+                      </a:r>
+                      <a:endParaRPr lang="en-US" sz="1200" dirty="0">
+                        <a:latin typeface="Calibri" charset="0"/>
+                        <a:ea typeface="Calibri" charset="0"/>
+                        <a:cs typeface="Calibri" charset="0"/>
+                      </a:endParaRPr>
+                    </a:p>
+                  </a:txBody>
+                  <a:tcPr marL="91440" marR="91440" marT="45720" marB="45720" anchor="ctr">
+                    <a:lnL w="6350" cap="flat" cmpd="sng" algn="ctr">
+                      <a:solidFill>
+                        <a:srgbClr val="D6CFC4"/>
+                      </a:solidFill>
+                      <a:prstDash val="solid"/>
+                      <a:round/>
+                      <a:headEnd type="none" w="med" len="med"/>
+                      <a:tailEnd type="none" w="med" len="med"/>
+                    </a:lnL>
+                    <a:lnR w="6350" cap="flat" cmpd="sng" algn="ctr">
+                      <a:solidFill>
+                        <a:srgbClr val="D6CFC4"/>
+                      </a:solidFill>
+                      <a:prstDash val="solid"/>
+                      <a:round/>
+                      <a:headEnd type="none" w="med" len="med"/>
+                      <a:tailEnd type="none" w="med" len="med"/>
+                    </a:lnR>
+                    <a:lnT w="6350" cap="flat" cmpd="sng" algn="ctr">
+                      <a:solidFill>
+                        <a:srgbClr val="D6CFC4"/>
+                      </a:solidFill>
+                      <a:prstDash val="solid"/>
+                      <a:round/>
+                      <a:headEnd type="none" w="med" len="med"/>
+                      <a:tailEnd type="none" w="med" len="med"/>
+                    </a:lnT>
+                    <a:lnB w="6350" cap="flat" cmpd="sng" algn="ctr">
+                      <a:solidFill>
+                        <a:srgbClr val="D6CFC4"/>
+                      </a:solidFill>
+                      <a:prstDash val="solid"/>
+                      <a:round/>
+                      <a:headEnd type="none" w="med" len="med"/>
+                      <a:tailEnd type="none" w="med" len="med"/>
+                    </a:lnB>
+                    <a:solidFill>
+                      <a:srgbClr val="FFFFFF"/>
+                    </a:solidFill>
+                  </a:tcPr>
+                </a:tc>
+                <a:tc>
+                  <a:txBody>
+                    <a:bodyPr/>
+                    <a:lstStyle/>
+                    <a:p>
+                      <a:pPr algn="ctr" indent="0" marL="0">
+                        <a:buNone/>
+                      </a:pPr>
+                      <a:r>
+                        <a:rPr lang="en-US" sz="1200" dirty="0">
+                          <a:solidFill>
+                            <a:srgbClr val="2D2A26"/>
+                          </a:solidFill>
+                          <a:latin typeface="Calibri" pitchFamily="34" charset="0"/>
+                          <a:ea typeface="Calibri" pitchFamily="34" charset="-122"/>
+                          <a:cs typeface="Calibri" pitchFamily="34" charset="-120"/>
+                        </a:rPr>
+                        <a:t>8.4%</a:t>
                       </a:r>
                       <a:endParaRPr lang="en-US" sz="1200" dirty="0">
                         <a:latin typeface="Calibri" charset="0"/>
@@ -20355,7 +20355,7 @@
                           <a:ea typeface="Century Gothic" pitchFamily="34" charset="-122"/>
                           <a:cs typeface="Century Gothic" pitchFamily="34" charset="-120"/>
                         </a:rPr>
-                        <a:t>Tanzania</a:t>
+                        <a:t>Uganda</a:t>
                       </a:r>
                       <a:endParaRPr lang="en-US" sz="1200" dirty="0">
                         <a:latin typeface="Century Gothic" charset="0"/>
@@ -20423,7 +20423,7 @@
                           <a:ea typeface="Calibri" pitchFamily="34" charset="-122"/>
                           <a:cs typeface="Calibri" pitchFamily="34" charset="-120"/>
                         </a:rPr>
-                        <a:t>8.0%</a:t>
+                        <a:t>9.6%</a:t>
                       </a:r>
                       <a:endParaRPr lang="en-US" sz="1200" dirty="0">
                         <a:latin typeface="Calibri" charset="0"/>
@@ -20491,7 +20491,7 @@
                           <a:ea typeface="Calibri" pitchFamily="34" charset="-122"/>
                           <a:cs typeface="Calibri" pitchFamily="34" charset="-120"/>
                         </a:rPr>
-                        <a:t>8.4%</a:t>
+                        <a:t>11.2%</a:t>
                       </a:r>
                       <a:endParaRPr lang="en-US" sz="1200" dirty="0">
                         <a:latin typeface="Calibri" charset="0"/>
@@ -20971,7 +20971,7 @@
                           <a:ea typeface="Calibri" pitchFamily="34" charset="-122"/>
                           <a:cs typeface="Calibri" pitchFamily="34" charset="-120"/>
                         </a:rPr>
-                        <a:t>7.1%</a:t>
+                        <a:t>7.3%</a:t>
                       </a:r>
                       <a:endParaRPr lang="en-US" sz="1200" dirty="0">
                         <a:latin typeface="Calibri" charset="0"/>
@@ -21039,7 +21039,7 @@
                           <a:ea typeface="Calibri" pitchFamily="34" charset="-122"/>
                           <a:cs typeface="Calibri" pitchFamily="34" charset="-120"/>
                         </a:rPr>
-                        <a:t>7.6%</a:t>
+                        <a:t>11.2%</a:t>
                       </a:r>
                       <a:endParaRPr lang="en-US" sz="1200" dirty="0">
                         <a:latin typeface="Calibri" charset="0"/>
@@ -21789,280 +21789,6 @@
                           <a:ea typeface="Century Gothic" pitchFamily="34" charset="-122"/>
                           <a:cs typeface="Century Gothic" pitchFamily="34" charset="-120"/>
                         </a:rPr>
-                        <a:t>Uganda</a:t>
-                      </a:r>
-                      <a:endParaRPr lang="en-US" sz="1200" dirty="0">
-                        <a:latin typeface="Century Gothic" charset="0"/>
-                        <a:ea typeface="Century Gothic" charset="0"/>
-                        <a:cs typeface="Century Gothic" charset="0"/>
-                      </a:endParaRPr>
-                    </a:p>
-                  </a:txBody>
-                  <a:tcPr marL="91440" marR="91440" marT="45720" marB="45720" anchor="ctr">
-                    <a:lnL w="6350" cap="flat" cmpd="sng" algn="ctr">
-                      <a:solidFill>
-                        <a:srgbClr val="D6CFC4"/>
-                      </a:solidFill>
-                      <a:prstDash val="solid"/>
-                      <a:round/>
-                      <a:headEnd type="none" w="med" len="med"/>
-                      <a:tailEnd type="none" w="med" len="med"/>
-                    </a:lnL>
-                    <a:lnR w="6350" cap="flat" cmpd="sng" algn="ctr">
-                      <a:solidFill>
-                        <a:srgbClr val="D6CFC4"/>
-                      </a:solidFill>
-                      <a:prstDash val="solid"/>
-                      <a:round/>
-                      <a:headEnd type="none" w="med" len="med"/>
-                      <a:tailEnd type="none" w="med" len="med"/>
-                    </a:lnR>
-                    <a:lnT w="6350" cap="flat" cmpd="sng" algn="ctr">
-                      <a:solidFill>
-                        <a:srgbClr val="D6CFC4"/>
-                      </a:solidFill>
-                      <a:prstDash val="solid"/>
-                      <a:round/>
-                      <a:headEnd type="none" w="med" len="med"/>
-                      <a:tailEnd type="none" w="med" len="med"/>
-                    </a:lnT>
-                    <a:lnB w="6350" cap="flat" cmpd="sng" algn="ctr">
-                      <a:solidFill>
-                        <a:srgbClr val="D6CFC4"/>
-                      </a:solidFill>
-                      <a:prstDash val="solid"/>
-                      <a:round/>
-                      <a:headEnd type="none" w="med" len="med"/>
-                      <a:tailEnd type="none" w="med" len="med"/>
-                    </a:lnB>
-                    <a:solidFill>
-                      <a:srgbClr val="FFFFFF"/>
-                    </a:solidFill>
-                  </a:tcPr>
-                </a:tc>
-                <a:tc>
-                  <a:txBody>
-                    <a:bodyPr/>
-                    <a:lstStyle/>
-                    <a:p>
-                      <a:pPr algn="ctr" indent="0" marL="0">
-                        <a:buNone/>
-                      </a:pPr>
-                      <a:r>
-                        <a:rPr lang="en-US" sz="1200" dirty="0">
-                          <a:solidFill>
-                            <a:srgbClr val="2D2A26"/>
-                          </a:solidFill>
-                          <a:latin typeface="Calibri" pitchFamily="34" charset="0"/>
-                          <a:ea typeface="Calibri" pitchFamily="34" charset="-122"/>
-                          <a:cs typeface="Calibri" pitchFamily="34" charset="-120"/>
-                        </a:rPr>
-                        <a:t>—</a:t>
-                      </a:r>
-                      <a:endParaRPr lang="en-US" sz="1200" dirty="0">
-                        <a:latin typeface="Calibri" charset="0"/>
-                        <a:ea typeface="Calibri" charset="0"/>
-                        <a:cs typeface="Calibri" charset="0"/>
-                      </a:endParaRPr>
-                    </a:p>
-                  </a:txBody>
-                  <a:tcPr marL="91440" marR="91440" marT="45720" marB="45720" anchor="ctr">
-                    <a:lnL w="6350" cap="flat" cmpd="sng" algn="ctr">
-                      <a:solidFill>
-                        <a:srgbClr val="D6CFC4"/>
-                      </a:solidFill>
-                      <a:prstDash val="solid"/>
-                      <a:round/>
-                      <a:headEnd type="none" w="med" len="med"/>
-                      <a:tailEnd type="none" w="med" len="med"/>
-                    </a:lnL>
-                    <a:lnR w="6350" cap="flat" cmpd="sng" algn="ctr">
-                      <a:solidFill>
-                        <a:srgbClr val="D6CFC4"/>
-                      </a:solidFill>
-                      <a:prstDash val="solid"/>
-                      <a:round/>
-                      <a:headEnd type="none" w="med" len="med"/>
-                      <a:tailEnd type="none" w="med" len="med"/>
-                    </a:lnR>
-                    <a:lnT w="6350" cap="flat" cmpd="sng" algn="ctr">
-                      <a:solidFill>
-                        <a:srgbClr val="D6CFC4"/>
-                      </a:solidFill>
-                      <a:prstDash val="solid"/>
-                      <a:round/>
-                      <a:headEnd type="none" w="med" len="med"/>
-                      <a:tailEnd type="none" w="med" len="med"/>
-                    </a:lnT>
-                    <a:lnB w="6350" cap="flat" cmpd="sng" algn="ctr">
-                      <a:solidFill>
-                        <a:srgbClr val="D6CFC4"/>
-                      </a:solidFill>
-                      <a:prstDash val="solid"/>
-                      <a:round/>
-                      <a:headEnd type="none" w="med" len="med"/>
-                      <a:tailEnd type="none" w="med" len="med"/>
-                    </a:lnB>
-                    <a:solidFill>
-                      <a:srgbClr val="FFFFFF"/>
-                    </a:solidFill>
-                  </a:tcPr>
-                </a:tc>
-                <a:tc>
-                  <a:txBody>
-                    <a:bodyPr/>
-                    <a:lstStyle/>
-                    <a:p>
-                      <a:pPr algn="ctr" indent="0" marL="0">
-                        <a:buNone/>
-                      </a:pPr>
-                      <a:r>
-                        <a:rPr lang="en-US" sz="1200" dirty="0">
-                          <a:solidFill>
-                            <a:srgbClr val="2D2A26"/>
-                          </a:solidFill>
-                          <a:latin typeface="Calibri" pitchFamily="34" charset="0"/>
-                          <a:ea typeface="Calibri" pitchFamily="34" charset="-122"/>
-                          <a:cs typeface="Calibri" pitchFamily="34" charset="-120"/>
-                        </a:rPr>
-                        <a:t>—</a:t>
-                      </a:r>
-                      <a:endParaRPr lang="en-US" sz="1200" dirty="0">
-                        <a:latin typeface="Calibri" charset="0"/>
-                        <a:ea typeface="Calibri" charset="0"/>
-                        <a:cs typeface="Calibri" charset="0"/>
-                      </a:endParaRPr>
-                    </a:p>
-                  </a:txBody>
-                  <a:tcPr marL="91440" marR="91440" marT="45720" marB="45720" anchor="ctr">
-                    <a:lnL w="6350" cap="flat" cmpd="sng" algn="ctr">
-                      <a:solidFill>
-                        <a:srgbClr val="D6CFC4"/>
-                      </a:solidFill>
-                      <a:prstDash val="solid"/>
-                      <a:round/>
-                      <a:headEnd type="none" w="med" len="med"/>
-                      <a:tailEnd type="none" w="med" len="med"/>
-                    </a:lnL>
-                    <a:lnR w="6350" cap="flat" cmpd="sng" algn="ctr">
-                      <a:solidFill>
-                        <a:srgbClr val="D6CFC4"/>
-                      </a:solidFill>
-                      <a:prstDash val="solid"/>
-                      <a:round/>
-                      <a:headEnd type="none" w="med" len="med"/>
-                      <a:tailEnd type="none" w="med" len="med"/>
-                    </a:lnR>
-                    <a:lnT w="6350" cap="flat" cmpd="sng" algn="ctr">
-                      <a:solidFill>
-                        <a:srgbClr val="D6CFC4"/>
-                      </a:solidFill>
-                      <a:prstDash val="solid"/>
-                      <a:round/>
-                      <a:headEnd type="none" w="med" len="med"/>
-                      <a:tailEnd type="none" w="med" len="med"/>
-                    </a:lnT>
-                    <a:lnB w="6350" cap="flat" cmpd="sng" algn="ctr">
-                      <a:solidFill>
-                        <a:srgbClr val="D6CFC4"/>
-                      </a:solidFill>
-                      <a:prstDash val="solid"/>
-                      <a:round/>
-                      <a:headEnd type="none" w="med" len="med"/>
-                      <a:tailEnd type="none" w="med" len="med"/>
-                    </a:lnB>
-                    <a:solidFill>
-                      <a:srgbClr val="FFFFFF"/>
-                    </a:solidFill>
-                  </a:tcPr>
-                </a:tc>
-                <a:tc>
-                  <a:txBody>
-                    <a:bodyPr/>
-                    <a:lstStyle/>
-                    <a:p>
-                      <a:pPr algn="ctr" indent="0" marL="0">
-                        <a:buNone/>
-                      </a:pPr>
-                      <a:r>
-                        <a:rPr lang="en-US" sz="1200" dirty="0">
-                          <a:solidFill>
-                            <a:srgbClr val="718096"/>
-                          </a:solidFill>
-                          <a:latin typeface="Calibri" pitchFamily="34" charset="0"/>
-                          <a:ea typeface="Calibri" pitchFamily="34" charset="-122"/>
-                          <a:cs typeface="Calibri" pitchFamily="34" charset="-120"/>
-                        </a:rPr>
-                        <a:t>—</a:t>
-                      </a:r>
-                      <a:endParaRPr lang="en-US" sz="1200" dirty="0">
-                        <a:latin typeface="Calibri" charset="0"/>
-                        <a:ea typeface="Calibri" charset="0"/>
-                        <a:cs typeface="Calibri" charset="0"/>
-                      </a:endParaRPr>
-                    </a:p>
-                  </a:txBody>
-                  <a:tcPr marL="91440" marR="91440" marT="45720" marB="45720" anchor="ctr">
-                    <a:lnL w="6350" cap="flat" cmpd="sng" algn="ctr">
-                      <a:solidFill>
-                        <a:srgbClr val="D6CFC4"/>
-                      </a:solidFill>
-                      <a:prstDash val="solid"/>
-                      <a:round/>
-                      <a:headEnd type="none" w="med" len="med"/>
-                      <a:tailEnd type="none" w="med" len="med"/>
-                    </a:lnL>
-                    <a:lnR w="6350" cap="flat" cmpd="sng" algn="ctr">
-                      <a:solidFill>
-                        <a:srgbClr val="D6CFC4"/>
-                      </a:solidFill>
-                      <a:prstDash val="solid"/>
-                      <a:round/>
-                      <a:headEnd type="none" w="med" len="med"/>
-                      <a:tailEnd type="none" w="med" len="med"/>
-                    </a:lnR>
-                    <a:lnT w="6350" cap="flat" cmpd="sng" algn="ctr">
-                      <a:solidFill>
-                        <a:srgbClr val="D6CFC4"/>
-                      </a:solidFill>
-                      <a:prstDash val="solid"/>
-                      <a:round/>
-                      <a:headEnd type="none" w="med" len="med"/>
-                      <a:tailEnd type="none" w="med" len="med"/>
-                    </a:lnT>
-                    <a:lnB w="6350" cap="flat" cmpd="sng" algn="ctr">
-                      <a:solidFill>
-                        <a:srgbClr val="D6CFC4"/>
-                      </a:solidFill>
-                      <a:prstDash val="solid"/>
-                      <a:round/>
-                      <a:headEnd type="none" w="med" len="med"/>
-                      <a:tailEnd type="none" w="med" len="med"/>
-                    </a:lnB>
-                    <a:solidFill>
-                      <a:srgbClr val="FFFFFF"/>
-                    </a:solidFill>
-                  </a:tcPr>
-                </a:tc>
-              </a:tr>
-              <a:tr h="384048">
-                <a:tc>
-                  <a:txBody>
-                    <a:bodyPr/>
-                    <a:lstStyle/>
-                    <a:p>
-                      <a:pPr algn="l" indent="0" marL="0">
-                        <a:buNone/>
-                      </a:pPr>
-                      <a:r>
-                        <a:rPr lang="en-US" sz="1200" b="1" dirty="0">
-                          <a:solidFill>
-                            <a:srgbClr val="2D2A26"/>
-                          </a:solidFill>
-                          <a:latin typeface="Century Gothic" pitchFamily="34" charset="0"/>
-                          <a:ea typeface="Century Gothic" pitchFamily="34" charset="-122"/>
-                          <a:cs typeface="Century Gothic" pitchFamily="34" charset="-120"/>
-                        </a:rPr>
                         <a:t>Sierra Leone</a:t>
                       </a:r>
                       <a:endParaRPr lang="en-US" sz="1200" dirty="0">
@@ -22110,7 +21836,7 @@
                       <a:tailEnd type="none" w="med" len="med"/>
                     </a:lnB>
                     <a:solidFill>
-                      <a:srgbClr val="FFF9D9"/>
+                      <a:srgbClr val="FFFFFF"/>
                     </a:solidFill>
                   </a:tcPr>
                 </a:tc>
@@ -22178,7 +21904,7 @@
                       <a:tailEnd type="none" w="med" len="med"/>
                     </a:lnB>
                     <a:solidFill>
-                      <a:srgbClr val="FFF9D9"/>
+                      <a:srgbClr val="FFFFFF"/>
                     </a:solidFill>
                   </a:tcPr>
                 </a:tc>
@@ -22246,7 +21972,7 @@
                       <a:tailEnd type="none" w="med" len="med"/>
                     </a:lnB>
                     <a:solidFill>
-                      <a:srgbClr val="FFF9D9"/>
+                      <a:srgbClr val="FFFFFF"/>
                     </a:solidFill>
                   </a:tcPr>
                 </a:tc>
@@ -22314,7 +22040,7 @@
                       <a:tailEnd type="none" w="med" len="med"/>
                     </a:lnB>
                     <a:solidFill>
-                      <a:srgbClr val="FFF9D9"/>
+                      <a:srgbClr val="FFFFFF"/>
                     </a:solidFill>
                   </a:tcPr>
                 </a:tc>
@@ -22384,7 +22110,7 @@
                       <a:tailEnd type="none" w="med" len="med"/>
                     </a:lnB>
                     <a:solidFill>
-                      <a:srgbClr val="FFFFFF"/>
+                      <a:srgbClr val="FFF9D9"/>
                     </a:solidFill>
                   </a:tcPr>
                 </a:tc>
@@ -22452,6 +22178,212 @@
                       <a:tailEnd type="none" w="med" len="med"/>
                     </a:lnB>
                     <a:solidFill>
+                      <a:srgbClr val="FFF9D9"/>
+                    </a:solidFill>
+                  </a:tcPr>
+                </a:tc>
+                <a:tc>
+                  <a:txBody>
+                    <a:bodyPr/>
+                    <a:lstStyle/>
+                    <a:p>
+                      <a:pPr algn="ctr" indent="0" marL="0">
+                        <a:buNone/>
+                      </a:pPr>
+                      <a:r>
+                        <a:rPr lang="en-US" sz="1200" dirty="0">
+                          <a:solidFill>
+                            <a:srgbClr val="2D2A26"/>
+                          </a:solidFill>
+                          <a:latin typeface="Calibri" pitchFamily="34" charset="0"/>
+                          <a:ea typeface="Calibri" pitchFamily="34" charset="-122"/>
+                          <a:cs typeface="Calibri" pitchFamily="34" charset="-120"/>
+                        </a:rPr>
+                        <a:t>7.6%</a:t>
+                      </a:r>
+                      <a:endParaRPr lang="en-US" sz="1200" dirty="0">
+                        <a:latin typeface="Calibri" charset="0"/>
+                        <a:ea typeface="Calibri" charset="0"/>
+                        <a:cs typeface="Calibri" charset="0"/>
+                      </a:endParaRPr>
+                    </a:p>
+                  </a:txBody>
+                  <a:tcPr marL="91440" marR="91440" marT="45720" marB="45720" anchor="ctr">
+                    <a:lnL w="6350" cap="flat" cmpd="sng" algn="ctr">
+                      <a:solidFill>
+                        <a:srgbClr val="D6CFC4"/>
+                      </a:solidFill>
+                      <a:prstDash val="solid"/>
+                      <a:round/>
+                      <a:headEnd type="none" w="med" len="med"/>
+                      <a:tailEnd type="none" w="med" len="med"/>
+                    </a:lnL>
+                    <a:lnR w="6350" cap="flat" cmpd="sng" algn="ctr">
+                      <a:solidFill>
+                        <a:srgbClr val="D6CFC4"/>
+                      </a:solidFill>
+                      <a:prstDash val="solid"/>
+                      <a:round/>
+                      <a:headEnd type="none" w="med" len="med"/>
+                      <a:tailEnd type="none" w="med" len="med"/>
+                    </a:lnR>
+                    <a:lnT w="6350" cap="flat" cmpd="sng" algn="ctr">
+                      <a:solidFill>
+                        <a:srgbClr val="D6CFC4"/>
+                      </a:solidFill>
+                      <a:prstDash val="solid"/>
+                      <a:round/>
+                      <a:headEnd type="none" w="med" len="med"/>
+                      <a:tailEnd type="none" w="med" len="med"/>
+                    </a:lnT>
+                    <a:lnB w="6350" cap="flat" cmpd="sng" algn="ctr">
+                      <a:solidFill>
+                        <a:srgbClr val="D6CFC4"/>
+                      </a:solidFill>
+                      <a:prstDash val="solid"/>
+                      <a:round/>
+                      <a:headEnd type="none" w="med" len="med"/>
+                      <a:tailEnd type="none" w="med" len="med"/>
+                    </a:lnB>
+                    <a:solidFill>
+                      <a:srgbClr val="FFF9D9"/>
+                    </a:solidFill>
+                  </a:tcPr>
+                </a:tc>
+                <a:tc>
+                  <a:txBody>
+                    <a:bodyPr/>
+                    <a:lstStyle/>
+                    <a:p>
+                      <a:pPr algn="ctr" indent="0" marL="0">
+                        <a:buNone/>
+                      </a:pPr>
+                      <a:r>
+                        <a:rPr lang="en-US" sz="1200" dirty="0">
+                          <a:solidFill>
+                            <a:srgbClr val="C0392B"/>
+                          </a:solidFill>
+                          <a:latin typeface="Calibri" pitchFamily="34" charset="0"/>
+                          <a:ea typeface="Calibri" pitchFamily="34" charset="-122"/>
+                          <a:cs typeface="Calibri" pitchFamily="34" charset="-120"/>
+                        </a:rPr>
+                        <a:t>↑</a:t>
+                      </a:r>
+                      <a:endParaRPr lang="en-US" sz="1200" dirty="0">
+                        <a:latin typeface="Calibri" charset="0"/>
+                        <a:ea typeface="Calibri" charset="0"/>
+                        <a:cs typeface="Calibri" charset="0"/>
+                      </a:endParaRPr>
+                    </a:p>
+                  </a:txBody>
+                  <a:tcPr marL="91440" marR="91440" marT="45720" marB="45720" anchor="ctr">
+                    <a:lnL w="6350" cap="flat" cmpd="sng" algn="ctr">
+                      <a:solidFill>
+                        <a:srgbClr val="D6CFC4"/>
+                      </a:solidFill>
+                      <a:prstDash val="solid"/>
+                      <a:round/>
+                      <a:headEnd type="none" w="med" len="med"/>
+                      <a:tailEnd type="none" w="med" len="med"/>
+                    </a:lnL>
+                    <a:lnR w="6350" cap="flat" cmpd="sng" algn="ctr">
+                      <a:solidFill>
+                        <a:srgbClr val="D6CFC4"/>
+                      </a:solidFill>
+                      <a:prstDash val="solid"/>
+                      <a:round/>
+                      <a:headEnd type="none" w="med" len="med"/>
+                      <a:tailEnd type="none" w="med" len="med"/>
+                    </a:lnR>
+                    <a:lnT w="6350" cap="flat" cmpd="sng" algn="ctr">
+                      <a:solidFill>
+                        <a:srgbClr val="D6CFC4"/>
+                      </a:solidFill>
+                      <a:prstDash val="solid"/>
+                      <a:round/>
+                      <a:headEnd type="none" w="med" len="med"/>
+                      <a:tailEnd type="none" w="med" len="med"/>
+                    </a:lnT>
+                    <a:lnB w="6350" cap="flat" cmpd="sng" algn="ctr">
+                      <a:solidFill>
+                        <a:srgbClr val="D6CFC4"/>
+                      </a:solidFill>
+                      <a:prstDash val="solid"/>
+                      <a:round/>
+                      <a:headEnd type="none" w="med" len="med"/>
+                      <a:tailEnd type="none" w="med" len="med"/>
+                    </a:lnB>
+                    <a:solidFill>
+                      <a:srgbClr val="FFF9D9"/>
+                    </a:solidFill>
+                  </a:tcPr>
+                </a:tc>
+              </a:tr>
+              <a:tr h="384048">
+                <a:tc>
+                  <a:txBody>
+                    <a:bodyPr/>
+                    <a:lstStyle/>
+                    <a:p>
+                      <a:pPr algn="l" indent="0" marL="0">
+                        <a:buNone/>
+                      </a:pPr>
+                      <a:r>
+                        <a:rPr lang="en-US" sz="1200" b="1" dirty="0">
+                          <a:solidFill>
+                            <a:srgbClr val="2D2A26"/>
+                          </a:solidFill>
+                          <a:latin typeface="Century Gothic" pitchFamily="34" charset="0"/>
+                          <a:ea typeface="Century Gothic" pitchFamily="34" charset="-122"/>
+                          <a:cs typeface="Century Gothic" pitchFamily="34" charset="-120"/>
+                        </a:rPr>
+                        <a:t>Tanzania</a:t>
+                      </a:r>
+                      <a:endParaRPr lang="en-US" sz="1200" dirty="0">
+                        <a:latin typeface="Century Gothic" charset="0"/>
+                        <a:ea typeface="Century Gothic" charset="0"/>
+                        <a:cs typeface="Century Gothic" charset="0"/>
+                      </a:endParaRPr>
+                    </a:p>
+                  </a:txBody>
+                  <a:tcPr marL="91440" marR="91440" marT="45720" marB="45720" anchor="ctr">
+                    <a:lnL w="6350" cap="flat" cmpd="sng" algn="ctr">
+                      <a:solidFill>
+                        <a:srgbClr val="D6CFC4"/>
+                      </a:solidFill>
+                      <a:prstDash val="solid"/>
+                      <a:round/>
+                      <a:headEnd type="none" w="med" len="med"/>
+                      <a:tailEnd type="none" w="med" len="med"/>
+                    </a:lnL>
+                    <a:lnR w="6350" cap="flat" cmpd="sng" algn="ctr">
+                      <a:solidFill>
+                        <a:srgbClr val="D6CFC4"/>
+                      </a:solidFill>
+                      <a:prstDash val="solid"/>
+                      <a:round/>
+                      <a:headEnd type="none" w="med" len="med"/>
+                      <a:tailEnd type="none" w="med" len="med"/>
+                    </a:lnR>
+                    <a:lnT w="6350" cap="flat" cmpd="sng" algn="ctr">
+                      <a:solidFill>
+                        <a:srgbClr val="D6CFC4"/>
+                      </a:solidFill>
+                      <a:prstDash val="solid"/>
+                      <a:round/>
+                      <a:headEnd type="none" w="med" len="med"/>
+                      <a:tailEnd type="none" w="med" len="med"/>
+                    </a:lnT>
+                    <a:lnB w="6350" cap="flat" cmpd="sng" algn="ctr">
+                      <a:solidFill>
+                        <a:srgbClr val="D6CFC4"/>
+                      </a:solidFill>
+                      <a:prstDash val="solid"/>
+                      <a:round/>
+                      <a:headEnd type="none" w="med" len="med"/>
+                      <a:tailEnd type="none" w="med" len="med"/>
+                    </a:lnB>
+                    <a:solidFill>
                       <a:srgbClr val="FFFFFF"/>
                     </a:solidFill>
                   </a:tcPr>
@@ -22473,7 +22405,75 @@
                           <a:ea typeface="Calibri" pitchFamily="34" charset="-122"/>
                           <a:cs typeface="Calibri" pitchFamily="34" charset="-120"/>
                         </a:rPr>
-                        <a:t>7.6%</a:t>
+                        <a:t>8.2%</a:t>
+                      </a:r>
+                      <a:endParaRPr lang="en-US" sz="1200" dirty="0">
+                        <a:latin typeface="Calibri" charset="0"/>
+                        <a:ea typeface="Calibri" charset="0"/>
+                        <a:cs typeface="Calibri" charset="0"/>
+                      </a:endParaRPr>
+                    </a:p>
+                  </a:txBody>
+                  <a:tcPr marL="91440" marR="91440" marT="45720" marB="45720" anchor="ctr">
+                    <a:lnL w="6350" cap="flat" cmpd="sng" algn="ctr">
+                      <a:solidFill>
+                        <a:srgbClr val="D6CFC4"/>
+                      </a:solidFill>
+                      <a:prstDash val="solid"/>
+                      <a:round/>
+                      <a:headEnd type="none" w="med" len="med"/>
+                      <a:tailEnd type="none" w="med" len="med"/>
+                    </a:lnL>
+                    <a:lnR w="6350" cap="flat" cmpd="sng" algn="ctr">
+                      <a:solidFill>
+                        <a:srgbClr val="D6CFC4"/>
+                      </a:solidFill>
+                      <a:prstDash val="solid"/>
+                      <a:round/>
+                      <a:headEnd type="none" w="med" len="med"/>
+                      <a:tailEnd type="none" w="med" len="med"/>
+                    </a:lnR>
+                    <a:lnT w="6350" cap="flat" cmpd="sng" algn="ctr">
+                      <a:solidFill>
+                        <a:srgbClr val="D6CFC4"/>
+                      </a:solidFill>
+                      <a:prstDash val="solid"/>
+                      <a:round/>
+                      <a:headEnd type="none" w="med" len="med"/>
+                      <a:tailEnd type="none" w="med" len="med"/>
+                    </a:lnT>
+                    <a:lnB w="6350" cap="flat" cmpd="sng" algn="ctr">
+                      <a:solidFill>
+                        <a:srgbClr val="D6CFC4"/>
+                      </a:solidFill>
+                      <a:prstDash val="solid"/>
+                      <a:round/>
+                      <a:headEnd type="none" w="med" len="med"/>
+                      <a:tailEnd type="none" w="med" len="med"/>
+                    </a:lnB>
+                    <a:solidFill>
+                      <a:srgbClr val="FFFFFF"/>
+                    </a:solidFill>
+                  </a:tcPr>
+                </a:tc>
+                <a:tc>
+                  <a:txBody>
+                    <a:bodyPr/>
+                    <a:lstStyle/>
+                    <a:p>
+                      <a:pPr algn="ctr" indent="0" marL="0">
+                        <a:buNone/>
+                      </a:pPr>
+                      <a:r>
+                        <a:rPr lang="en-US" sz="1200" dirty="0">
+                          <a:solidFill>
+                            <a:srgbClr val="2D2A26"/>
+                          </a:solidFill>
+                          <a:latin typeface="Calibri" pitchFamily="34" charset="0"/>
+                          <a:ea typeface="Calibri" pitchFamily="34" charset="-122"/>
+                          <a:cs typeface="Calibri" pitchFamily="34" charset="-120"/>
+                        </a:rPr>
+                        <a:t>9.9%</a:t>
                       </a:r>
                       <a:endParaRPr lang="en-US" sz="1200" dirty="0">
                         <a:latin typeface="Calibri" charset="0"/>
@@ -22611,7 +22611,7 @@
                           <a:ea typeface="Century Gothic" pitchFamily="34" charset="-122"/>
                           <a:cs typeface="Century Gothic" pitchFamily="34" charset="-120"/>
                         </a:rPr>
-                        <a:t>Tanzania</a:t>
+                        <a:t>Uganda</a:t>
                       </a:r>
                       <a:endParaRPr lang="en-US" sz="1200" dirty="0">
                         <a:latin typeface="Century Gothic" charset="0"/>
@@ -22679,7 +22679,7 @@
                           <a:ea typeface="Calibri" pitchFamily="34" charset="-122"/>
                           <a:cs typeface="Calibri" pitchFamily="34" charset="-120"/>
                         </a:rPr>
-                        <a:t>8.2%</a:t>
+                        <a:t>14.3%</a:t>
                       </a:r>
                       <a:endParaRPr lang="en-US" sz="1200" dirty="0">
                         <a:latin typeface="Calibri" charset="0"/>
@@ -22747,7 +22747,7 @@
                           <a:ea typeface="Calibri" pitchFamily="34" charset="-122"/>
                           <a:cs typeface="Calibri" pitchFamily="34" charset="-120"/>
                         </a:rPr>
-                        <a:t>9.9%</a:t>
+                        <a:t>12.2%</a:t>
                       </a:r>
                       <a:endParaRPr lang="en-US" sz="1200" dirty="0">
                         <a:latin typeface="Calibri" charset="0"/>
@@ -22809,13 +22809,13 @@
                       <a:r>
                         <a:rPr lang="en-US" sz="1200" dirty="0">
                           <a:solidFill>
-                            <a:srgbClr val="C0392B"/>
+                            <a:srgbClr val="1A7A6E"/>
                           </a:solidFill>
                           <a:latin typeface="Calibri" pitchFamily="34" charset="0"/>
                           <a:ea typeface="Calibri" pitchFamily="34" charset="-122"/>
                           <a:cs typeface="Calibri" pitchFamily="34" charset="-120"/>
                         </a:rPr>
-                        <a:t>↑</a:t>
+                        <a:t>↓</a:t>
                       </a:r>
                       <a:endParaRPr lang="en-US" sz="1200" dirty="0">
                         <a:latin typeface="Calibri" charset="0"/>
@@ -23227,7 +23227,7 @@
                           <a:ea typeface="Calibri" pitchFamily="34" charset="-122"/>
                           <a:cs typeface="Calibri" pitchFamily="34" charset="-120"/>
                         </a:rPr>
-                        <a:t>7.6%</a:t>
+                        <a:t>8.2%</a:t>
                       </a:r>
                       <a:endParaRPr lang="en-US" sz="1200" dirty="0">
                         <a:latin typeface="Calibri" charset="0"/>
@@ -23295,7 +23295,7 @@
                           <a:ea typeface="Calibri" pitchFamily="34" charset="-122"/>
                           <a:cs typeface="Calibri" pitchFamily="34" charset="-120"/>
                         </a:rPr>
-                        <a:t>8.4%</a:t>
+                        <a:t>12.2%</a:t>
                       </a:r>
                       <a:endParaRPr lang="en-US" sz="1200" dirty="0">
                         <a:latin typeface="Calibri" charset="0"/>

</xml_diff>

<commit_message>
Auto-build: 2026-05-08 17:33 UTC
</commit_message>
<xml_diff>
--- a/reports/2026-04.pptx
+++ b/reports/2026-04.pptx
@@ -1138,16 +1138,16 @@
                 <c:ptCount val="5"/>
                 <c:lvl>
                   <c:pt idx="0">
-                    <c:v>Uganda</c:v>
+                    <c:v>Tanzania</c:v>
                   </c:pt>
                   <c:pt idx="1">
-                    <c:v>Tanzania</c:v>
+                    <c:v>Kenya</c:v>
                   </c:pt>
                   <c:pt idx="2">
-                    <c:v>Kenya</c:v>
+                    <c:v>Sierra Leone</c:v>
                   </c:pt>
                   <c:pt idx="3">
-                    <c:v>Sierra Leone</c:v>
+                    <c:v>Uganda</c:v>
                   </c:pt>
                   <c:pt idx="4">
                     <c:v>Nigeria</c:v>
@@ -1163,16 +1163,16 @@
                 <c:formatCode>General</c:formatCode>
                 <c:ptCount val="5"/>
                 <c:pt idx="0">
-                  <c:v>1958650000</c:v>
+                  <c:v>2578766.939</c:v>
                 </c:pt>
                 <c:pt idx="1">
-                  <c:v>2578766.939</c:v>
+                  <c:v>1665440.892</c:v>
                 </c:pt>
                 <c:pt idx="2">
-                  <c:v>1665440.892</c:v>
+                  <c:v>670923.5772</c:v>
                 </c:pt>
                 <c:pt idx="3">
-                  <c:v>670923.5772</c:v>
+                  <c:v>533692.0981</c:v>
                 </c:pt>
                 <c:pt idx="4">
                   <c:v>177919.708</c:v>
@@ -1438,16 +1438,16 @@
                 <c:ptCount val="5"/>
                 <c:lvl>
                   <c:pt idx="0">
-                    <c:v>Uganda</c:v>
+                    <c:v>Tanzania</c:v>
                   </c:pt>
                   <c:pt idx="1">
-                    <c:v>Tanzania</c:v>
+                    <c:v>Kenya</c:v>
                   </c:pt>
                   <c:pt idx="2">
-                    <c:v>Kenya</c:v>
+                    <c:v>Sierra Leone</c:v>
                   </c:pt>
                   <c:pt idx="3">
-                    <c:v>Sierra Leone</c:v>
+                    <c:v>Uganda</c:v>
                   </c:pt>
                   <c:pt idx="4">
                     <c:v>Nigeria</c:v>
@@ -1463,16 +1463,16 @@
                 <c:formatCode>General</c:formatCode>
                 <c:ptCount val="5"/>
                 <c:pt idx="0">
-                  <c:v>779407.0832</c:v>
+                  <c:v>231.8618</c:v>
                 </c:pt>
                 <c:pt idx="1">
-                  <c:v>231.8618</c:v>
+                  <c:v>289.793091</c:v>
                 </c:pt>
                 <c:pt idx="2">
-                  <c:v>289.793091</c:v>
+                  <c:v>457.03241</c:v>
                 </c:pt>
                 <c:pt idx="3">
-                  <c:v>457.03241</c:v>
+                  <c:v>212.372502</c:v>
                 </c:pt>
                 <c:pt idx="4">
                   <c:v>169.770714</c:v>
@@ -1738,16 +1738,16 @@
                 <c:ptCount val="5"/>
                 <c:lvl>
                   <c:pt idx="0">
-                    <c:v>Uganda</c:v>
+                    <c:v>Tanzania</c:v>
                   </c:pt>
                   <c:pt idx="1">
-                    <c:v>Tanzania</c:v>
+                    <c:v>Kenya</c:v>
                   </c:pt>
                   <c:pt idx="2">
-                    <c:v>Kenya</c:v>
+                    <c:v>Sierra Leone</c:v>
                   </c:pt>
                   <c:pt idx="3">
-                    <c:v>Sierra Leone</c:v>
+                    <c:v>Uganda</c:v>
                   </c:pt>
                   <c:pt idx="4">
                     <c:v>Nigeria</c:v>
@@ -1763,16 +1763,16 @@
                 <c:formatCode>General</c:formatCode>
                 <c:ptCount val="5"/>
                 <c:pt idx="0">
-                  <c:v>68</c:v>
+                  <c:v>141</c:v>
                 </c:pt>
                 <c:pt idx="1">
-                  <c:v>141</c:v>
+                  <c:v>76</c:v>
                 </c:pt>
                 <c:pt idx="2">
-                  <c:v>76</c:v>
+                  <c:v>26</c:v>
                 </c:pt>
                 <c:pt idx="3">
-                  <c:v>26</c:v>
+                  <c:v>68</c:v>
                 </c:pt>
                 <c:pt idx="4">
                   <c:v>66</c:v>
@@ -2338,13 +2338,13 @@
                 <c:ptCount val="5"/>
                 <c:lvl>
                   <c:pt idx="0">
-                    <c:v>Uganda</c:v>
+                    <c:v>Tanzania</c:v>
                   </c:pt>
                   <c:pt idx="1">
-                    <c:v>Tanzania</c:v>
+                    <c:v>Kenya</c:v>
                   </c:pt>
                   <c:pt idx="2">
-                    <c:v>Kenya</c:v>
+                    <c:v>Uganda</c:v>
                   </c:pt>
                   <c:pt idx="3">
                     <c:v>Sierra Leone</c:v>
@@ -2363,13 +2363,13 @@
                 <c:formatCode>General</c:formatCode>
                 <c:ptCount val="5"/>
                 <c:pt idx="0">
-                  <c:v>5080472080</c:v>
+                  <c:v>6528403.079</c:v>
                 </c:pt>
                 <c:pt idx="1">
-                  <c:v>6528403.079</c:v>
+                  <c:v>4047098.07</c:v>
                 </c:pt>
                 <c:pt idx="2">
-                  <c:v>4047098.07</c:v>
+                  <c:v>1384324.817</c:v>
                 </c:pt>
                 <c:pt idx="3">
                   <c:v>1367460.185</c:v>
@@ -14548,45 +14548,6 @@
             <a:r>
               <a:rPr lang="en-US" sz="1200" b="1" dirty="0">
                 <a:solidFill>
-                  <a:srgbClr val="1A7A6E"/>
-                </a:solidFill>
-                <a:latin typeface="Calibri" pitchFamily="34" charset="0"/>
-                <a:ea typeface="Calibri" pitchFamily="34" charset="-122"/>
-                <a:cs typeface="Calibri" pitchFamily="34" charset="-120"/>
-              </a:rPr>
-              <a:t>+355244.0%</a:t>
-            </a:r>
-            <a:endParaRPr lang="en-US" sz="1200" dirty="0"/>
-          </a:p>
-        </p:txBody>
-      </p:sp>
-      <p:sp>
-        <p:nvSpPr>
-          <p:cNvPr id="16" name="Text 13"/>
-          <p:cNvSpPr/>
-          <p:nvPr/>
-        </p:nvSpPr>
-        <p:spPr>
-          <a:xfrm>
-            <a:off x="1655064" y="5925312"/>
-            <a:ext cx="1517904" cy="347472"/>
-          </a:xfrm>
-          <a:prstGeom prst="rect">
-            <a:avLst/>
-          </a:prstGeom>
-          <a:noFill/>
-          <a:ln/>
-        </p:spPr>
-        <p:txBody>
-          <a:bodyPr wrap="square" rtlCol="0" anchor="ctr"/>
-          <a:lstStyle/>
-          <a:p>
-            <a:pPr algn="ctr" indent="0" marL="0">
-              <a:buNone/>
-            </a:pPr>
-            <a:r>
-              <a:rPr lang="en-US" sz="1200" b="1" dirty="0">
-                <a:solidFill>
                   <a:srgbClr val="C0392B"/>
                 </a:solidFill>
                 <a:latin typeface="Calibri" pitchFamily="34" charset="0"/>
@@ -14601,13 +14562,13 @@
       </p:sp>
       <p:sp>
         <p:nvSpPr>
-          <p:cNvPr id="17" name="Text 14"/>
-          <p:cNvSpPr/>
-          <p:nvPr/>
-        </p:nvSpPr>
-        <p:spPr>
-          <a:xfrm>
-            <a:off x="3172968" y="5925312"/>
+          <p:cNvPr id="16" name="Text 13"/>
+          <p:cNvSpPr/>
+          <p:nvPr/>
+        </p:nvSpPr>
+        <p:spPr>
+          <a:xfrm>
+            <a:off x="1655064" y="5925312"/>
             <a:ext cx="1517904" cy="347472"/>
           </a:xfrm>
           <a:prstGeom prst="rect">
@@ -14640,13 +14601,13 @@
       </p:sp>
       <p:sp>
         <p:nvSpPr>
-          <p:cNvPr id="18" name="Text 15"/>
-          <p:cNvSpPr/>
-          <p:nvPr/>
-        </p:nvSpPr>
-        <p:spPr>
-          <a:xfrm>
-            <a:off x="4690872" y="5925312"/>
+          <p:cNvPr id="17" name="Text 14"/>
+          <p:cNvSpPr/>
+          <p:nvPr/>
+        </p:nvSpPr>
+        <p:spPr>
+          <a:xfrm>
+            <a:off x="3172968" y="5925312"/>
             <a:ext cx="1517904" cy="347472"/>
           </a:xfrm>
           <a:prstGeom prst="rect">
@@ -14672,6 +14633,45 @@
                 <a:cs typeface="Calibri" pitchFamily="34" charset="-120"/>
               </a:rPr>
               <a:t>+1.6%</a:t>
+            </a:r>
+            <a:endParaRPr lang="en-US" sz="1200" dirty="0"/>
+          </a:p>
+        </p:txBody>
+      </p:sp>
+      <p:sp>
+        <p:nvSpPr>
+          <p:cNvPr id="18" name="Text 15"/>
+          <p:cNvSpPr/>
+          <p:nvPr/>
+        </p:nvSpPr>
+        <p:spPr>
+          <a:xfrm>
+            <a:off x="4690872" y="5925312"/>
+            <a:ext cx="1517904" cy="347472"/>
+          </a:xfrm>
+          <a:prstGeom prst="rect">
+            <a:avLst/>
+          </a:prstGeom>
+          <a:noFill/>
+          <a:ln/>
+        </p:spPr>
+        <p:txBody>
+          <a:bodyPr wrap="square" rtlCol="0" anchor="ctr"/>
+          <a:lstStyle/>
+          <a:p>
+            <a:pPr algn="ctr" indent="0" marL="0">
+              <a:buNone/>
+            </a:pPr>
+            <a:r>
+              <a:rPr lang="en-US" sz="1200" b="1" dirty="0">
+                <a:solidFill>
+                  <a:srgbClr val="C0392B"/>
+                </a:solidFill>
+                <a:latin typeface="Calibri" pitchFamily="34" charset="0"/>
+                <a:ea typeface="Calibri" pitchFamily="34" charset="-122"/>
+                <a:cs typeface="Calibri" pitchFamily="34" charset="-120"/>
+              </a:rPr>
+              <a:t>-3.2%</a:t>
             </a:r>
             <a:endParaRPr lang="en-US" sz="1200" dirty="0"/>
           </a:p>
@@ -14806,7 +14806,7 @@
                 <a:ea typeface="Century Gothic" pitchFamily="34" charset="-122"/>
                 <a:cs typeface="Century Gothic" pitchFamily="34" charset="-120"/>
               </a:rPr>
-              <a:t>$1,963,743,051</a:t>
+              <a:t>$5,626,743</a:t>
             </a:r>
             <a:endParaRPr lang="en-US" sz="2600" dirty="0"/>
           </a:p>
@@ -14941,7 +14941,7 @@
                 <a:ea typeface="Century Gothic" pitchFamily="34" charset="-122"/>
                 <a:cs typeface="Century Gothic" pitchFamily="34" charset="-120"/>
               </a:rPr>
-              <a:t>+31627.6%</a:t>
+              <a:t>-9.1%</a:t>
             </a:r>
             <a:endParaRPr lang="en-US" sz="2600" dirty="0"/>
           </a:p>
@@ -15268,6 +15268,315 @@
                 <a:ea typeface="Calibri" pitchFamily="34" charset="-122"/>
                 <a:cs typeface="Calibri" pitchFamily="34" charset="-120"/>
               </a:rPr>
+              <a:t>Tanzania</a:t>
+            </a:r>
+            <a:endParaRPr lang="en-US" sz="1100" dirty="0"/>
+          </a:p>
+        </p:txBody>
+      </p:sp>
+      <p:sp>
+        <p:nvSpPr>
+          <p:cNvPr id="37" name="Text 34"/>
+          <p:cNvSpPr/>
+          <p:nvPr/>
+        </p:nvSpPr>
+        <p:spPr>
+          <a:xfrm>
+            <a:off x="7955280" y="4261104"/>
+            <a:ext cx="1234440" cy="292608"/>
+          </a:xfrm>
+          <a:prstGeom prst="rect">
+            <a:avLst/>
+          </a:prstGeom>
+          <a:noFill/>
+          <a:ln/>
+        </p:spPr>
+        <p:txBody>
+          <a:bodyPr wrap="square" rtlCol="0" anchor="ctr"/>
+          <a:lstStyle/>
+          <a:p>
+            <a:pPr algn="ctr" indent="0" marL="0">
+              <a:buNone/>
+            </a:pPr>
+            <a:r>
+              <a:rPr lang="en-US" sz="1100" b="1" dirty="0">
+                <a:solidFill>
+                  <a:srgbClr val="5D300F"/>
+                </a:solidFill>
+                <a:latin typeface="Century Gothic" pitchFamily="34" charset="0"/>
+                <a:ea typeface="Century Gothic" pitchFamily="34" charset="-122"/>
+                <a:cs typeface="Century Gothic" pitchFamily="34" charset="-120"/>
+              </a:rPr>
+              <a:t>139</a:t>
+            </a:r>
+            <a:endParaRPr lang="en-US" sz="1100" dirty="0"/>
+          </a:p>
+        </p:txBody>
+      </p:sp>
+      <p:sp>
+        <p:nvSpPr>
+          <p:cNvPr id="38" name="Shape 35"/>
+          <p:cNvSpPr/>
+          <p:nvPr/>
+        </p:nvSpPr>
+        <p:spPr>
+          <a:xfrm>
+            <a:off x="9308592" y="4023360"/>
+            <a:ext cx="1234440" cy="530352"/>
+          </a:xfrm>
+          <a:prstGeom prst="rect">
+            <a:avLst/>
+          </a:prstGeom>
+          <a:solidFill>
+            <a:srgbClr val="FFF9D9"/>
+          </a:solidFill>
+          <a:ln w="12700">
+            <a:solidFill>
+              <a:srgbClr val="D6CFC4"/>
+            </a:solidFill>
+            <a:prstDash val="solid"/>
+          </a:ln>
+        </p:spPr>
+      </p:sp>
+      <p:sp>
+        <p:nvSpPr>
+          <p:cNvPr id="39" name="Text 36"/>
+          <p:cNvSpPr/>
+          <p:nvPr/>
+        </p:nvSpPr>
+        <p:spPr>
+          <a:xfrm>
+            <a:off x="9308592" y="4023360"/>
+            <a:ext cx="1234440" cy="237744"/>
+          </a:xfrm>
+          <a:prstGeom prst="rect">
+            <a:avLst/>
+          </a:prstGeom>
+          <a:noFill/>
+          <a:ln/>
+        </p:spPr>
+        <p:txBody>
+          <a:bodyPr wrap="square" rtlCol="0" anchor="b"/>
+          <a:lstStyle/>
+          <a:p>
+            <a:pPr algn="ctr" indent="0" marL="0">
+              <a:buNone/>
+            </a:pPr>
+            <a:r>
+              <a:rPr lang="en-US" sz="1100" dirty="0">
+                <a:solidFill>
+                  <a:srgbClr val="718096"/>
+                </a:solidFill>
+                <a:latin typeface="Calibri" pitchFamily="34" charset="0"/>
+                <a:ea typeface="Calibri" pitchFamily="34" charset="-122"/>
+                <a:cs typeface="Calibri" pitchFamily="34" charset="-120"/>
+              </a:rPr>
+              <a:t>Kenya</a:t>
+            </a:r>
+            <a:endParaRPr lang="en-US" sz="1100" dirty="0"/>
+          </a:p>
+        </p:txBody>
+      </p:sp>
+      <p:sp>
+        <p:nvSpPr>
+          <p:cNvPr id="40" name="Text 37"/>
+          <p:cNvSpPr/>
+          <p:nvPr/>
+        </p:nvSpPr>
+        <p:spPr>
+          <a:xfrm>
+            <a:off x="9308592" y="4261104"/>
+            <a:ext cx="1234440" cy="292608"/>
+          </a:xfrm>
+          <a:prstGeom prst="rect">
+            <a:avLst/>
+          </a:prstGeom>
+          <a:noFill/>
+          <a:ln/>
+        </p:spPr>
+        <p:txBody>
+          <a:bodyPr wrap="square" rtlCol="0" anchor="ctr"/>
+          <a:lstStyle/>
+          <a:p>
+            <a:pPr algn="ctr" indent="0" marL="0">
+              <a:buNone/>
+            </a:pPr>
+            <a:r>
+              <a:rPr lang="en-US" sz="1100" b="1" dirty="0">
+                <a:solidFill>
+                  <a:srgbClr val="5D300F"/>
+                </a:solidFill>
+                <a:latin typeface="Century Gothic" pitchFamily="34" charset="0"/>
+                <a:ea typeface="Century Gothic" pitchFamily="34" charset="-122"/>
+                <a:cs typeface="Century Gothic" pitchFamily="34" charset="-120"/>
+              </a:rPr>
+              <a:t>100</a:t>
+            </a:r>
+            <a:endParaRPr lang="en-US" sz="1100" dirty="0"/>
+          </a:p>
+        </p:txBody>
+      </p:sp>
+      <p:sp>
+        <p:nvSpPr>
+          <p:cNvPr id="41" name="Shape 38"/>
+          <p:cNvSpPr/>
+          <p:nvPr/>
+        </p:nvSpPr>
+        <p:spPr>
+          <a:xfrm>
+            <a:off x="10661904" y="4023360"/>
+            <a:ext cx="1234440" cy="530352"/>
+          </a:xfrm>
+          <a:prstGeom prst="rect">
+            <a:avLst/>
+          </a:prstGeom>
+          <a:solidFill>
+            <a:srgbClr val="FFF9D9"/>
+          </a:solidFill>
+          <a:ln w="12700">
+            <a:solidFill>
+              <a:srgbClr val="D6CFC4"/>
+            </a:solidFill>
+            <a:prstDash val="solid"/>
+          </a:ln>
+        </p:spPr>
+      </p:sp>
+      <p:sp>
+        <p:nvSpPr>
+          <p:cNvPr id="42" name="Text 39"/>
+          <p:cNvSpPr/>
+          <p:nvPr/>
+        </p:nvSpPr>
+        <p:spPr>
+          <a:xfrm>
+            <a:off x="10661904" y="4023360"/>
+            <a:ext cx="1234440" cy="237744"/>
+          </a:xfrm>
+          <a:prstGeom prst="rect">
+            <a:avLst/>
+          </a:prstGeom>
+          <a:noFill/>
+          <a:ln/>
+        </p:spPr>
+        <p:txBody>
+          <a:bodyPr wrap="square" rtlCol="0" anchor="b"/>
+          <a:lstStyle/>
+          <a:p>
+            <a:pPr algn="ctr" indent="0" marL="0">
+              <a:buNone/>
+            </a:pPr>
+            <a:r>
+              <a:rPr lang="en-US" sz="1100" dirty="0">
+                <a:solidFill>
+                  <a:srgbClr val="718096"/>
+                </a:solidFill>
+                <a:latin typeface="Calibri" pitchFamily="34" charset="0"/>
+                <a:ea typeface="Calibri" pitchFamily="34" charset="-122"/>
+                <a:cs typeface="Calibri" pitchFamily="34" charset="-120"/>
+              </a:rPr>
+              <a:t>Sierra Leone</a:t>
+            </a:r>
+            <a:endParaRPr lang="en-US" sz="1100" dirty="0"/>
+          </a:p>
+        </p:txBody>
+      </p:sp>
+      <p:sp>
+        <p:nvSpPr>
+          <p:cNvPr id="43" name="Text 40"/>
+          <p:cNvSpPr/>
+          <p:nvPr/>
+        </p:nvSpPr>
+        <p:spPr>
+          <a:xfrm>
+            <a:off x="10661904" y="4261104"/>
+            <a:ext cx="1234440" cy="292608"/>
+          </a:xfrm>
+          <a:prstGeom prst="rect">
+            <a:avLst/>
+          </a:prstGeom>
+          <a:noFill/>
+          <a:ln/>
+        </p:spPr>
+        <p:txBody>
+          <a:bodyPr wrap="square" rtlCol="0" anchor="ctr"/>
+          <a:lstStyle/>
+          <a:p>
+            <a:pPr algn="ctr" indent="0" marL="0">
+              <a:buNone/>
+            </a:pPr>
+            <a:r>
+              <a:rPr lang="en-US" sz="1100" b="1" dirty="0">
+                <a:solidFill>
+                  <a:srgbClr val="5D300F"/>
+                </a:solidFill>
+                <a:latin typeface="Century Gothic" pitchFamily="34" charset="0"/>
+                <a:ea typeface="Century Gothic" pitchFamily="34" charset="-122"/>
+                <a:cs typeface="Century Gothic" pitchFamily="34" charset="-120"/>
+              </a:rPr>
+              <a:t>33</a:t>
+            </a:r>
+            <a:endParaRPr lang="en-US" sz="1100" dirty="0"/>
+          </a:p>
+        </p:txBody>
+      </p:sp>
+      <p:sp>
+        <p:nvSpPr>
+          <p:cNvPr id="44" name="Shape 41"/>
+          <p:cNvSpPr/>
+          <p:nvPr/>
+        </p:nvSpPr>
+        <p:spPr>
+          <a:xfrm>
+            <a:off x="7955280" y="4617720"/>
+            <a:ext cx="1234440" cy="530352"/>
+          </a:xfrm>
+          <a:prstGeom prst="rect">
+            <a:avLst/>
+          </a:prstGeom>
+          <a:solidFill>
+            <a:srgbClr val="FFF9D9"/>
+          </a:solidFill>
+          <a:ln w="12700">
+            <a:solidFill>
+              <a:srgbClr val="D6CFC4"/>
+            </a:solidFill>
+            <a:prstDash val="solid"/>
+          </a:ln>
+        </p:spPr>
+      </p:sp>
+      <p:sp>
+        <p:nvSpPr>
+          <p:cNvPr id="45" name="Text 42"/>
+          <p:cNvSpPr/>
+          <p:nvPr/>
+        </p:nvSpPr>
+        <p:spPr>
+          <a:xfrm>
+            <a:off x="7955280" y="4617720"/>
+            <a:ext cx="1234440" cy="237744"/>
+          </a:xfrm>
+          <a:prstGeom prst="rect">
+            <a:avLst/>
+          </a:prstGeom>
+          <a:noFill/>
+          <a:ln/>
+        </p:spPr>
+        <p:txBody>
+          <a:bodyPr wrap="square" rtlCol="0" anchor="b"/>
+          <a:lstStyle/>
+          <a:p>
+            <a:pPr algn="ctr" indent="0" marL="0">
+              <a:buNone/>
+            </a:pPr>
+            <a:r>
+              <a:rPr lang="en-US" sz="1100" dirty="0">
+                <a:solidFill>
+                  <a:srgbClr val="718096"/>
+                </a:solidFill>
+                <a:latin typeface="Calibri" pitchFamily="34" charset="0"/>
+                <a:ea typeface="Calibri" pitchFamily="34" charset="-122"/>
+                <a:cs typeface="Calibri" pitchFamily="34" charset="-120"/>
+              </a:rPr>
               <a:t>Uganda</a:t>
             </a:r>
             <a:endParaRPr lang="en-US" sz="1100" dirty="0"/>
@@ -15276,13 +15585,13 @@
       </p:sp>
       <p:sp>
         <p:nvSpPr>
-          <p:cNvPr id="37" name="Text 34"/>
-          <p:cNvSpPr/>
-          <p:nvPr/>
-        </p:nvSpPr>
-        <p:spPr>
-          <a:xfrm>
-            <a:off x="7955280" y="4261104"/>
+          <p:cNvPr id="46" name="Text 43"/>
+          <p:cNvSpPr/>
+          <p:nvPr/>
+        </p:nvSpPr>
+        <p:spPr>
+          <a:xfrm>
+            <a:off x="7955280" y="4855464"/>
             <a:ext cx="1234440" cy="292608"/>
           </a:xfrm>
           <a:prstGeom prst="rect">
@@ -15315,315 +15624,6 @@
       </p:sp>
       <p:sp>
         <p:nvSpPr>
-          <p:cNvPr id="38" name="Shape 35"/>
-          <p:cNvSpPr/>
-          <p:nvPr/>
-        </p:nvSpPr>
-        <p:spPr>
-          <a:xfrm>
-            <a:off x="9308592" y="4023360"/>
-            <a:ext cx="1234440" cy="530352"/>
-          </a:xfrm>
-          <a:prstGeom prst="rect">
-            <a:avLst/>
-          </a:prstGeom>
-          <a:solidFill>
-            <a:srgbClr val="FFF9D9"/>
-          </a:solidFill>
-          <a:ln w="12700">
-            <a:solidFill>
-              <a:srgbClr val="D6CFC4"/>
-            </a:solidFill>
-            <a:prstDash val="solid"/>
-          </a:ln>
-        </p:spPr>
-      </p:sp>
-      <p:sp>
-        <p:nvSpPr>
-          <p:cNvPr id="39" name="Text 36"/>
-          <p:cNvSpPr/>
-          <p:nvPr/>
-        </p:nvSpPr>
-        <p:spPr>
-          <a:xfrm>
-            <a:off x="9308592" y="4023360"/>
-            <a:ext cx="1234440" cy="237744"/>
-          </a:xfrm>
-          <a:prstGeom prst="rect">
-            <a:avLst/>
-          </a:prstGeom>
-          <a:noFill/>
-          <a:ln/>
-        </p:spPr>
-        <p:txBody>
-          <a:bodyPr wrap="square" rtlCol="0" anchor="b"/>
-          <a:lstStyle/>
-          <a:p>
-            <a:pPr algn="ctr" indent="0" marL="0">
-              <a:buNone/>
-            </a:pPr>
-            <a:r>
-              <a:rPr lang="en-US" sz="1100" dirty="0">
-                <a:solidFill>
-                  <a:srgbClr val="718096"/>
-                </a:solidFill>
-                <a:latin typeface="Calibri" pitchFamily="34" charset="0"/>
-                <a:ea typeface="Calibri" pitchFamily="34" charset="-122"/>
-                <a:cs typeface="Calibri" pitchFamily="34" charset="-120"/>
-              </a:rPr>
-              <a:t>Tanzania</a:t>
-            </a:r>
-            <a:endParaRPr lang="en-US" sz="1100" dirty="0"/>
-          </a:p>
-        </p:txBody>
-      </p:sp>
-      <p:sp>
-        <p:nvSpPr>
-          <p:cNvPr id="40" name="Text 37"/>
-          <p:cNvSpPr/>
-          <p:nvPr/>
-        </p:nvSpPr>
-        <p:spPr>
-          <a:xfrm>
-            <a:off x="9308592" y="4261104"/>
-            <a:ext cx="1234440" cy="292608"/>
-          </a:xfrm>
-          <a:prstGeom prst="rect">
-            <a:avLst/>
-          </a:prstGeom>
-          <a:noFill/>
-          <a:ln/>
-        </p:spPr>
-        <p:txBody>
-          <a:bodyPr wrap="square" rtlCol="0" anchor="ctr"/>
-          <a:lstStyle/>
-          <a:p>
-            <a:pPr algn="ctr" indent="0" marL="0">
-              <a:buNone/>
-            </a:pPr>
-            <a:r>
-              <a:rPr lang="en-US" sz="1100" b="1" dirty="0">
-                <a:solidFill>
-                  <a:srgbClr val="5D300F"/>
-                </a:solidFill>
-                <a:latin typeface="Century Gothic" pitchFamily="34" charset="0"/>
-                <a:ea typeface="Century Gothic" pitchFamily="34" charset="-122"/>
-                <a:cs typeface="Century Gothic" pitchFamily="34" charset="-120"/>
-              </a:rPr>
-              <a:t>139</a:t>
-            </a:r>
-            <a:endParaRPr lang="en-US" sz="1100" dirty="0"/>
-          </a:p>
-        </p:txBody>
-      </p:sp>
-      <p:sp>
-        <p:nvSpPr>
-          <p:cNvPr id="41" name="Shape 38"/>
-          <p:cNvSpPr/>
-          <p:nvPr/>
-        </p:nvSpPr>
-        <p:spPr>
-          <a:xfrm>
-            <a:off x="10661904" y="4023360"/>
-            <a:ext cx="1234440" cy="530352"/>
-          </a:xfrm>
-          <a:prstGeom prst="rect">
-            <a:avLst/>
-          </a:prstGeom>
-          <a:solidFill>
-            <a:srgbClr val="FFF9D9"/>
-          </a:solidFill>
-          <a:ln w="12700">
-            <a:solidFill>
-              <a:srgbClr val="D6CFC4"/>
-            </a:solidFill>
-            <a:prstDash val="solid"/>
-          </a:ln>
-        </p:spPr>
-      </p:sp>
-      <p:sp>
-        <p:nvSpPr>
-          <p:cNvPr id="42" name="Text 39"/>
-          <p:cNvSpPr/>
-          <p:nvPr/>
-        </p:nvSpPr>
-        <p:spPr>
-          <a:xfrm>
-            <a:off x="10661904" y="4023360"/>
-            <a:ext cx="1234440" cy="237744"/>
-          </a:xfrm>
-          <a:prstGeom prst="rect">
-            <a:avLst/>
-          </a:prstGeom>
-          <a:noFill/>
-          <a:ln/>
-        </p:spPr>
-        <p:txBody>
-          <a:bodyPr wrap="square" rtlCol="0" anchor="b"/>
-          <a:lstStyle/>
-          <a:p>
-            <a:pPr algn="ctr" indent="0" marL="0">
-              <a:buNone/>
-            </a:pPr>
-            <a:r>
-              <a:rPr lang="en-US" sz="1100" dirty="0">
-                <a:solidFill>
-                  <a:srgbClr val="718096"/>
-                </a:solidFill>
-                <a:latin typeface="Calibri" pitchFamily="34" charset="0"/>
-                <a:ea typeface="Calibri" pitchFamily="34" charset="-122"/>
-                <a:cs typeface="Calibri" pitchFamily="34" charset="-120"/>
-              </a:rPr>
-              <a:t>Kenya</a:t>
-            </a:r>
-            <a:endParaRPr lang="en-US" sz="1100" dirty="0"/>
-          </a:p>
-        </p:txBody>
-      </p:sp>
-      <p:sp>
-        <p:nvSpPr>
-          <p:cNvPr id="43" name="Text 40"/>
-          <p:cNvSpPr/>
-          <p:nvPr/>
-        </p:nvSpPr>
-        <p:spPr>
-          <a:xfrm>
-            <a:off x="10661904" y="4261104"/>
-            <a:ext cx="1234440" cy="292608"/>
-          </a:xfrm>
-          <a:prstGeom prst="rect">
-            <a:avLst/>
-          </a:prstGeom>
-          <a:noFill/>
-          <a:ln/>
-        </p:spPr>
-        <p:txBody>
-          <a:bodyPr wrap="square" rtlCol="0" anchor="ctr"/>
-          <a:lstStyle/>
-          <a:p>
-            <a:pPr algn="ctr" indent="0" marL="0">
-              <a:buNone/>
-            </a:pPr>
-            <a:r>
-              <a:rPr lang="en-US" sz="1100" b="1" dirty="0">
-                <a:solidFill>
-                  <a:srgbClr val="5D300F"/>
-                </a:solidFill>
-                <a:latin typeface="Century Gothic" pitchFamily="34" charset="0"/>
-                <a:ea typeface="Century Gothic" pitchFamily="34" charset="-122"/>
-                <a:cs typeface="Century Gothic" pitchFamily="34" charset="-120"/>
-              </a:rPr>
-              <a:t>100</a:t>
-            </a:r>
-            <a:endParaRPr lang="en-US" sz="1100" dirty="0"/>
-          </a:p>
-        </p:txBody>
-      </p:sp>
-      <p:sp>
-        <p:nvSpPr>
-          <p:cNvPr id="44" name="Shape 41"/>
-          <p:cNvSpPr/>
-          <p:nvPr/>
-        </p:nvSpPr>
-        <p:spPr>
-          <a:xfrm>
-            <a:off x="7955280" y="4617720"/>
-            <a:ext cx="1234440" cy="530352"/>
-          </a:xfrm>
-          <a:prstGeom prst="rect">
-            <a:avLst/>
-          </a:prstGeom>
-          <a:solidFill>
-            <a:srgbClr val="FFF9D9"/>
-          </a:solidFill>
-          <a:ln w="12700">
-            <a:solidFill>
-              <a:srgbClr val="D6CFC4"/>
-            </a:solidFill>
-            <a:prstDash val="solid"/>
-          </a:ln>
-        </p:spPr>
-      </p:sp>
-      <p:sp>
-        <p:nvSpPr>
-          <p:cNvPr id="45" name="Text 42"/>
-          <p:cNvSpPr/>
-          <p:nvPr/>
-        </p:nvSpPr>
-        <p:spPr>
-          <a:xfrm>
-            <a:off x="7955280" y="4617720"/>
-            <a:ext cx="1234440" cy="237744"/>
-          </a:xfrm>
-          <a:prstGeom prst="rect">
-            <a:avLst/>
-          </a:prstGeom>
-          <a:noFill/>
-          <a:ln/>
-        </p:spPr>
-        <p:txBody>
-          <a:bodyPr wrap="square" rtlCol="0" anchor="b"/>
-          <a:lstStyle/>
-          <a:p>
-            <a:pPr algn="ctr" indent="0" marL="0">
-              <a:buNone/>
-            </a:pPr>
-            <a:r>
-              <a:rPr lang="en-US" sz="1100" dirty="0">
-                <a:solidFill>
-                  <a:srgbClr val="718096"/>
-                </a:solidFill>
-                <a:latin typeface="Calibri" pitchFamily="34" charset="0"/>
-                <a:ea typeface="Calibri" pitchFamily="34" charset="-122"/>
-                <a:cs typeface="Calibri" pitchFamily="34" charset="-120"/>
-              </a:rPr>
-              <a:t>Sierra Leone</a:t>
-            </a:r>
-            <a:endParaRPr lang="en-US" sz="1100" dirty="0"/>
-          </a:p>
-        </p:txBody>
-      </p:sp>
-      <p:sp>
-        <p:nvSpPr>
-          <p:cNvPr id="46" name="Text 43"/>
-          <p:cNvSpPr/>
-          <p:nvPr/>
-        </p:nvSpPr>
-        <p:spPr>
-          <a:xfrm>
-            <a:off x="7955280" y="4855464"/>
-            <a:ext cx="1234440" cy="292608"/>
-          </a:xfrm>
-          <a:prstGeom prst="rect">
-            <a:avLst/>
-          </a:prstGeom>
-          <a:noFill/>
-          <a:ln/>
-        </p:spPr>
-        <p:txBody>
-          <a:bodyPr wrap="square" rtlCol="0" anchor="ctr"/>
-          <a:lstStyle/>
-          <a:p>
-            <a:pPr algn="ctr" indent="0" marL="0">
-              <a:buNone/>
-            </a:pPr>
-            <a:r>
-              <a:rPr lang="en-US" sz="1100" b="1" dirty="0">
-                <a:solidFill>
-                  <a:srgbClr val="5D300F"/>
-                </a:solidFill>
-                <a:latin typeface="Century Gothic" pitchFamily="34" charset="0"/>
-                <a:ea typeface="Century Gothic" pitchFamily="34" charset="-122"/>
-                <a:cs typeface="Century Gothic" pitchFamily="34" charset="-120"/>
-              </a:rPr>
-              <a:t>33</a:t>
-            </a:r>
-            <a:endParaRPr lang="en-US" sz="1100" dirty="0"/>
-          </a:p>
-        </p:txBody>
-      </p:sp>
-      <p:sp>
-        <p:nvSpPr>
           <p:cNvPr id="47" name="Shape 44"/>
           <p:cNvSpPr/>
           <p:nvPr/>
@@ -15847,7 +15847,7 @@
                 <a:ea typeface="Calibri" pitchFamily="34" charset="-122"/>
                 <a:cs typeface="Calibri" pitchFamily="34" charset="-120"/>
               </a:rPr>
-              <a:t>Total disbursed: $1,963,743,051 (+31627.6% vs prior month).</a:t>
+              <a:t>Total disbursed: $5,626,743 (-9.1% vs prior month).</a:t>
             </a:r>
             <a:endParaRPr lang="en-US" sz="1200" dirty="0"/>
           </a:p>
@@ -15864,7 +15864,7 @@
                 <a:ea typeface="Calibri" pitchFamily="34" charset="-122"/>
                 <a:cs typeface="Calibri" pitchFamily="34" charset="-120"/>
               </a:rPr>
-              <a:t>Uganda had the highest disbursements ($1,958,650,000).</a:t>
+              <a:t>Tanzania had the highest disbursements ($2,578,767).</a:t>
             </a:r>
             <a:endParaRPr lang="en-US" sz="1200" dirty="0"/>
           </a:p>
@@ -16419,45 +16419,6 @@
                 <a:ea typeface="Calibri" pitchFamily="34" charset="-122"/>
                 <a:cs typeface="Calibri" pitchFamily="34" charset="-120"/>
               </a:rPr>
-              <a:t>+386635.3%</a:t>
-            </a:r>
-            <a:endParaRPr lang="en-US" sz="1200" dirty="0"/>
-          </a:p>
-        </p:txBody>
-      </p:sp>
-      <p:sp>
-        <p:nvSpPr>
-          <p:cNvPr id="20" name="Text 16"/>
-          <p:cNvSpPr/>
-          <p:nvPr/>
-        </p:nvSpPr>
-        <p:spPr>
-          <a:xfrm>
-            <a:off x="1298448" y="5925312"/>
-            <a:ext cx="1161288" cy="347472"/>
-          </a:xfrm>
-          <a:prstGeom prst="rect">
-            <a:avLst/>
-          </a:prstGeom>
-          <a:noFill/>
-          <a:ln/>
-        </p:spPr>
-        <p:txBody>
-          <a:bodyPr wrap="square" rtlCol="0" anchor="ctr"/>
-          <a:lstStyle/>
-          <a:p>
-            <a:pPr algn="ctr" indent="0" marL="0">
-              <a:buNone/>
-            </a:pPr>
-            <a:r>
-              <a:rPr lang="en-US" sz="1200" b="1" dirty="0">
-                <a:solidFill>
-                  <a:srgbClr val="1A7A6E"/>
-                </a:solidFill>
-                <a:latin typeface="Calibri" pitchFamily="34" charset="0"/>
-                <a:ea typeface="Calibri" pitchFamily="34" charset="-122"/>
-                <a:cs typeface="Calibri" pitchFamily="34" charset="-120"/>
-              </a:rPr>
               <a:t>+0.8%</a:t>
             </a:r>
             <a:endParaRPr lang="en-US" sz="1200" dirty="0"/>
@@ -16466,13 +16427,13 @@
       </p:sp>
       <p:sp>
         <p:nvSpPr>
-          <p:cNvPr id="21" name="Text 17"/>
-          <p:cNvSpPr/>
-          <p:nvPr/>
-        </p:nvSpPr>
-        <p:spPr>
-          <a:xfrm>
-            <a:off x="2459736" y="5925312"/>
+          <p:cNvPr id="20" name="Text 16"/>
+          <p:cNvSpPr/>
+          <p:nvPr/>
+        </p:nvSpPr>
+        <p:spPr>
+          <a:xfrm>
+            <a:off x="1298448" y="5925312"/>
             <a:ext cx="1161288" cy="347472"/>
           </a:xfrm>
           <a:prstGeom prst="rect">
@@ -16505,13 +16466,13 @@
       </p:sp>
       <p:sp>
         <p:nvSpPr>
-          <p:cNvPr id="22" name="Text 18"/>
-          <p:cNvSpPr/>
-          <p:nvPr/>
-        </p:nvSpPr>
-        <p:spPr>
-          <a:xfrm>
-            <a:off x="3621024" y="5925312"/>
+          <p:cNvPr id="21" name="Text 17"/>
+          <p:cNvSpPr/>
+          <p:nvPr/>
+        </p:nvSpPr>
+        <p:spPr>
+          <a:xfrm>
+            <a:off x="2459736" y="5925312"/>
             <a:ext cx="1161288" cy="347472"/>
           </a:xfrm>
           <a:prstGeom prst="rect">
@@ -16544,6 +16505,45 @@
       </p:sp>
       <p:sp>
         <p:nvSpPr>
+          <p:cNvPr id="22" name="Text 18"/>
+          <p:cNvSpPr/>
+          <p:nvPr/>
+        </p:nvSpPr>
+        <p:spPr>
+          <a:xfrm>
+            <a:off x="3621024" y="5925312"/>
+            <a:ext cx="1161288" cy="347472"/>
+          </a:xfrm>
+          <a:prstGeom prst="rect">
+            <a:avLst/>
+          </a:prstGeom>
+          <a:noFill/>
+          <a:ln/>
+        </p:spPr>
+        <p:txBody>
+          <a:bodyPr wrap="square" rtlCol="0" anchor="ctr"/>
+          <a:lstStyle/>
+          <a:p>
+            <a:pPr algn="ctr" indent="0" marL="0">
+              <a:buNone/>
+            </a:pPr>
+            <a:r>
+              <a:rPr lang="en-US" sz="1200" b="1" dirty="0">
+                <a:solidFill>
+                  <a:srgbClr val="1A7A6E"/>
+                </a:solidFill>
+                <a:latin typeface="Calibri" pitchFamily="34" charset="0"/>
+                <a:ea typeface="Calibri" pitchFamily="34" charset="-122"/>
+                <a:cs typeface="Calibri" pitchFamily="34" charset="-120"/>
+              </a:rPr>
+              <a:t>+5.4%</a:t>
+            </a:r>
+            <a:endParaRPr lang="en-US" sz="1200" dirty="0"/>
+          </a:p>
+        </p:txBody>
+      </p:sp>
+      <p:sp>
+        <p:nvSpPr>
           <p:cNvPr id="23" name="Text 19"/>
           <p:cNvSpPr/>
           <p:nvPr/>
@@ -16703,45 +16703,6 @@
                 <a:ea typeface="Calibri" pitchFamily="34" charset="-122"/>
                 <a:cs typeface="Calibri" pitchFamily="34" charset="-120"/>
               </a:rPr>
-              <a:t>-18.1%</a:t>
-            </a:r>
-            <a:endParaRPr lang="en-US" sz="1200" dirty="0"/>
-          </a:p>
-        </p:txBody>
-      </p:sp>
-      <p:sp>
-        <p:nvSpPr>
-          <p:cNvPr id="28" name="Text 24"/>
-          <p:cNvSpPr/>
-          <p:nvPr/>
-        </p:nvSpPr>
-        <p:spPr>
-          <a:xfrm>
-            <a:off x="7333488" y="5925312"/>
-            <a:ext cx="1161288" cy="347472"/>
-          </a:xfrm>
-          <a:prstGeom prst="rect">
-            <a:avLst/>
-          </a:prstGeom>
-          <a:noFill/>
-          <a:ln/>
-        </p:spPr>
-        <p:txBody>
-          <a:bodyPr wrap="square" rtlCol="0" anchor="ctr"/>
-          <a:lstStyle/>
-          <a:p>
-            <a:pPr algn="ctr" indent="0" marL="0">
-              <a:buNone/>
-            </a:pPr>
-            <a:r>
-              <a:rPr lang="en-US" sz="1200" b="1" dirty="0">
-                <a:solidFill>
-                  <a:srgbClr val="C0392B"/>
-                </a:solidFill>
-                <a:latin typeface="Calibri" pitchFamily="34" charset="0"/>
-                <a:ea typeface="Calibri" pitchFamily="34" charset="-122"/>
-                <a:cs typeface="Calibri" pitchFamily="34" charset="-120"/>
-              </a:rPr>
               <a:t>-11.9%</a:t>
             </a:r>
             <a:endParaRPr lang="en-US" sz="1200" dirty="0"/>
@@ -16750,13 +16711,13 @@
       </p:sp>
       <p:sp>
         <p:nvSpPr>
-          <p:cNvPr id="29" name="Text 25"/>
-          <p:cNvSpPr/>
-          <p:nvPr/>
-        </p:nvSpPr>
-        <p:spPr>
-          <a:xfrm>
-            <a:off x="8494776" y="5925312"/>
+          <p:cNvPr id="28" name="Text 24"/>
+          <p:cNvSpPr/>
+          <p:nvPr/>
+        </p:nvSpPr>
+        <p:spPr>
+          <a:xfrm>
+            <a:off x="7333488" y="5925312"/>
             <a:ext cx="1161288" cy="347472"/>
           </a:xfrm>
           <a:prstGeom prst="rect">
@@ -16789,13 +16750,13 @@
       </p:sp>
       <p:sp>
         <p:nvSpPr>
-          <p:cNvPr id="30" name="Text 26"/>
-          <p:cNvSpPr/>
-          <p:nvPr/>
-        </p:nvSpPr>
-        <p:spPr>
-          <a:xfrm>
-            <a:off x="9656064" y="5925312"/>
+          <p:cNvPr id="29" name="Text 25"/>
+          <p:cNvSpPr/>
+          <p:nvPr/>
+        </p:nvSpPr>
+        <p:spPr>
+          <a:xfrm>
+            <a:off x="8494776" y="5925312"/>
             <a:ext cx="1161288" cy="347472"/>
           </a:xfrm>
           <a:prstGeom prst="rect">
@@ -16821,6 +16782,45 @@
                 <a:cs typeface="Calibri" pitchFamily="34" charset="-120"/>
               </a:rPr>
               <a:t>+0.0%</a:t>
+            </a:r>
+            <a:endParaRPr lang="en-US" sz="1200" dirty="0"/>
+          </a:p>
+        </p:txBody>
+      </p:sp>
+      <p:sp>
+        <p:nvSpPr>
+          <p:cNvPr id="30" name="Text 26"/>
+          <p:cNvSpPr/>
+          <p:nvPr/>
+        </p:nvSpPr>
+        <p:spPr>
+          <a:xfrm>
+            <a:off x="9656064" y="5925312"/>
+            <a:ext cx="1161288" cy="347472"/>
+          </a:xfrm>
+          <a:prstGeom prst="rect">
+            <a:avLst/>
+          </a:prstGeom>
+          <a:noFill/>
+          <a:ln/>
+        </p:spPr>
+        <p:txBody>
+          <a:bodyPr wrap="square" rtlCol="0" anchor="ctr"/>
+          <a:lstStyle/>
+          <a:p>
+            <a:pPr algn="ctr" indent="0" marL="0">
+              <a:buNone/>
+            </a:pPr>
+            <a:r>
+              <a:rPr lang="en-US" sz="1200" b="1" dirty="0">
+                <a:solidFill>
+                  <a:srgbClr val="C0392B"/>
+                </a:solidFill>
+                <a:latin typeface="Calibri" pitchFamily="34" charset="0"/>
+                <a:ea typeface="Calibri" pitchFamily="34" charset="-122"/>
+                <a:cs typeface="Calibri" pitchFamily="34" charset="-120"/>
+              </a:rPr>
+              <a:t>-18.1%</a:t>
             </a:r>
             <a:endParaRPr lang="en-US" sz="1200" dirty="0"/>
           </a:p>
@@ -18324,45 +18324,6 @@
             <a:r>
               <a:rPr lang="en-US" sz="1200" b="1" dirty="0">
                 <a:solidFill>
-                  <a:srgbClr val="1A7A6E"/>
-                </a:solidFill>
-                <a:latin typeface="Calibri" pitchFamily="34" charset="0"/>
-                <a:ea typeface="Calibri" pitchFamily="34" charset="-122"/>
-                <a:cs typeface="Calibri" pitchFamily="34" charset="-120"/>
-              </a:rPr>
-              <a:t>+387968.7%</a:t>
-            </a:r>
-            <a:endParaRPr lang="en-US" sz="1200" dirty="0"/>
-          </a:p>
-        </p:txBody>
-      </p:sp>
-      <p:sp>
-        <p:nvSpPr>
-          <p:cNvPr id="16" name="Text 13"/>
-          <p:cNvSpPr/>
-          <p:nvPr/>
-        </p:nvSpPr>
-        <p:spPr>
-          <a:xfrm>
-            <a:off x="1655064" y="5925312"/>
-            <a:ext cx="1517904" cy="347472"/>
-          </a:xfrm>
-          <a:prstGeom prst="rect">
-            <a:avLst/>
-          </a:prstGeom>
-          <a:noFill/>
-          <a:ln/>
-        </p:spPr>
-        <p:txBody>
-          <a:bodyPr wrap="square" rtlCol="0" anchor="ctr"/>
-          <a:lstStyle/>
-          <a:p>
-            <a:pPr algn="ctr" indent="0" marL="0">
-              <a:buNone/>
-            </a:pPr>
-            <a:r>
-              <a:rPr lang="en-US" sz="1200" b="1" dirty="0">
-                <a:solidFill>
                   <a:srgbClr val="C0392B"/>
                 </a:solidFill>
                 <a:latin typeface="Calibri" pitchFamily="34" charset="0"/>
@@ -18377,13 +18338,13 @@
       </p:sp>
       <p:sp>
         <p:nvSpPr>
-          <p:cNvPr id="17" name="Text 14"/>
-          <p:cNvSpPr/>
-          <p:nvPr/>
-        </p:nvSpPr>
-        <p:spPr>
-          <a:xfrm>
-            <a:off x="3172968" y="5925312"/>
+          <p:cNvPr id="16" name="Text 13"/>
+          <p:cNvSpPr/>
+          <p:nvPr/>
+        </p:nvSpPr>
+        <p:spPr>
+          <a:xfrm>
+            <a:off x="1655064" y="5925312"/>
             <a:ext cx="1517904" cy="347472"/>
           </a:xfrm>
           <a:prstGeom prst="rect">
@@ -18409,6 +18370,45 @@
                 <a:cs typeface="Calibri" pitchFamily="34" charset="-120"/>
               </a:rPr>
               <a:t>-3.9%</a:t>
+            </a:r>
+            <a:endParaRPr lang="en-US" sz="1200" dirty="0"/>
+          </a:p>
+        </p:txBody>
+      </p:sp>
+      <p:sp>
+        <p:nvSpPr>
+          <p:cNvPr id="17" name="Text 14"/>
+          <p:cNvSpPr/>
+          <p:nvPr/>
+        </p:nvSpPr>
+        <p:spPr>
+          <a:xfrm>
+            <a:off x="3172968" y="5925312"/>
+            <a:ext cx="1517904" cy="347472"/>
+          </a:xfrm>
+          <a:prstGeom prst="rect">
+            <a:avLst/>
+          </a:prstGeom>
+          <a:noFill/>
+          <a:ln/>
+        </p:spPr>
+        <p:txBody>
+          <a:bodyPr wrap="square" rtlCol="0" anchor="ctr"/>
+          <a:lstStyle/>
+          <a:p>
+            <a:pPr algn="ctr" indent="0" marL="0">
+              <a:buNone/>
+            </a:pPr>
+            <a:r>
+              <a:rPr lang="en-US" sz="1200" b="1" dirty="0">
+                <a:solidFill>
+                  <a:srgbClr val="1A7A6E"/>
+                </a:solidFill>
+                <a:latin typeface="Calibri" pitchFamily="34" charset="0"/>
+                <a:ea typeface="Calibri" pitchFamily="34" charset="-122"/>
+                <a:cs typeface="Calibri" pitchFamily="34" charset="-120"/>
+              </a:rPr>
+              <a:t>+5.7%</a:t>
             </a:r>
             <a:endParaRPr lang="en-US" sz="1200" dirty="0"/>
           </a:p>
@@ -18582,7 +18582,7 @@
                 <a:ea typeface="Century Gothic" pitchFamily="34" charset="-122"/>
                 <a:cs typeface="Century Gothic" pitchFamily="34" charset="-120"/>
               </a:rPr>
-              <a:t>$5,092,841,089</a:t>
+              <a:t>$13,753,334</a:t>
             </a:r>
             <a:endParaRPr lang="en-US" sz="2600" dirty="0"/>
           </a:p>
@@ -18717,7 +18717,7 @@
                 <a:ea typeface="Century Gothic" pitchFamily="34" charset="-122"/>
                 <a:cs typeface="Century Gothic" pitchFamily="34" charset="-120"/>
               </a:rPr>
-              <a:t>+36218.7%</a:t>
+              <a:t>-1.9%</a:t>
             </a:r>
             <a:endParaRPr lang="en-US" sz="2600" dirty="0"/>
           </a:p>
@@ -18884,7 +18884,7 @@
                 <a:ea typeface="Calibri" pitchFamily="34" charset="-122"/>
                 <a:cs typeface="Calibri" pitchFamily="34" charset="-120"/>
               </a:rPr>
-              <a:t>Total loan book: $5,092,841,089 (+36218.7% vs prior month).</a:t>
+              <a:t>Total loan book: $13,753,334 (-1.9% vs prior month).</a:t>
             </a:r>
             <a:endParaRPr lang="en-US" sz="1200" dirty="0"/>
           </a:p>
@@ -18901,7 +18901,7 @@
                 <a:ea typeface="Calibri" pitchFamily="34" charset="-122"/>
                 <a:cs typeface="Calibri" pitchFamily="34" charset="-120"/>
               </a:rPr>
-              <a:t>Uganda has the largest loan book ($5,080,472,080).</a:t>
+              <a:t>Tanzania has the largest loan book ($6,528,403).</a:t>
             </a:r>
             <a:endParaRPr lang="en-US" sz="1200" dirty="0"/>
           </a:p>
@@ -21039,7 +21039,7 @@
                           <a:ea typeface="Calibri" pitchFamily="34" charset="-122"/>
                           <a:cs typeface="Calibri" pitchFamily="34" charset="-120"/>
                         </a:rPr>
-                        <a:t>11.2%</a:t>
+                        <a:t>8.0%</a:t>
                       </a:r>
                       <a:endParaRPr lang="en-US" sz="1200" dirty="0">
                         <a:latin typeface="Calibri" charset="0"/>
@@ -23295,7 +23295,7 @@
                           <a:ea typeface="Calibri" pitchFamily="34" charset="-122"/>
                           <a:cs typeface="Calibri" pitchFamily="34" charset="-120"/>
                         </a:rPr>
-                        <a:t>12.2%</a:t>
+                        <a:t>8.8%</a:t>
                       </a:r>
                       <a:endParaRPr lang="en-US" sz="1200" dirty="0">
                         <a:latin typeface="Calibri" charset="0"/>

</xml_diff>